<commit_message>
feat: add tool-using LLM agent auto-tuner
</commit_message>
<xml_diff>
--- a/outputs_embedded_demo/ESP32_七算法温度闭环_零基础教学.pptx
+++ b/outputs_embedded_demo/ESP32_七算法温度闭环_零基础教学.pptx
@@ -2,32 +2,32 @@
 <file path=ppt/presentation.xml><?xml version="1.0" encoding="utf-8"?>
 <p:presentation xmlns:p="http://schemas.openxmlformats.org/presentationml/2006/main">
   <p:sldMasterIdLst>
-    <p:sldMasterId xmlns:r="http://schemas.openxmlformats.org/officeDocument/2006/relationships" id="2147483648" r:id="Rad48a877d9b0411c"/>
+    <p:sldMasterId xmlns:r="http://schemas.openxmlformats.org/officeDocument/2006/relationships" id="2147483648" r:id="R664f500a8421489c"/>
   </p:sldMasterIdLst>
   <p:notesMasterIdLst>
-    <p:notesMasterId xmlns:r="http://schemas.openxmlformats.org/officeDocument/2006/relationships" r:id="R50552bba12914457"/>
+    <p:notesMasterId xmlns:r="http://schemas.openxmlformats.org/officeDocument/2006/relationships" r:id="Rdef4f8b47ed346ef"/>
   </p:notesMasterIdLst>
   <p:sldIdLst>
-    <p:sldId xmlns:r="http://schemas.openxmlformats.org/officeDocument/2006/relationships" id="256" r:id="Rcbe25fc2d86e42a9"/>
-    <p:sldId xmlns:r="http://schemas.openxmlformats.org/officeDocument/2006/relationships" id="257" r:id="R38e11eb2dbc340e7"/>
-    <p:sldId xmlns:r="http://schemas.openxmlformats.org/officeDocument/2006/relationships" id="258" r:id="Rdb21e37c1f064987"/>
-    <p:sldId xmlns:r="http://schemas.openxmlformats.org/officeDocument/2006/relationships" id="259" r:id="R5a7e6ee9f0d841e1"/>
-    <p:sldId xmlns:r="http://schemas.openxmlformats.org/officeDocument/2006/relationships" id="260" r:id="R1b85d0ac7ec142ea"/>
-    <p:sldId xmlns:r="http://schemas.openxmlformats.org/officeDocument/2006/relationships" id="261" r:id="R3bab9365014c4f24"/>
-    <p:sldId xmlns:r="http://schemas.openxmlformats.org/officeDocument/2006/relationships" id="262" r:id="R34b4d5d07d7a4c42"/>
-    <p:sldId xmlns:r="http://schemas.openxmlformats.org/officeDocument/2006/relationships" id="263" r:id="Rcff8e672356c418e"/>
-    <p:sldId xmlns:r="http://schemas.openxmlformats.org/officeDocument/2006/relationships" id="264" r:id="R3636863341494f0e"/>
-    <p:sldId xmlns:r="http://schemas.openxmlformats.org/officeDocument/2006/relationships" id="265" r:id="R9d27cc8c168c4faa"/>
-    <p:sldId xmlns:r="http://schemas.openxmlformats.org/officeDocument/2006/relationships" id="266" r:id="R77362c125769446f"/>
-    <p:sldId xmlns:r="http://schemas.openxmlformats.org/officeDocument/2006/relationships" id="267" r:id="Rc142647eb5824489"/>
-    <p:sldId xmlns:r="http://schemas.openxmlformats.org/officeDocument/2006/relationships" id="268" r:id="R75146867cd034877"/>
-    <p:sldId xmlns:r="http://schemas.openxmlformats.org/officeDocument/2006/relationships" id="269" r:id="R4c5c72a64fe94537"/>
-    <p:sldId xmlns:r="http://schemas.openxmlformats.org/officeDocument/2006/relationships" id="270" r:id="Rcc5ce94c1b844b14"/>
-    <p:sldId xmlns:r="http://schemas.openxmlformats.org/officeDocument/2006/relationships" id="271" r:id="R24993d5a9588431e"/>
-    <p:sldId xmlns:r="http://schemas.openxmlformats.org/officeDocument/2006/relationships" id="272" r:id="R2126f9a918ae4912"/>
-    <p:sldId xmlns:r="http://schemas.openxmlformats.org/officeDocument/2006/relationships" id="273" r:id="Rf6add24f9c1742d9"/>
-    <p:sldId xmlns:r="http://schemas.openxmlformats.org/officeDocument/2006/relationships" id="274" r:id="R8ee8ee62e6fa49f8"/>
-    <p:sldId xmlns:r="http://schemas.openxmlformats.org/officeDocument/2006/relationships" id="275" r:id="Rf25ca410d91d495f"/>
+    <p:sldId xmlns:r="http://schemas.openxmlformats.org/officeDocument/2006/relationships" id="256" r:id="R81df9a1a81d5400c"/>
+    <p:sldId xmlns:r="http://schemas.openxmlformats.org/officeDocument/2006/relationships" id="257" r:id="R7ec84f2f50154076"/>
+    <p:sldId xmlns:r="http://schemas.openxmlformats.org/officeDocument/2006/relationships" id="258" r:id="R1938828d1bb941a7"/>
+    <p:sldId xmlns:r="http://schemas.openxmlformats.org/officeDocument/2006/relationships" id="259" r:id="R7e71f786ed454ff4"/>
+    <p:sldId xmlns:r="http://schemas.openxmlformats.org/officeDocument/2006/relationships" id="260" r:id="Re8a97deee086499a"/>
+    <p:sldId xmlns:r="http://schemas.openxmlformats.org/officeDocument/2006/relationships" id="261" r:id="R571b60813fe14a37"/>
+    <p:sldId xmlns:r="http://schemas.openxmlformats.org/officeDocument/2006/relationships" id="262" r:id="R30d740455f094dfa"/>
+    <p:sldId xmlns:r="http://schemas.openxmlformats.org/officeDocument/2006/relationships" id="263" r:id="R55930e4410f74115"/>
+    <p:sldId xmlns:r="http://schemas.openxmlformats.org/officeDocument/2006/relationships" id="264" r:id="R7e984eefe8d54bc5"/>
+    <p:sldId xmlns:r="http://schemas.openxmlformats.org/officeDocument/2006/relationships" id="265" r:id="Rf5bbced042c1454f"/>
+    <p:sldId xmlns:r="http://schemas.openxmlformats.org/officeDocument/2006/relationships" id="266" r:id="R7d01cadbcc844fd7"/>
+    <p:sldId xmlns:r="http://schemas.openxmlformats.org/officeDocument/2006/relationships" id="267" r:id="R167d2a15f4bd4e7c"/>
+    <p:sldId xmlns:r="http://schemas.openxmlformats.org/officeDocument/2006/relationships" id="268" r:id="R003c3d749a34453d"/>
+    <p:sldId xmlns:r="http://schemas.openxmlformats.org/officeDocument/2006/relationships" id="269" r:id="Rb0da61e0932b4285"/>
+    <p:sldId xmlns:r="http://schemas.openxmlformats.org/officeDocument/2006/relationships" id="270" r:id="Rc8c75cf8a91849fe"/>
+    <p:sldId xmlns:r="http://schemas.openxmlformats.org/officeDocument/2006/relationships" id="271" r:id="R9f5bbe35b68c47a8"/>
+    <p:sldId xmlns:r="http://schemas.openxmlformats.org/officeDocument/2006/relationships" id="272" r:id="Rc7b13b5f17be45c3"/>
+    <p:sldId xmlns:r="http://schemas.openxmlformats.org/officeDocument/2006/relationships" id="273" r:id="Rf7fd4fa6c12c4503"/>
+    <p:sldId xmlns:r="http://schemas.openxmlformats.org/officeDocument/2006/relationships" id="274" r:id="Ref3a02927cbc481b"/>
+    <p:sldId xmlns:r="http://schemas.openxmlformats.org/officeDocument/2006/relationships" id="275" r:id="R92830de0ce9f483e"/>
   </p:sldIdLst>
   <p:sldSz cx="12192000" cy="6858000"/>
   <p:notesSz cx="6858000" cy="9144000"/>
@@ -2249,7 +2249,7 @@
   </p:cSld>
   <p:clrMap bg1="lt1" tx1="dk1" bg2="lt2" tx2="dk2" accent1="accent1" accent2="accent2" accent3="accent3" accent4="accent4" accent5="accent5" accent6="accent6" hlink="hlink" folHlink="folHlink"/>
   <p:sldLayoutIdLst>
-    <p:sldLayoutId xmlns:r="http://schemas.openxmlformats.org/officeDocument/2006/relationships" id="2147483649" r:id="R7d8e2e8aea324266"/>
+    <p:sldLayoutId xmlns:r="http://schemas.openxmlformats.org/officeDocument/2006/relationships" id="2147483649" r:id="R005b2a15722b4bd0"/>
   </p:sldLayoutIdLst>
   <p:txStyles>
     <p:titleStyle>
@@ -4149,7 +4149,7 @@
           <c:idx val="6"/>
           <c:order val="6"/>
           <c:tx>
-            <c:v>LLM</c:v>
+            <c:v>LLM Agent</c:v>
           </c:tx>
           <c:spPr>
             <a:solidFill xmlns:a="http://schemas.openxmlformats.org/drawingml/2006/main">
@@ -5647,7 +5647,7 @@
           <p:cNvPr id="10" name="">
             <a:extLst xmlns:a="http://schemas.openxmlformats.org/drawingml/2006/main">
               <a:ext uri="{FF2B5EF4-FFF2-40B4-BE49-F238E27FC236}">
-                <a16:creationId xmlns:a16="http://schemas.microsoft.com/office/drawing/2014/main" id="{2B809D9F-9057-49FF-9F06-590C52939A04}"/>
+                <a16:creationId xmlns:a16="http://schemas.microsoft.com/office/drawing/2014/main" id="{7868D555-B585-4B92-AEC7-3F66936066E3}"/>
               </a:ext>
             </a:extLst>
           </p:cNvPr>
@@ -5705,7 +5705,7 @@
           <p:cNvPr id="2" name="">
             <a:extLst xmlns:a="http://schemas.openxmlformats.org/drawingml/2006/main">
               <a:ext uri="{FF2B5EF4-FFF2-40B4-BE49-F238E27FC236}">
-                <a16:creationId xmlns:a16="http://schemas.microsoft.com/office/drawing/2014/main" id="{7DE40B89-1D29-4166-9661-BD399EFC10D1}"/>
+                <a16:creationId xmlns:a16="http://schemas.microsoft.com/office/drawing/2014/main" id="{618E118B-BC3B-46C3-A542-EEA1398B76EC}"/>
               </a:ext>
             </a:extLst>
           </p:cNvPr>
@@ -5786,7 +5786,7 @@
           <p:cNvPr id="3" name="">
             <a:extLst xmlns:a="http://schemas.openxmlformats.org/drawingml/2006/main">
               <a:ext uri="{FF2B5EF4-FFF2-40B4-BE49-F238E27FC236}">
-                <a16:creationId xmlns:a16="http://schemas.microsoft.com/office/drawing/2014/main" id="{192BC707-006B-422B-96DD-5EA9E4A3774D}"/>
+                <a16:creationId xmlns:a16="http://schemas.microsoft.com/office/drawing/2014/main" id="{91517AC6-ED93-4153-9621-82F6E499ADF0}"/>
               </a:ext>
             </a:extLst>
           </p:cNvPr>
@@ -5798,7 +5798,7 @@
         <p:spPr>
           <a:xfrm xmlns:a="http://schemas.openxmlformats.org/drawingml/2006/main">
             <a:off x="400050" y="4333875"/>
-            <a:ext cx="10096500" cy="666750"/>
+            <a:ext cx="10477500" cy="666750"/>
           </a:xfrm>
           <a:prstGeom xmlns:a="http://schemas.openxmlformats.org/drawingml/2006/main" prst="rect">
             <a:avLst/>
@@ -5834,7 +5834,7 @@
                 <a:ea typeface="Microsoft YaHei"/>
                 <a:cs typeface="Microsoft YaHei"/>
               </a:rPr>
-              <a:t>ESP32 · 安全 PI · Z-N / IMC / BO / Safe BO / FNN / RL / LLM</a:t>
+              <a:t>ESP32 · 安全 PI · Z-N / IMC / BO / Safe BO / FNN / RL / LLM Agent</a:t>
             </a:r>
           </a:p>
         </p:txBody>
@@ -5844,7 +5844,7 @@
           <p:cNvPr id="4" name="">
             <a:extLst xmlns:a="http://schemas.openxmlformats.org/drawingml/2006/main">
               <a:ext uri="{FF2B5EF4-FFF2-40B4-BE49-F238E27FC236}">
-                <a16:creationId xmlns:a16="http://schemas.microsoft.com/office/drawing/2014/main" id="{94987404-2549-49BE-ABED-BB3E81306CD8}"/>
+                <a16:creationId xmlns:a16="http://schemas.microsoft.com/office/drawing/2014/main" id="{8E02FB66-5F4C-4D98-9DCF-3C17E240C06C}"/>
               </a:ext>
             </a:extLst>
           </p:cNvPr>
@@ -5879,7 +5879,7 @@
           <p:cNvPr id="5" name="">
             <a:extLst xmlns:a="http://schemas.openxmlformats.org/drawingml/2006/main">
               <a:ext uri="{FF2B5EF4-FFF2-40B4-BE49-F238E27FC236}">
-                <a16:creationId xmlns:a16="http://schemas.microsoft.com/office/drawing/2014/main" id="{C1C547EA-5494-427F-8148-1AEBF7BA487E}"/>
+                <a16:creationId xmlns:a16="http://schemas.microsoft.com/office/drawing/2014/main" id="{3017EB3E-DCD7-4C41-A434-52074F34AA7E}"/>
               </a:ext>
             </a:extLst>
           </p:cNvPr>
@@ -5937,7 +5937,7 @@
           <p:cNvPr id="6" name="">
             <a:extLst xmlns:a="http://schemas.openxmlformats.org/drawingml/2006/main">
               <a:ext uri="{FF2B5EF4-FFF2-40B4-BE49-F238E27FC236}">
-                <a16:creationId xmlns:a16="http://schemas.microsoft.com/office/drawing/2014/main" id="{1D1DDBB9-E305-4920-9FB9-2774791090C4}"/>
+                <a16:creationId xmlns:a16="http://schemas.microsoft.com/office/drawing/2014/main" id="{FE4C5716-C0E7-4CD9-9CAF-A2579B2E69A6}"/>
               </a:ext>
             </a:extLst>
           </p:cNvPr>
@@ -5970,7 +5970,7 @@
           <p:cNvPr id="7" name="">
             <a:extLst xmlns:a="http://schemas.openxmlformats.org/drawingml/2006/main">
               <a:ext uri="{FF2B5EF4-FFF2-40B4-BE49-F238E27FC236}">
-                <a16:creationId xmlns:a16="http://schemas.microsoft.com/office/drawing/2014/main" id="{B0EB452B-54EB-4C21-BACB-39C0D622E5C5}"/>
+                <a16:creationId xmlns:a16="http://schemas.microsoft.com/office/drawing/2014/main" id="{CE2BC4A0-8949-46E2-AB3B-266A1BEBD4C7}"/>
               </a:ext>
             </a:extLst>
           </p:cNvPr>
@@ -6003,7 +6003,7 @@
           <p:cNvPr id="8" name="">
             <a:extLst xmlns:a="http://schemas.openxmlformats.org/drawingml/2006/main">
               <a:ext uri="{FF2B5EF4-FFF2-40B4-BE49-F238E27FC236}">
-                <a16:creationId xmlns:a16="http://schemas.microsoft.com/office/drawing/2014/main" id="{9EE05A98-7AFF-45C4-AAD7-01AC6BDAC55D}"/>
+                <a16:creationId xmlns:a16="http://schemas.microsoft.com/office/drawing/2014/main" id="{3C9A6430-CF47-4AF2-A239-3F12EE396953}"/>
               </a:ext>
             </a:extLst>
           </p:cNvPr>
@@ -6036,7 +6036,7 @@
           <p:cNvPr id="9" name="">
             <a:extLst xmlns:a="http://schemas.openxmlformats.org/drawingml/2006/main">
               <a:ext uri="{FF2B5EF4-FFF2-40B4-BE49-F238E27FC236}">
-                <a16:creationId xmlns:a16="http://schemas.microsoft.com/office/drawing/2014/main" id="{EAAD31C8-F0C3-4723-B8DF-4257D7F3528F}"/>
+                <a16:creationId xmlns:a16="http://schemas.microsoft.com/office/drawing/2014/main" id="{B0503EC0-B716-46EC-A418-D112DE93EA88}"/>
               </a:ext>
             </a:extLst>
           </p:cNvPr>
@@ -6092,7 +6092,7 @@
     </p:spTree>
     <p:extLst>
       <p:ext uri="{BB962C8B-B14F-4D97-AF65-F5344CB8AC3E}">
-        <p14:creationId xmlns:p14="http://schemas.microsoft.com/office/powerpoint/2010/main" val="1071095060"/>
+        <p14:creationId xmlns:p14="http://schemas.microsoft.com/office/powerpoint/2010/main" val="741248758"/>
       </p:ext>
     </p:extLst>
   </p:cSld>
@@ -6116,7 +6116,7 @@
           <p:cNvPr id="23" name="">
             <a:extLst xmlns:a="http://schemas.openxmlformats.org/drawingml/2006/main">
               <a:ext uri="{FF2B5EF4-FFF2-40B4-BE49-F238E27FC236}">
-                <a16:creationId xmlns:a16="http://schemas.microsoft.com/office/drawing/2014/main" id="{8467C878-3845-4AF9-A53D-EAF570C074BF}"/>
+                <a16:creationId xmlns:a16="http://schemas.microsoft.com/office/drawing/2014/main" id="{DA8A596B-AEAD-4F81-842F-FE1C288C1EF3}"/>
               </a:ext>
             </a:extLst>
           </p:cNvPr>
@@ -6174,7 +6174,7 @@
           <p:cNvPr id="2" name="">
             <a:extLst xmlns:a="http://schemas.openxmlformats.org/drawingml/2006/main">
               <a:ext uri="{FF2B5EF4-FFF2-40B4-BE49-F238E27FC236}">
-                <a16:creationId xmlns:a16="http://schemas.microsoft.com/office/drawing/2014/main" id="{E8703B5A-9406-4B43-B5F4-D45DCDE4F454}"/>
+                <a16:creationId xmlns:a16="http://schemas.microsoft.com/office/drawing/2014/main" id="{04347162-AB27-45EB-BAAA-292372FD81E9}"/>
               </a:ext>
             </a:extLst>
           </p:cNvPr>
@@ -6232,19 +6232,19 @@
           <p:cNvPr id="3" name="">
             <a:extLst xmlns:a="http://schemas.openxmlformats.org/drawingml/2006/main">
               <a:ext uri="{FF2B5EF4-FFF2-40B4-BE49-F238E27FC236}">
-                <a16:creationId xmlns:a16="http://schemas.microsoft.com/office/drawing/2014/main" id="{EC9F2400-FB77-4A71-91FC-43DE0A3CCCF2}"/>
-              </a:ext>
-            </a:extLst>
-          </p:cNvPr>
-          <p:cNvSpPr>
-            <a:spLocks xmlns:a="http://schemas.openxmlformats.org/drawingml/2006/main" noGrp="1"/>
-          </p:cNvSpPr>
-          <p:nvPr/>
-        </p:nvSpPr>
-        <p:spPr>
-          <a:xfrm xmlns:a="http://schemas.openxmlformats.org/drawingml/2006/main">
-            <a:off x="11239500" y="6334125"/>
-            <a:ext cx="552450" cy="190500"/>
+                <a16:creationId xmlns:a16="http://schemas.microsoft.com/office/drawing/2014/main" id="{8278E23B-17DB-4AF3-AA1F-50F42C636EAF}"/>
+              </a:ext>
+            </a:extLst>
+          </p:cNvPr>
+          <p:cNvSpPr>
+            <a:spLocks xmlns:a="http://schemas.openxmlformats.org/drawingml/2006/main" noGrp="1"/>
+          </p:cNvSpPr>
+          <p:nvPr/>
+        </p:nvSpPr>
+        <p:spPr>
+          <a:xfrm xmlns:a="http://schemas.openxmlformats.org/drawingml/2006/main">
+            <a:off x="10953750" y="6334125"/>
+            <a:ext cx="838200" cy="190500"/>
           </a:xfrm>
           <a:prstGeom xmlns:a="http://schemas.openxmlformats.org/drawingml/2006/main" prst="rect">
             <a:avLst/>
@@ -6290,7 +6290,7 @@
           <p:cNvPr id="4" name="">
             <a:extLst xmlns:a="http://schemas.openxmlformats.org/drawingml/2006/main">
               <a:ext uri="{FF2B5EF4-FFF2-40B4-BE49-F238E27FC236}">
-                <a16:creationId xmlns:a16="http://schemas.microsoft.com/office/drawing/2014/main" id="{681C829F-038E-4CC9-8EB7-B2AFE93C5822}"/>
+                <a16:creationId xmlns:a16="http://schemas.microsoft.com/office/drawing/2014/main" id="{0C3DC061-9F8B-46B4-9545-02AB399E263D}"/>
               </a:ext>
             </a:extLst>
           </p:cNvPr>
@@ -6325,7 +6325,7 @@
           <p:cNvPr id="5" name="">
             <a:extLst xmlns:a="http://schemas.openxmlformats.org/drawingml/2006/main">
               <a:ext uri="{FF2B5EF4-FFF2-40B4-BE49-F238E27FC236}">
-                <a16:creationId xmlns:a16="http://schemas.microsoft.com/office/drawing/2014/main" id="{CECC6628-8B41-466A-ADC9-B8C7C86D1BF2}"/>
+                <a16:creationId xmlns:a16="http://schemas.microsoft.com/office/drawing/2014/main" id="{0BFF7976-1C47-4BAA-9D40-C8B1320BE048}"/>
               </a:ext>
             </a:extLst>
           </p:cNvPr>
@@ -6383,7 +6383,7 @@
           <p:cNvPr id="6" name="">
             <a:extLst xmlns:a="http://schemas.openxmlformats.org/drawingml/2006/main">
               <a:ext uri="{FF2B5EF4-FFF2-40B4-BE49-F238E27FC236}">
-                <a16:creationId xmlns:a16="http://schemas.microsoft.com/office/drawing/2014/main" id="{6F560F5B-43D3-4DBA-9A55-AE3C58C71B5E}"/>
+                <a16:creationId xmlns:a16="http://schemas.microsoft.com/office/drawing/2014/main" id="{BB28D6E1-6021-41FA-88A3-66E11A88E700}"/>
               </a:ext>
             </a:extLst>
           </p:cNvPr>
@@ -6441,7 +6441,7 @@
           <p:cNvPr id="7" name="">
             <a:extLst xmlns:a="http://schemas.openxmlformats.org/drawingml/2006/main">
               <a:ext uri="{FF2B5EF4-FFF2-40B4-BE49-F238E27FC236}">
-                <a16:creationId xmlns:a16="http://schemas.microsoft.com/office/drawing/2014/main" id="{558206C5-5B77-4242-B490-F450415630F9}"/>
+                <a16:creationId xmlns:a16="http://schemas.microsoft.com/office/drawing/2014/main" id="{355C3F4F-7AD5-48AE-98AB-08EE38E243B0}"/>
               </a:ext>
             </a:extLst>
           </p:cNvPr>
@@ -6474,7 +6474,7 @@
           <p:cNvPr id="8" name="">
             <a:extLst xmlns:a="http://schemas.openxmlformats.org/drawingml/2006/main">
               <a:ext uri="{FF2B5EF4-FFF2-40B4-BE49-F238E27FC236}">
-                <a16:creationId xmlns:a16="http://schemas.microsoft.com/office/drawing/2014/main" id="{EFE4F0D9-46A2-4773-AD1F-CE6F78E43549}"/>
+                <a16:creationId xmlns:a16="http://schemas.microsoft.com/office/drawing/2014/main" id="{06E845A8-E0A6-47F7-B2E0-5E7E71CCB7AA}"/>
               </a:ext>
             </a:extLst>
           </p:cNvPr>
@@ -6509,7 +6509,7 @@
           <p:cNvPr id="9" name="">
             <a:extLst xmlns:a="http://schemas.openxmlformats.org/drawingml/2006/main">
               <a:ext uri="{FF2B5EF4-FFF2-40B4-BE49-F238E27FC236}">
-                <a16:creationId xmlns:a16="http://schemas.microsoft.com/office/drawing/2014/main" id="{8C73CA7A-4DD2-4358-8A8F-5A92508A109F}"/>
+                <a16:creationId xmlns:a16="http://schemas.microsoft.com/office/drawing/2014/main" id="{96AE7D0D-494E-45B1-8C98-A04A91E251B6}"/>
               </a:ext>
             </a:extLst>
           </p:cNvPr>
@@ -6567,7 +6567,7 @@
           <p:cNvPr id="10" name="">
             <a:extLst xmlns:a="http://schemas.openxmlformats.org/drawingml/2006/main">
               <a:ext uri="{FF2B5EF4-FFF2-40B4-BE49-F238E27FC236}">
-                <a16:creationId xmlns:a16="http://schemas.microsoft.com/office/drawing/2014/main" id="{C525AD0F-037D-40E4-857D-0E93A2AE4E34}"/>
+                <a16:creationId xmlns:a16="http://schemas.microsoft.com/office/drawing/2014/main" id="{4DA63B0D-1A71-4D72-A4D9-7A5D97E78827}"/>
               </a:ext>
             </a:extLst>
           </p:cNvPr>
@@ -6625,7 +6625,7 @@
           <p:cNvPr id="11" name="">
             <a:extLst xmlns:a="http://schemas.openxmlformats.org/drawingml/2006/main">
               <a:ext uri="{FF2B5EF4-FFF2-40B4-BE49-F238E27FC236}">
-                <a16:creationId xmlns:a16="http://schemas.microsoft.com/office/drawing/2014/main" id="{5B0284F9-677B-4945-928B-71479FBFF13E}"/>
+                <a16:creationId xmlns:a16="http://schemas.microsoft.com/office/drawing/2014/main" id="{EEE18D82-EDD6-4A4F-847F-C7AA263FCEAF}"/>
               </a:ext>
             </a:extLst>
           </p:cNvPr>
@@ -6658,7 +6658,7 @@
           <p:cNvPr id="12" name="">
             <a:extLst xmlns:a="http://schemas.openxmlformats.org/drawingml/2006/main">
               <a:ext uri="{FF2B5EF4-FFF2-40B4-BE49-F238E27FC236}">
-                <a16:creationId xmlns:a16="http://schemas.microsoft.com/office/drawing/2014/main" id="{8D66CEB6-DCF1-4DC6-BE1B-62049B884178}"/>
+                <a16:creationId xmlns:a16="http://schemas.microsoft.com/office/drawing/2014/main" id="{8EAF0879-5B2E-42F8-A968-FAC75A0593A1}"/>
               </a:ext>
             </a:extLst>
           </p:cNvPr>
@@ -6693,7 +6693,7 @@
           <p:cNvPr id="13" name="">
             <a:extLst xmlns:a="http://schemas.openxmlformats.org/drawingml/2006/main">
               <a:ext uri="{FF2B5EF4-FFF2-40B4-BE49-F238E27FC236}">
-                <a16:creationId xmlns:a16="http://schemas.microsoft.com/office/drawing/2014/main" id="{FBFCF0DA-8FAD-4777-B90D-54F9C660ABFF}"/>
+                <a16:creationId xmlns:a16="http://schemas.microsoft.com/office/drawing/2014/main" id="{383EFB0F-9B3B-47C9-BD98-D637D5AE225C}"/>
               </a:ext>
             </a:extLst>
           </p:cNvPr>
@@ -6751,7 +6751,7 @@
           <p:cNvPr id="14" name="">
             <a:extLst xmlns:a="http://schemas.openxmlformats.org/drawingml/2006/main">
               <a:ext uri="{FF2B5EF4-FFF2-40B4-BE49-F238E27FC236}">
-                <a16:creationId xmlns:a16="http://schemas.microsoft.com/office/drawing/2014/main" id="{6BD2FBCE-5497-41CC-A9B1-59E4C062B3FE}"/>
+                <a16:creationId xmlns:a16="http://schemas.microsoft.com/office/drawing/2014/main" id="{F0D74901-2B7E-4DC1-AFC3-6FB239AFA8ED}"/>
               </a:ext>
             </a:extLst>
           </p:cNvPr>
@@ -6809,7 +6809,7 @@
           <p:cNvPr id="15" name="">
             <a:extLst xmlns:a="http://schemas.openxmlformats.org/drawingml/2006/main">
               <a:ext uri="{FF2B5EF4-FFF2-40B4-BE49-F238E27FC236}">
-                <a16:creationId xmlns:a16="http://schemas.microsoft.com/office/drawing/2014/main" id="{B5725498-4BC4-470F-AA4A-25A76924AE8F}"/>
+                <a16:creationId xmlns:a16="http://schemas.microsoft.com/office/drawing/2014/main" id="{EECF2607-6620-4923-A4AF-B813832F5B79}"/>
               </a:ext>
             </a:extLst>
           </p:cNvPr>
@@ -6842,7 +6842,7 @@
           <p:cNvPr id="16" name="">
             <a:extLst xmlns:a="http://schemas.openxmlformats.org/drawingml/2006/main">
               <a:ext uri="{FF2B5EF4-FFF2-40B4-BE49-F238E27FC236}">
-                <a16:creationId xmlns:a16="http://schemas.microsoft.com/office/drawing/2014/main" id="{A4AED724-F3C8-42E8-8D53-509CB33A964F}"/>
+                <a16:creationId xmlns:a16="http://schemas.microsoft.com/office/drawing/2014/main" id="{D019E25C-3B5E-4742-9877-58C93DA90957}"/>
               </a:ext>
             </a:extLst>
           </p:cNvPr>
@@ -6877,7 +6877,7 @@
           <p:cNvPr id="17" name="">
             <a:extLst xmlns:a="http://schemas.openxmlformats.org/drawingml/2006/main">
               <a:ext uri="{FF2B5EF4-FFF2-40B4-BE49-F238E27FC236}">
-                <a16:creationId xmlns:a16="http://schemas.microsoft.com/office/drawing/2014/main" id="{4FB764F1-AA87-4262-A5FD-8A1B17FA1FD8}"/>
+                <a16:creationId xmlns:a16="http://schemas.microsoft.com/office/drawing/2014/main" id="{3612100D-140D-480E-93A0-A893EA27208B}"/>
               </a:ext>
             </a:extLst>
           </p:cNvPr>
@@ -6935,7 +6935,7 @@
           <p:cNvPr id="18" name="">
             <a:extLst xmlns:a="http://schemas.openxmlformats.org/drawingml/2006/main">
               <a:ext uri="{FF2B5EF4-FFF2-40B4-BE49-F238E27FC236}">
-                <a16:creationId xmlns:a16="http://schemas.microsoft.com/office/drawing/2014/main" id="{CA785A54-2347-4AC4-8B03-F6EFAA18752C}"/>
+                <a16:creationId xmlns:a16="http://schemas.microsoft.com/office/drawing/2014/main" id="{B9940799-0E61-4775-9A54-BEE88CEF8B5E}"/>
               </a:ext>
             </a:extLst>
           </p:cNvPr>
@@ -6993,7 +6993,7 @@
           <p:cNvPr id="19" name="">
             <a:extLst xmlns:a="http://schemas.openxmlformats.org/drawingml/2006/main">
               <a:ext uri="{FF2B5EF4-FFF2-40B4-BE49-F238E27FC236}">
-                <a16:creationId xmlns:a16="http://schemas.microsoft.com/office/drawing/2014/main" id="{417B44B2-B613-4656-8DB0-57036D516ABB}"/>
+                <a16:creationId xmlns:a16="http://schemas.microsoft.com/office/drawing/2014/main" id="{33E843D8-9082-4D7F-97F7-8793F3494E9E}"/>
               </a:ext>
             </a:extLst>
           </p:cNvPr>
@@ -7028,7 +7028,7 @@
           <p:cNvPr id="20" name="">
             <a:extLst xmlns:a="http://schemas.openxmlformats.org/drawingml/2006/main">
               <a:ext uri="{FF2B5EF4-FFF2-40B4-BE49-F238E27FC236}">
-                <a16:creationId xmlns:a16="http://schemas.microsoft.com/office/drawing/2014/main" id="{42AD54C1-3A26-4498-9443-16699812967B}"/>
+                <a16:creationId xmlns:a16="http://schemas.microsoft.com/office/drawing/2014/main" id="{40E64963-7B95-45BF-843F-61C09CD7CBD9}"/>
               </a:ext>
             </a:extLst>
           </p:cNvPr>
@@ -7086,7 +7086,7 @@
           <p:cNvPr id="21" name="">
             <a:extLst xmlns:a="http://schemas.openxmlformats.org/drawingml/2006/main">
               <a:ext uri="{FF2B5EF4-FFF2-40B4-BE49-F238E27FC236}">
-                <a16:creationId xmlns:a16="http://schemas.microsoft.com/office/drawing/2014/main" id="{213A1731-5D72-41C6-839D-001884EF3BA4}"/>
+                <a16:creationId xmlns:a16="http://schemas.microsoft.com/office/drawing/2014/main" id="{F2D4A798-3083-4F89-A889-D5A399F3BF4B}"/>
               </a:ext>
             </a:extLst>
           </p:cNvPr>
@@ -7144,7 +7144,7 @@
           <p:cNvPr id="22" name="">
             <a:extLst xmlns:a="http://schemas.openxmlformats.org/drawingml/2006/main">
               <a:ext uri="{FF2B5EF4-FFF2-40B4-BE49-F238E27FC236}">
-                <a16:creationId xmlns:a16="http://schemas.microsoft.com/office/drawing/2014/main" id="{09B2C745-335C-490A-B954-2DEAB78D6987}"/>
+                <a16:creationId xmlns:a16="http://schemas.microsoft.com/office/drawing/2014/main" id="{E8EA3250-895B-44D0-A427-766E18EB602A}"/>
               </a:ext>
             </a:extLst>
           </p:cNvPr>
@@ -7200,7 +7200,7 @@
     </p:spTree>
     <p:extLst>
       <p:ext uri="{BB962C8B-B14F-4D97-AF65-F5344CB8AC3E}">
-        <p14:creationId xmlns:p14="http://schemas.microsoft.com/office/powerpoint/2010/main" val="2093801261"/>
+        <p14:creationId xmlns:p14="http://schemas.microsoft.com/office/powerpoint/2010/main" val="1527960937"/>
       </p:ext>
     </p:extLst>
   </p:cSld>
@@ -7224,7 +7224,7 @@
           <p:cNvPr id="23" name="">
             <a:extLst xmlns:a="http://schemas.openxmlformats.org/drawingml/2006/main">
               <a:ext uri="{FF2B5EF4-FFF2-40B4-BE49-F238E27FC236}">
-                <a16:creationId xmlns:a16="http://schemas.microsoft.com/office/drawing/2014/main" id="{426530CC-330D-4EFC-A65A-67C4D389B38D}"/>
+                <a16:creationId xmlns:a16="http://schemas.microsoft.com/office/drawing/2014/main" id="{98533C1A-3ADA-4368-B71F-5A8F80A55419}"/>
               </a:ext>
             </a:extLst>
           </p:cNvPr>
@@ -7282,7 +7282,7 @@
           <p:cNvPr id="2" name="">
             <a:extLst xmlns:a="http://schemas.openxmlformats.org/drawingml/2006/main">
               <a:ext uri="{FF2B5EF4-FFF2-40B4-BE49-F238E27FC236}">
-                <a16:creationId xmlns:a16="http://schemas.microsoft.com/office/drawing/2014/main" id="{A50629A4-427B-4C70-9B93-2B317574679A}"/>
+                <a16:creationId xmlns:a16="http://schemas.microsoft.com/office/drawing/2014/main" id="{34F55BC4-9C17-4A77-B79E-DFCA93D866BE}"/>
               </a:ext>
             </a:extLst>
           </p:cNvPr>
@@ -7340,19 +7340,19 @@
           <p:cNvPr id="3" name="">
             <a:extLst xmlns:a="http://schemas.openxmlformats.org/drawingml/2006/main">
               <a:ext uri="{FF2B5EF4-FFF2-40B4-BE49-F238E27FC236}">
-                <a16:creationId xmlns:a16="http://schemas.microsoft.com/office/drawing/2014/main" id="{6D6D0E56-2360-4647-AA60-A25FBBBAAD63}"/>
-              </a:ext>
-            </a:extLst>
-          </p:cNvPr>
-          <p:cNvSpPr>
-            <a:spLocks xmlns:a="http://schemas.openxmlformats.org/drawingml/2006/main" noGrp="1"/>
-          </p:cNvSpPr>
-          <p:nvPr/>
-        </p:nvSpPr>
-        <p:spPr>
-          <a:xfrm xmlns:a="http://schemas.openxmlformats.org/drawingml/2006/main">
-            <a:off x="11239500" y="6334125"/>
-            <a:ext cx="552450" cy="190500"/>
+                <a16:creationId xmlns:a16="http://schemas.microsoft.com/office/drawing/2014/main" id="{FE1A3AF2-7E68-4CCC-9462-50B348F3032C}"/>
+              </a:ext>
+            </a:extLst>
+          </p:cNvPr>
+          <p:cNvSpPr>
+            <a:spLocks xmlns:a="http://schemas.openxmlformats.org/drawingml/2006/main" noGrp="1"/>
+          </p:cNvSpPr>
+          <p:nvPr/>
+        </p:nvSpPr>
+        <p:spPr>
+          <a:xfrm xmlns:a="http://schemas.openxmlformats.org/drawingml/2006/main">
+            <a:off x="10953750" y="6334125"/>
+            <a:ext cx="838200" cy="190500"/>
           </a:xfrm>
           <a:prstGeom xmlns:a="http://schemas.openxmlformats.org/drawingml/2006/main" prst="rect">
             <a:avLst/>
@@ -7398,7 +7398,7 @@
           <p:cNvPr id="4" name="">
             <a:extLst xmlns:a="http://schemas.openxmlformats.org/drawingml/2006/main">
               <a:ext uri="{FF2B5EF4-FFF2-40B4-BE49-F238E27FC236}">
-                <a16:creationId xmlns:a16="http://schemas.microsoft.com/office/drawing/2014/main" id="{7097205B-C42B-45A5-9B94-6B224CE61377}"/>
+                <a16:creationId xmlns:a16="http://schemas.microsoft.com/office/drawing/2014/main" id="{4755BF0A-45DD-4BB5-B5B8-8BC2A42D0E11}"/>
               </a:ext>
             </a:extLst>
           </p:cNvPr>
@@ -7433,7 +7433,7 @@
           <p:cNvPr id="5" name="">
             <a:extLst xmlns:a="http://schemas.openxmlformats.org/drawingml/2006/main">
               <a:ext uri="{FF2B5EF4-FFF2-40B4-BE49-F238E27FC236}">
-                <a16:creationId xmlns:a16="http://schemas.microsoft.com/office/drawing/2014/main" id="{CBC29E32-A15B-4D10-B906-16BAF4231076}"/>
+                <a16:creationId xmlns:a16="http://schemas.microsoft.com/office/drawing/2014/main" id="{A1B10062-2C0D-4A99-AEFB-69D6582DA45A}"/>
               </a:ext>
             </a:extLst>
           </p:cNvPr>
@@ -7491,7 +7491,7 @@
           <p:cNvPr id="6" name="">
             <a:extLst xmlns:a="http://schemas.openxmlformats.org/drawingml/2006/main">
               <a:ext uri="{FF2B5EF4-FFF2-40B4-BE49-F238E27FC236}">
-                <a16:creationId xmlns:a16="http://schemas.microsoft.com/office/drawing/2014/main" id="{3766F646-28A5-455F-9579-874EC4220C9A}"/>
+                <a16:creationId xmlns:a16="http://schemas.microsoft.com/office/drawing/2014/main" id="{C428969D-7EB5-4C39-A652-B527E7536F73}"/>
               </a:ext>
             </a:extLst>
           </p:cNvPr>
@@ -7549,7 +7549,7 @@
           <p:cNvPr id="7" name="">
             <a:extLst xmlns:a="http://schemas.openxmlformats.org/drawingml/2006/main">
               <a:ext uri="{FF2B5EF4-FFF2-40B4-BE49-F238E27FC236}">
-                <a16:creationId xmlns:a16="http://schemas.microsoft.com/office/drawing/2014/main" id="{16F7B0CD-8DB4-4C67-BDF0-610C20DD5A3C}"/>
+                <a16:creationId xmlns:a16="http://schemas.microsoft.com/office/drawing/2014/main" id="{19C21F88-ED71-4F9A-9B66-12ACDADF6422}"/>
               </a:ext>
             </a:extLst>
           </p:cNvPr>
@@ -7582,7 +7582,7 @@
           <p:cNvPr id="8" name="">
             <a:extLst xmlns:a="http://schemas.openxmlformats.org/drawingml/2006/main">
               <a:ext uri="{FF2B5EF4-FFF2-40B4-BE49-F238E27FC236}">
-                <a16:creationId xmlns:a16="http://schemas.microsoft.com/office/drawing/2014/main" id="{0DB8D0D6-F22A-401A-BEAA-B979D8D98489}"/>
+                <a16:creationId xmlns:a16="http://schemas.microsoft.com/office/drawing/2014/main" id="{1AB20278-9790-4C14-A84A-CF660813E177}"/>
               </a:ext>
             </a:extLst>
           </p:cNvPr>
@@ -7617,7 +7617,7 @@
           <p:cNvPr id="9" name="">
             <a:extLst xmlns:a="http://schemas.openxmlformats.org/drawingml/2006/main">
               <a:ext uri="{FF2B5EF4-FFF2-40B4-BE49-F238E27FC236}">
-                <a16:creationId xmlns:a16="http://schemas.microsoft.com/office/drawing/2014/main" id="{17BC30D2-745E-45C9-989E-0648229DC869}"/>
+                <a16:creationId xmlns:a16="http://schemas.microsoft.com/office/drawing/2014/main" id="{2789C8B1-C612-4E72-99D6-3EFC77022597}"/>
               </a:ext>
             </a:extLst>
           </p:cNvPr>
@@ -7675,7 +7675,7 @@
           <p:cNvPr id="10" name="">
             <a:extLst xmlns:a="http://schemas.openxmlformats.org/drawingml/2006/main">
               <a:ext uri="{FF2B5EF4-FFF2-40B4-BE49-F238E27FC236}">
-                <a16:creationId xmlns:a16="http://schemas.microsoft.com/office/drawing/2014/main" id="{E9224452-B9D0-4340-B08A-6E3FCDBDAF48}"/>
+                <a16:creationId xmlns:a16="http://schemas.microsoft.com/office/drawing/2014/main" id="{603E26CB-8808-45D4-89FE-DEC0DD8C5B7F}"/>
               </a:ext>
             </a:extLst>
           </p:cNvPr>
@@ -7733,7 +7733,7 @@
           <p:cNvPr id="11" name="">
             <a:extLst xmlns:a="http://schemas.openxmlformats.org/drawingml/2006/main">
               <a:ext uri="{FF2B5EF4-FFF2-40B4-BE49-F238E27FC236}">
-                <a16:creationId xmlns:a16="http://schemas.microsoft.com/office/drawing/2014/main" id="{625C6386-AC6D-48FA-B01A-C24DBA1E12F8}"/>
+                <a16:creationId xmlns:a16="http://schemas.microsoft.com/office/drawing/2014/main" id="{77BB4667-32C9-457B-BA6C-E2E5BB254210}"/>
               </a:ext>
             </a:extLst>
           </p:cNvPr>
@@ -7766,7 +7766,7 @@
           <p:cNvPr id="12" name="">
             <a:extLst xmlns:a="http://schemas.openxmlformats.org/drawingml/2006/main">
               <a:ext uri="{FF2B5EF4-FFF2-40B4-BE49-F238E27FC236}">
-                <a16:creationId xmlns:a16="http://schemas.microsoft.com/office/drawing/2014/main" id="{D22DCDC3-AA74-430A-B1B0-84500FF02450}"/>
+                <a16:creationId xmlns:a16="http://schemas.microsoft.com/office/drawing/2014/main" id="{868F8CF4-27ED-44D1-9429-87D4BB1E09E0}"/>
               </a:ext>
             </a:extLst>
           </p:cNvPr>
@@ -7801,7 +7801,7 @@
           <p:cNvPr id="13" name="">
             <a:extLst xmlns:a="http://schemas.openxmlformats.org/drawingml/2006/main">
               <a:ext uri="{FF2B5EF4-FFF2-40B4-BE49-F238E27FC236}">
-                <a16:creationId xmlns:a16="http://schemas.microsoft.com/office/drawing/2014/main" id="{4500E312-B908-43D8-A453-74B90FC6E312}"/>
+                <a16:creationId xmlns:a16="http://schemas.microsoft.com/office/drawing/2014/main" id="{8F27FF0D-22E9-42F5-BFBF-222E9F166087}"/>
               </a:ext>
             </a:extLst>
           </p:cNvPr>
@@ -7859,7 +7859,7 @@
           <p:cNvPr id="14" name="">
             <a:extLst xmlns:a="http://schemas.openxmlformats.org/drawingml/2006/main">
               <a:ext uri="{FF2B5EF4-FFF2-40B4-BE49-F238E27FC236}">
-                <a16:creationId xmlns:a16="http://schemas.microsoft.com/office/drawing/2014/main" id="{69189D4B-91BA-44A5-9F46-2C55EA5B88D1}"/>
+                <a16:creationId xmlns:a16="http://schemas.microsoft.com/office/drawing/2014/main" id="{1565458C-5C2D-40EE-A516-29D20BF890E4}"/>
               </a:ext>
             </a:extLst>
           </p:cNvPr>
@@ -7917,7 +7917,7 @@
           <p:cNvPr id="15" name="">
             <a:extLst xmlns:a="http://schemas.openxmlformats.org/drawingml/2006/main">
               <a:ext uri="{FF2B5EF4-FFF2-40B4-BE49-F238E27FC236}">
-                <a16:creationId xmlns:a16="http://schemas.microsoft.com/office/drawing/2014/main" id="{43D1D305-891C-49EE-935E-0ACF13967F98}"/>
+                <a16:creationId xmlns:a16="http://schemas.microsoft.com/office/drawing/2014/main" id="{250C2FFE-211B-4ADC-88ED-24F627D6B798}"/>
               </a:ext>
             </a:extLst>
           </p:cNvPr>
@@ -7950,7 +7950,7 @@
           <p:cNvPr id="16" name="">
             <a:extLst xmlns:a="http://schemas.openxmlformats.org/drawingml/2006/main">
               <a:ext uri="{FF2B5EF4-FFF2-40B4-BE49-F238E27FC236}">
-                <a16:creationId xmlns:a16="http://schemas.microsoft.com/office/drawing/2014/main" id="{5B80EA87-7096-4FA9-ABDB-BF82D79EBB79}"/>
+                <a16:creationId xmlns:a16="http://schemas.microsoft.com/office/drawing/2014/main" id="{557DF73E-4BA2-497C-A961-7851EFA4E144}"/>
               </a:ext>
             </a:extLst>
           </p:cNvPr>
@@ -7985,7 +7985,7 @@
           <p:cNvPr id="17" name="">
             <a:extLst xmlns:a="http://schemas.openxmlformats.org/drawingml/2006/main">
               <a:ext uri="{FF2B5EF4-FFF2-40B4-BE49-F238E27FC236}">
-                <a16:creationId xmlns:a16="http://schemas.microsoft.com/office/drawing/2014/main" id="{93853C15-C1D8-4A52-909A-0D70255E9471}"/>
+                <a16:creationId xmlns:a16="http://schemas.microsoft.com/office/drawing/2014/main" id="{3DF385F2-EA8F-4080-99EF-F3C028AFC7EF}"/>
               </a:ext>
             </a:extLst>
           </p:cNvPr>
@@ -8043,7 +8043,7 @@
           <p:cNvPr id="18" name="">
             <a:extLst xmlns:a="http://schemas.openxmlformats.org/drawingml/2006/main">
               <a:ext uri="{FF2B5EF4-FFF2-40B4-BE49-F238E27FC236}">
-                <a16:creationId xmlns:a16="http://schemas.microsoft.com/office/drawing/2014/main" id="{89D9299E-E10A-4785-BB81-55984BB7A49B}"/>
+                <a16:creationId xmlns:a16="http://schemas.microsoft.com/office/drawing/2014/main" id="{8F787A98-B155-4B93-BA37-696687238A27}"/>
               </a:ext>
             </a:extLst>
           </p:cNvPr>
@@ -8101,7 +8101,7 @@
           <p:cNvPr id="19" name="">
             <a:extLst xmlns:a="http://schemas.openxmlformats.org/drawingml/2006/main">
               <a:ext uri="{FF2B5EF4-FFF2-40B4-BE49-F238E27FC236}">
-                <a16:creationId xmlns:a16="http://schemas.microsoft.com/office/drawing/2014/main" id="{B6DDCEFC-889B-4A3C-871D-A5D17AB92463}"/>
+                <a16:creationId xmlns:a16="http://schemas.microsoft.com/office/drawing/2014/main" id="{82CEFC87-9630-4408-BAF3-6127EDC39031}"/>
               </a:ext>
             </a:extLst>
           </p:cNvPr>
@@ -8136,7 +8136,7 @@
           <p:cNvPr id="20" name="">
             <a:extLst xmlns:a="http://schemas.openxmlformats.org/drawingml/2006/main">
               <a:ext uri="{FF2B5EF4-FFF2-40B4-BE49-F238E27FC236}">
-                <a16:creationId xmlns:a16="http://schemas.microsoft.com/office/drawing/2014/main" id="{0A4B076E-290A-4BE4-AD73-50BC18F25D66}"/>
+                <a16:creationId xmlns:a16="http://schemas.microsoft.com/office/drawing/2014/main" id="{6AD7236E-58AC-401E-96F0-A6C2D18B4792}"/>
               </a:ext>
             </a:extLst>
           </p:cNvPr>
@@ -8194,7 +8194,7 @@
           <p:cNvPr id="21" name="">
             <a:extLst xmlns:a="http://schemas.openxmlformats.org/drawingml/2006/main">
               <a:ext uri="{FF2B5EF4-FFF2-40B4-BE49-F238E27FC236}">
-                <a16:creationId xmlns:a16="http://schemas.microsoft.com/office/drawing/2014/main" id="{0A2F8826-A8BB-4578-90EB-5663F373FED8}"/>
+                <a16:creationId xmlns:a16="http://schemas.microsoft.com/office/drawing/2014/main" id="{744FEF78-7F33-4142-9156-EE22BBE0E3C5}"/>
               </a:ext>
             </a:extLst>
           </p:cNvPr>
@@ -8252,7 +8252,7 @@
           <p:cNvPr id="22" name="">
             <a:extLst xmlns:a="http://schemas.openxmlformats.org/drawingml/2006/main">
               <a:ext uri="{FF2B5EF4-FFF2-40B4-BE49-F238E27FC236}">
-                <a16:creationId xmlns:a16="http://schemas.microsoft.com/office/drawing/2014/main" id="{7D77BD82-CBD3-4B5A-9890-941C15E18443}"/>
+                <a16:creationId xmlns:a16="http://schemas.microsoft.com/office/drawing/2014/main" id="{8E20AB7F-855D-4E46-BE78-E76B29BA1B24}"/>
               </a:ext>
             </a:extLst>
           </p:cNvPr>
@@ -8308,7 +8308,7 @@
     </p:spTree>
     <p:extLst>
       <p:ext uri="{BB962C8B-B14F-4D97-AF65-F5344CB8AC3E}">
-        <p14:creationId xmlns:p14="http://schemas.microsoft.com/office/powerpoint/2010/main" val="2050206373"/>
+        <p14:creationId xmlns:p14="http://schemas.microsoft.com/office/powerpoint/2010/main" val="1700875373"/>
       </p:ext>
     </p:extLst>
   </p:cSld>
@@ -8332,7 +8332,7 @@
           <p:cNvPr id="23" name="">
             <a:extLst xmlns:a="http://schemas.openxmlformats.org/drawingml/2006/main">
               <a:ext uri="{FF2B5EF4-FFF2-40B4-BE49-F238E27FC236}">
-                <a16:creationId xmlns:a16="http://schemas.microsoft.com/office/drawing/2014/main" id="{5B8E19F6-7D7B-40C9-AA35-FA3BA9460638}"/>
+                <a16:creationId xmlns:a16="http://schemas.microsoft.com/office/drawing/2014/main" id="{00AEC8A4-6857-43A3-A12E-AF7CF56B2730}"/>
               </a:ext>
             </a:extLst>
           </p:cNvPr>
@@ -8390,7 +8390,7 @@
           <p:cNvPr id="2" name="">
             <a:extLst xmlns:a="http://schemas.openxmlformats.org/drawingml/2006/main">
               <a:ext uri="{FF2B5EF4-FFF2-40B4-BE49-F238E27FC236}">
-                <a16:creationId xmlns:a16="http://schemas.microsoft.com/office/drawing/2014/main" id="{B835608A-4852-4CD4-9086-4AD0028DE2C5}"/>
+                <a16:creationId xmlns:a16="http://schemas.microsoft.com/office/drawing/2014/main" id="{2D6798E0-970D-477F-86B3-B2015F198BE6}"/>
               </a:ext>
             </a:extLst>
           </p:cNvPr>
@@ -8438,7 +8438,7 @@
                 <a:ea typeface="Microsoft YaHei"/>
                 <a:cs typeface="Microsoft YaHei"/>
               </a:rPr>
-              <a:t>LLM 只提建议：Schema、±10%与仿真门拥有最终决定权</a:t>
+              <a:t>Agent 自主试验，宿主安全门最终裁决</a:t>
             </a:r>
           </a:p>
         </p:txBody>
@@ -8448,19 +8448,19 @@
           <p:cNvPr id="3" name="">
             <a:extLst xmlns:a="http://schemas.openxmlformats.org/drawingml/2006/main">
               <a:ext uri="{FF2B5EF4-FFF2-40B4-BE49-F238E27FC236}">
-                <a16:creationId xmlns:a16="http://schemas.microsoft.com/office/drawing/2014/main" id="{C237A654-F563-4729-A3ED-CA14F67BA6EF}"/>
-              </a:ext>
-            </a:extLst>
-          </p:cNvPr>
-          <p:cNvSpPr>
-            <a:spLocks xmlns:a="http://schemas.openxmlformats.org/drawingml/2006/main" noGrp="1"/>
-          </p:cNvSpPr>
-          <p:nvPr/>
-        </p:nvSpPr>
-        <p:spPr>
-          <a:xfrm xmlns:a="http://schemas.openxmlformats.org/drawingml/2006/main">
-            <a:off x="11239500" y="6334125"/>
-            <a:ext cx="552450" cy="190500"/>
+                <a16:creationId xmlns:a16="http://schemas.microsoft.com/office/drawing/2014/main" id="{86CCCB57-EE6A-4210-BBB3-B5C6CF27CC35}"/>
+              </a:ext>
+            </a:extLst>
+          </p:cNvPr>
+          <p:cNvSpPr>
+            <a:spLocks xmlns:a="http://schemas.openxmlformats.org/drawingml/2006/main" noGrp="1"/>
+          </p:cNvSpPr>
+          <p:nvPr/>
+        </p:nvSpPr>
+        <p:spPr>
+          <a:xfrm xmlns:a="http://schemas.openxmlformats.org/drawingml/2006/main">
+            <a:off x="10953750" y="6334125"/>
+            <a:ext cx="838200" cy="190500"/>
           </a:xfrm>
           <a:prstGeom xmlns:a="http://schemas.openxmlformats.org/drawingml/2006/main" prst="rect">
             <a:avLst/>
@@ -8506,7 +8506,7 @@
           <p:cNvPr id="4" name="">
             <a:extLst xmlns:a="http://schemas.openxmlformats.org/drawingml/2006/main">
               <a:ext uri="{FF2B5EF4-FFF2-40B4-BE49-F238E27FC236}">
-                <a16:creationId xmlns:a16="http://schemas.microsoft.com/office/drawing/2014/main" id="{42E7E90E-3100-412B-B295-7CEE0C58D977}"/>
+                <a16:creationId xmlns:a16="http://schemas.microsoft.com/office/drawing/2014/main" id="{974EA59A-BA77-40CB-8B66-C5E666E36E8F}"/>
               </a:ext>
             </a:extLst>
           </p:cNvPr>
@@ -8541,7 +8541,7 @@
           <p:cNvPr id="5" name="">
             <a:extLst xmlns:a="http://schemas.openxmlformats.org/drawingml/2006/main">
               <a:ext uri="{FF2B5EF4-FFF2-40B4-BE49-F238E27FC236}">
-                <a16:creationId xmlns:a16="http://schemas.microsoft.com/office/drawing/2014/main" id="{FF8D2C81-033B-4B54-A6BE-E1071AC31831}"/>
+                <a16:creationId xmlns:a16="http://schemas.microsoft.com/office/drawing/2014/main" id="{590B2D46-C083-4147-838A-4B5ACCB03A83}"/>
               </a:ext>
             </a:extLst>
           </p:cNvPr>
@@ -8589,7 +8589,7 @@
                 <a:ea typeface="Microsoft YaHei"/>
                 <a:cs typeface="Microsoft YaHei"/>
               </a:rPr>
-              <a:t>当前增益与指标</a:t>
+              <a:t>当前安全点与历史</a:t>
             </a:r>
           </a:p>
         </p:txBody>
@@ -8599,7 +8599,7 @@
           <p:cNvPr id="6" name="">
             <a:extLst xmlns:a="http://schemas.openxmlformats.org/drawingml/2006/main">
               <a:ext uri="{FF2B5EF4-FFF2-40B4-BE49-F238E27FC236}">
-                <a16:creationId xmlns:a16="http://schemas.microsoft.com/office/drawing/2014/main" id="{C90CC90B-1986-4673-8E3F-6F8652FD079C}"/>
+                <a16:creationId xmlns:a16="http://schemas.microsoft.com/office/drawing/2014/main" id="{D632BBDD-65F6-4C63-87BB-58435F928B06}"/>
               </a:ext>
             </a:extLst>
           </p:cNvPr>
@@ -8647,7 +8647,7 @@
                 <a:ea typeface="Microsoft YaHei"/>
                 <a:cs typeface="Microsoft YaHei"/>
               </a:rPr>
-              <a:t>replay / Ollama / OpenAI</a:t>
+              <a:t>指标、限制、剩余预算</a:t>
             </a:r>
           </a:p>
         </p:txBody>
@@ -8657,7 +8657,7 @@
           <p:cNvPr id="7" name="">
             <a:extLst xmlns:a="http://schemas.openxmlformats.org/drawingml/2006/main">
               <a:ext uri="{FF2B5EF4-FFF2-40B4-BE49-F238E27FC236}">
-                <a16:creationId xmlns:a16="http://schemas.microsoft.com/office/drawing/2014/main" id="{43C1EE82-6A52-44BA-B664-B8CCD6B19E6F}"/>
+                <a16:creationId xmlns:a16="http://schemas.microsoft.com/office/drawing/2014/main" id="{90935D30-EE21-47C1-867A-450B6534BF21}"/>
               </a:ext>
             </a:extLst>
           </p:cNvPr>
@@ -8690,7 +8690,7 @@
           <p:cNvPr id="8" name="">
             <a:extLst xmlns:a="http://schemas.openxmlformats.org/drawingml/2006/main">
               <a:ext uri="{FF2B5EF4-FFF2-40B4-BE49-F238E27FC236}">
-                <a16:creationId xmlns:a16="http://schemas.microsoft.com/office/drawing/2014/main" id="{02DD9127-718B-43A4-96BB-790376A8071E}"/>
+                <a16:creationId xmlns:a16="http://schemas.microsoft.com/office/drawing/2014/main" id="{82405B0C-532C-4259-A2F2-55816BF5B2B0}"/>
               </a:ext>
             </a:extLst>
           </p:cNvPr>
@@ -8725,7 +8725,7 @@
           <p:cNvPr id="9" name="">
             <a:extLst xmlns:a="http://schemas.openxmlformats.org/drawingml/2006/main">
               <a:ext uri="{FF2B5EF4-FFF2-40B4-BE49-F238E27FC236}">
-                <a16:creationId xmlns:a16="http://schemas.microsoft.com/office/drawing/2014/main" id="{66870887-58BE-4A50-BB9E-1735C84FEAD2}"/>
+                <a16:creationId xmlns:a16="http://schemas.microsoft.com/office/drawing/2014/main" id="{B24D7B6A-2C8E-4B09-A27A-3FAAF29E3D9C}"/>
               </a:ext>
             </a:extLst>
           </p:cNvPr>
@@ -8773,7 +8773,7 @@
                 <a:ea typeface="Microsoft YaHei"/>
                 <a:cs typeface="Microsoft YaHei"/>
               </a:rPr>
-              <a:t>结构化诊断</a:t>
+              <a:t>自主三选一</a:t>
             </a:r>
           </a:p>
         </p:txBody>
@@ -8783,7 +8783,7 @@
           <p:cNvPr id="10" name="">
             <a:extLst xmlns:a="http://schemas.openxmlformats.org/drawingml/2006/main">
               <a:ext uri="{FF2B5EF4-FFF2-40B4-BE49-F238E27FC236}">
-                <a16:creationId xmlns:a16="http://schemas.microsoft.com/office/drawing/2014/main" id="{0FC328ED-3A8F-42FF-B1A0-2C534B062359}"/>
+                <a16:creationId xmlns:a16="http://schemas.microsoft.com/office/drawing/2014/main" id="{CC59F0A0-2844-4838-8576-A42420A7490F}"/>
               </a:ext>
             </a:extLst>
           </p:cNvPr>
@@ -8831,7 +8831,7 @@
                 <a:ea typeface="Microsoft YaHei"/>
                 <a:cs typeface="Microsoft YaHei"/>
               </a:rPr>
-              <a:t>只提出 Kp/Ki</a:t>
+              <a:t>查看 / 仿真 / 结束</a:t>
             </a:r>
           </a:p>
         </p:txBody>
@@ -8841,7 +8841,7 @@
           <p:cNvPr id="11" name="">
             <a:extLst xmlns:a="http://schemas.openxmlformats.org/drawingml/2006/main">
               <a:ext uri="{FF2B5EF4-FFF2-40B4-BE49-F238E27FC236}">
-                <a16:creationId xmlns:a16="http://schemas.microsoft.com/office/drawing/2014/main" id="{F750770D-0EC6-4A7C-A933-F8E6571BBB91}"/>
+                <a16:creationId xmlns:a16="http://schemas.microsoft.com/office/drawing/2014/main" id="{820C5FDC-11C7-419B-8A2D-E8D18772A059}"/>
               </a:ext>
             </a:extLst>
           </p:cNvPr>
@@ -8874,7 +8874,7 @@
           <p:cNvPr id="12" name="">
             <a:extLst xmlns:a="http://schemas.openxmlformats.org/drawingml/2006/main">
               <a:ext uri="{FF2B5EF4-FFF2-40B4-BE49-F238E27FC236}">
-                <a16:creationId xmlns:a16="http://schemas.microsoft.com/office/drawing/2014/main" id="{A7244973-4C9E-4FAA-90DE-908D29187913}"/>
+                <a16:creationId xmlns:a16="http://schemas.microsoft.com/office/drawing/2014/main" id="{179089E2-8B29-4257-8747-D98BD795FBB8}"/>
               </a:ext>
             </a:extLst>
           </p:cNvPr>
@@ -8909,7 +8909,7 @@
           <p:cNvPr id="13" name="">
             <a:extLst xmlns:a="http://schemas.openxmlformats.org/drawingml/2006/main">
               <a:ext uri="{FF2B5EF4-FFF2-40B4-BE49-F238E27FC236}">
-                <a16:creationId xmlns:a16="http://schemas.microsoft.com/office/drawing/2014/main" id="{B51F7C53-67A1-47E9-90B5-9CC8EE131FA5}"/>
+                <a16:creationId xmlns:a16="http://schemas.microsoft.com/office/drawing/2014/main" id="{FE7CD19B-D5C6-44BE-A05D-37CA05188E4A}"/>
               </a:ext>
             </a:extLst>
           </p:cNvPr>
@@ -8957,7 +8957,7 @@
                 <a:ea typeface="Microsoft YaHei"/>
                 <a:cs typeface="Microsoft YaHei"/>
               </a:rPr>
-              <a:t>格式→边界→±10%</a:t>
+              <a:t>宿主限幅 ±10%</a:t>
             </a:r>
           </a:p>
         </p:txBody>
@@ -8967,7 +8967,7 @@
           <p:cNvPr id="14" name="">
             <a:extLst xmlns:a="http://schemas.openxmlformats.org/drawingml/2006/main">
               <a:ext uri="{FF2B5EF4-FFF2-40B4-BE49-F238E27FC236}">
-                <a16:creationId xmlns:a16="http://schemas.microsoft.com/office/drawing/2014/main" id="{1D66568B-7070-4AFA-94BF-881DC9E59E7B}"/>
+                <a16:creationId xmlns:a16="http://schemas.microsoft.com/office/drawing/2014/main" id="{2CAEF1FA-1B10-42CB-A10A-609618F62E1F}"/>
               </a:ext>
             </a:extLst>
           </p:cNvPr>
@@ -9025,7 +9025,7 @@
           <p:cNvPr id="15" name="">
             <a:extLst xmlns:a="http://schemas.openxmlformats.org/drawingml/2006/main">
               <a:ext uri="{FF2B5EF4-FFF2-40B4-BE49-F238E27FC236}">
-                <a16:creationId xmlns:a16="http://schemas.microsoft.com/office/drawing/2014/main" id="{2F414F96-6B67-42C2-BCBA-599F4575BA53}"/>
+                <a16:creationId xmlns:a16="http://schemas.microsoft.com/office/drawing/2014/main" id="{E9007658-4722-42E7-978A-B7F717BEDB59}"/>
               </a:ext>
             </a:extLst>
           </p:cNvPr>
@@ -9058,7 +9058,7 @@
           <p:cNvPr id="16" name="">
             <a:extLst xmlns:a="http://schemas.openxmlformats.org/drawingml/2006/main">
               <a:ext uri="{FF2B5EF4-FFF2-40B4-BE49-F238E27FC236}">
-                <a16:creationId xmlns:a16="http://schemas.microsoft.com/office/drawing/2014/main" id="{8C0A004C-6E94-4ABA-BFA1-8F8AC026680B}"/>
+                <a16:creationId xmlns:a16="http://schemas.microsoft.com/office/drawing/2014/main" id="{BE5671FD-19C5-4CB4-8333-AEDBCAC69119}"/>
               </a:ext>
             </a:extLst>
           </p:cNvPr>
@@ -9093,7 +9093,7 @@
           <p:cNvPr id="17" name="">
             <a:extLst xmlns:a="http://schemas.openxmlformats.org/drawingml/2006/main">
               <a:ext uri="{FF2B5EF4-FFF2-40B4-BE49-F238E27FC236}">
-                <a16:creationId xmlns:a16="http://schemas.microsoft.com/office/drawing/2014/main" id="{1691CAB9-D717-4283-B849-7FB12AE4AD92}"/>
+                <a16:creationId xmlns:a16="http://schemas.microsoft.com/office/drawing/2014/main" id="{F8AC05C2-2B7A-4558-929E-50CAC69EE949}"/>
               </a:ext>
             </a:extLst>
           </p:cNvPr>
@@ -9141,7 +9141,7 @@
                 <a:ea typeface="Microsoft YaHei"/>
                 <a:cs typeface="Microsoft YaHei"/>
               </a:rPr>
-              <a:t>验收后的固定参数</a:t>
+              <a:t>已验收固定参数</a:t>
             </a:r>
           </a:p>
         </p:txBody>
@@ -9151,7 +9151,7 @@
           <p:cNvPr id="18" name="">
             <a:extLst xmlns:a="http://schemas.openxmlformats.org/drawingml/2006/main">
               <a:ext uri="{FF2B5EF4-FFF2-40B4-BE49-F238E27FC236}">
-                <a16:creationId xmlns:a16="http://schemas.microsoft.com/office/drawing/2014/main" id="{007EABAC-47AE-4E8A-A00B-B2CC5FA82AB1}"/>
+                <a16:creationId xmlns:a16="http://schemas.microsoft.com/office/drawing/2014/main" id="{AC86E884-A5E4-488C-8B06-F45F2B76EC2D}"/>
               </a:ext>
             </a:extLst>
           </p:cNvPr>
@@ -9199,7 +9199,7 @@
                 <a:ea typeface="Microsoft YaHei"/>
                 <a:cs typeface="Microsoft YaHei"/>
               </a:rPr>
-              <a:t>异常保持 IMC</a:t>
+              <a:t>无合格候选则 IMC</a:t>
             </a:r>
           </a:p>
         </p:txBody>
@@ -9209,7 +9209,7 @@
           <p:cNvPr id="19" name="">
             <a:extLst xmlns:a="http://schemas.openxmlformats.org/drawingml/2006/main">
               <a:ext uri="{FF2B5EF4-FFF2-40B4-BE49-F238E27FC236}">
-                <a16:creationId xmlns:a16="http://schemas.microsoft.com/office/drawing/2014/main" id="{F94CB66D-909C-4DB4-8EC3-AEB89974E9DA}"/>
+                <a16:creationId xmlns:a16="http://schemas.microsoft.com/office/drawing/2014/main" id="{DB5767A5-D043-41B9-889E-B24F3EFB71D2}"/>
               </a:ext>
             </a:extLst>
           </p:cNvPr>
@@ -9244,7 +9244,7 @@
           <p:cNvPr id="20" name="">
             <a:extLst xmlns:a="http://schemas.openxmlformats.org/drawingml/2006/main">
               <a:ext uri="{FF2B5EF4-FFF2-40B4-BE49-F238E27FC236}">
-                <a16:creationId xmlns:a16="http://schemas.microsoft.com/office/drawing/2014/main" id="{7982083F-7D5D-4EA6-B730-DE295202077E}"/>
+                <a16:creationId xmlns:a16="http://schemas.microsoft.com/office/drawing/2014/main" id="{F0992986-58AB-4632-B300-A014BDF5049C}"/>
               </a:ext>
             </a:extLst>
           </p:cNvPr>
@@ -9302,7 +9302,7 @@
           <p:cNvPr id="21" name="">
             <a:extLst xmlns:a="http://schemas.openxmlformats.org/drawingml/2006/main">
               <a:ext uri="{FF2B5EF4-FFF2-40B4-BE49-F238E27FC236}">
-                <a16:creationId xmlns:a16="http://schemas.microsoft.com/office/drawing/2014/main" id="{42164CA0-3632-4909-80A2-D555E936D234}"/>
+                <a16:creationId xmlns:a16="http://schemas.microsoft.com/office/drawing/2014/main" id="{1832FCDF-2D54-4187-9A7E-7F28580B9E52}"/>
               </a:ext>
             </a:extLst>
           </p:cNvPr>
@@ -9350,7 +9350,7 @@
                 <a:ea typeface="Microsoft YaHei"/>
                 <a:cs typeface="Microsoft YaHei"/>
               </a:rPr>
-              <a:t>LLM 不输出实时容量，更不能直接控制压缩机</a:t>
+              <a:t>Agent 有试验编排权，但没有安全裁决权或压缩机写入权</a:t>
             </a:r>
           </a:p>
         </p:txBody>
@@ -9360,7 +9360,7 @@
           <p:cNvPr id="22" name="">
             <a:extLst xmlns:a="http://schemas.openxmlformats.org/drawingml/2006/main">
               <a:ext uri="{FF2B5EF4-FFF2-40B4-BE49-F238E27FC236}">
-                <a16:creationId xmlns:a16="http://schemas.microsoft.com/office/drawing/2014/main" id="{F5E25006-96D0-4CFC-BBF2-25A16C32D6FA}"/>
+                <a16:creationId xmlns:a16="http://schemas.microsoft.com/office/drawing/2014/main" id="{56A08EFC-6918-441C-9385-CFBBF587874D}"/>
               </a:ext>
             </a:extLst>
           </p:cNvPr>
@@ -9408,7 +9408,7 @@
                 <a:ea typeface="Microsoft YaHei"/>
                 <a:cs typeface="Microsoft YaHei"/>
               </a:rPr>
-              <a:t>无密钥时 replay 明确标为录制响应；云端使用 Responses API、严格 JSON Schema、store:false。</a:t>
+              <a:t>replay 是录制工具轨迹；OpenAI/Ollama 模式才会在本次运行中自主调用白名单工具。</a:t>
             </a:r>
           </a:p>
         </p:txBody>
@@ -9416,7 +9416,7 @@
     </p:spTree>
     <p:extLst>
       <p:ext uri="{BB962C8B-B14F-4D97-AF65-F5344CB8AC3E}">
-        <p14:creationId xmlns:p14="http://schemas.microsoft.com/office/powerpoint/2010/main" val="1722267327"/>
+        <p14:creationId xmlns:p14="http://schemas.microsoft.com/office/powerpoint/2010/main" val="1976949910"/>
       </p:ext>
     </p:extLst>
   </p:cSld>
@@ -9440,7 +9440,7 @@
           <p:cNvPr id="14" name="">
             <a:extLst xmlns:a="http://schemas.openxmlformats.org/drawingml/2006/main">
               <a:ext uri="{FF2B5EF4-FFF2-40B4-BE49-F238E27FC236}">
-                <a16:creationId xmlns:a16="http://schemas.microsoft.com/office/drawing/2014/main" id="{C25E56FC-B4D5-4EE9-B749-5E9312AA86DB}"/>
+                <a16:creationId xmlns:a16="http://schemas.microsoft.com/office/drawing/2014/main" id="{B59D8E0D-CBDA-4B85-9CE5-849FFF137333}"/>
               </a:ext>
             </a:extLst>
           </p:cNvPr>
@@ -9498,7 +9498,7 @@
           <p:cNvPr id="2" name="">
             <a:extLst xmlns:a="http://schemas.openxmlformats.org/drawingml/2006/main">
               <a:ext uri="{FF2B5EF4-FFF2-40B4-BE49-F238E27FC236}">
-                <a16:creationId xmlns:a16="http://schemas.microsoft.com/office/drawing/2014/main" id="{BD355636-2706-4AF2-AA83-A280A17155F6}"/>
+                <a16:creationId xmlns:a16="http://schemas.microsoft.com/office/drawing/2014/main" id="{5B4100CD-654C-46DB-AF85-7EE1A7CA425D}"/>
               </a:ext>
             </a:extLst>
           </p:cNvPr>
@@ -9546,7 +9546,7 @@
                 <a:ea typeface="Microsoft YaHei"/>
                 <a:cs typeface="Microsoft YaHei"/>
               </a:rPr>
-              <a:t>LLM 不进实时环：慢、不可确定、可能断网</a:t>
+              <a:t>Agent 不进实时环：它只编排上位机试验</a:t>
             </a:r>
           </a:p>
         </p:txBody>
@@ -9556,19 +9556,19 @@
           <p:cNvPr id="3" name="">
             <a:extLst xmlns:a="http://schemas.openxmlformats.org/drawingml/2006/main">
               <a:ext uri="{FF2B5EF4-FFF2-40B4-BE49-F238E27FC236}">
-                <a16:creationId xmlns:a16="http://schemas.microsoft.com/office/drawing/2014/main" id="{C3B25C7C-B879-4620-8AF3-5E47660B0546}"/>
-              </a:ext>
-            </a:extLst>
-          </p:cNvPr>
-          <p:cNvSpPr>
-            <a:spLocks xmlns:a="http://schemas.openxmlformats.org/drawingml/2006/main" noGrp="1"/>
-          </p:cNvSpPr>
-          <p:nvPr/>
-        </p:nvSpPr>
-        <p:spPr>
-          <a:xfrm xmlns:a="http://schemas.openxmlformats.org/drawingml/2006/main">
-            <a:off x="11239500" y="6334125"/>
-            <a:ext cx="552450" cy="190500"/>
+                <a16:creationId xmlns:a16="http://schemas.microsoft.com/office/drawing/2014/main" id="{FCA40021-B762-43D9-88B4-76CEE903C338}"/>
+              </a:ext>
+            </a:extLst>
+          </p:cNvPr>
+          <p:cNvSpPr>
+            <a:spLocks xmlns:a="http://schemas.openxmlformats.org/drawingml/2006/main" noGrp="1"/>
+          </p:cNvSpPr>
+          <p:nvPr/>
+        </p:nvSpPr>
+        <p:spPr>
+          <a:xfrm xmlns:a="http://schemas.openxmlformats.org/drawingml/2006/main">
+            <a:off x="10953750" y="6334125"/>
+            <a:ext cx="838200" cy="190500"/>
           </a:xfrm>
           <a:prstGeom xmlns:a="http://schemas.openxmlformats.org/drawingml/2006/main" prst="rect">
             <a:avLst/>
@@ -9614,7 +9614,7 @@
           <p:cNvPr id="4" name="">
             <a:extLst xmlns:a="http://schemas.openxmlformats.org/drawingml/2006/main">
               <a:ext uri="{FF2B5EF4-FFF2-40B4-BE49-F238E27FC236}">
-                <a16:creationId xmlns:a16="http://schemas.microsoft.com/office/drawing/2014/main" id="{85FDA37D-F696-4B80-A2DA-777AF14C9997}"/>
+                <a16:creationId xmlns:a16="http://schemas.microsoft.com/office/drawing/2014/main" id="{136CB986-6BF3-4AD5-8DF8-78E375A4A56E}"/>
               </a:ext>
             </a:extLst>
           </p:cNvPr>
@@ -9649,7 +9649,7 @@
           <p:cNvPr id="5" name="">
             <a:extLst xmlns:a="http://schemas.openxmlformats.org/drawingml/2006/main">
               <a:ext uri="{FF2B5EF4-FFF2-40B4-BE49-F238E27FC236}">
-                <a16:creationId xmlns:a16="http://schemas.microsoft.com/office/drawing/2014/main" id="{E99DE24D-DD9D-46CE-8C9F-AA6C5C255D8A}"/>
+                <a16:creationId xmlns:a16="http://schemas.microsoft.com/office/drawing/2014/main" id="{6D0CF43F-6623-4472-B74F-E15B5A2F879E}"/>
               </a:ext>
             </a:extLst>
           </p:cNvPr>
@@ -9707,7 +9707,7 @@
           <p:cNvPr id="6" name="">
             <a:extLst xmlns:a="http://schemas.openxmlformats.org/drawingml/2006/main">
               <a:ext uri="{FF2B5EF4-FFF2-40B4-BE49-F238E27FC236}">
-                <a16:creationId xmlns:a16="http://schemas.microsoft.com/office/drawing/2014/main" id="{D73DD795-A5AC-4C22-9092-0F1BA57F7D25}"/>
+                <a16:creationId xmlns:a16="http://schemas.microsoft.com/office/drawing/2014/main" id="{81DBAFE7-8AA1-4E6D-8753-BE77412FD2D5}"/>
               </a:ext>
             </a:extLst>
           </p:cNvPr>
@@ -9788,7 +9788,7 @@
           <p:cNvPr id="7" name="">
             <a:extLst xmlns:a="http://schemas.openxmlformats.org/drawingml/2006/main">
               <a:ext uri="{FF2B5EF4-FFF2-40B4-BE49-F238E27FC236}">
-                <a16:creationId xmlns:a16="http://schemas.microsoft.com/office/drawing/2014/main" id="{381F10A5-84F7-4F77-987E-86CAF01B51D7}"/>
+                <a16:creationId xmlns:a16="http://schemas.microsoft.com/office/drawing/2014/main" id="{37099768-519C-4F27-BAAD-409D747DA85C}"/>
               </a:ext>
             </a:extLst>
           </p:cNvPr>
@@ -9823,7 +9823,7 @@
           <p:cNvPr id="8" name="">
             <a:extLst xmlns:a="http://schemas.openxmlformats.org/drawingml/2006/main">
               <a:ext uri="{FF2B5EF4-FFF2-40B4-BE49-F238E27FC236}">
-                <a16:creationId xmlns:a16="http://schemas.microsoft.com/office/drawing/2014/main" id="{A03644CB-574A-4516-A1DD-67C8FC051616}"/>
+                <a16:creationId xmlns:a16="http://schemas.microsoft.com/office/drawing/2014/main" id="{3ABD863A-C598-4F89-85CB-A421FE937BD8}"/>
               </a:ext>
             </a:extLst>
           </p:cNvPr>
@@ -9871,7 +9871,7 @@
                 <a:ea typeface="Microsoft YaHei"/>
                 <a:cs typeface="Microsoft YaHei"/>
               </a:rPr>
-              <a:t>秒到分钟上位机层</a:t>
+              <a:t>秒到分钟 Agent 层</a:t>
             </a:r>
           </a:p>
         </p:txBody>
@@ -9881,7 +9881,7 @@
           <p:cNvPr id="9" name="">
             <a:extLst xmlns:a="http://schemas.openxmlformats.org/drawingml/2006/main">
               <a:ext uri="{FF2B5EF4-FFF2-40B4-BE49-F238E27FC236}">
-                <a16:creationId xmlns:a16="http://schemas.microsoft.com/office/drawing/2014/main" id="{8437D0D3-37AD-4F29-A7F5-5ABB1E8CA99D}"/>
+                <a16:creationId xmlns:a16="http://schemas.microsoft.com/office/drawing/2014/main" id="{9DE3B17A-24BF-4CFA-B5FF-BA64455BB084}"/>
               </a:ext>
             </a:extLst>
           </p:cNvPr>
@@ -9929,7 +9929,7 @@
                 <a:ea typeface="Microsoft YaHei"/>
                 <a:cs typeface="Microsoft YaHei"/>
               </a:rPr>
-              <a:t>LLM 诊断 → 候选增益 → 多场景仿真</a:t>
+              <a:t>查看历史 → 请求候选仿真 → 读取门控结果 → 继续或停止</a:t>
             </a:r>
           </a:p>
           <a:p xmlns:a="http://schemas.openxmlformats.org/drawingml/2006/main">
@@ -9952,7 +9952,7 @@
                 <a:ea typeface="Microsoft YaHei"/>
                 <a:cs typeface="Microsoft YaHei"/>
               </a:rPr>
-              <a:t>允许超时，但无权越过安全门</a:t>
+              <a:t>只调用白名单工具；宿主执行并裁决</a:t>
             </a:r>
           </a:p>
         </p:txBody>
@@ -9962,7 +9962,7 @@
           <p:cNvPr id="10" name="">
             <a:extLst xmlns:a="http://schemas.openxmlformats.org/drawingml/2006/main">
               <a:ext uri="{FF2B5EF4-FFF2-40B4-BE49-F238E27FC236}">
-                <a16:creationId xmlns:a16="http://schemas.microsoft.com/office/drawing/2014/main" id="{6AC84F4C-6314-45AC-8360-D4AEC3628A76}"/>
+                <a16:creationId xmlns:a16="http://schemas.microsoft.com/office/drawing/2014/main" id="{7ED02E1D-1891-4853-B5FE-EB64400555DD}"/>
               </a:ext>
             </a:extLst>
           </p:cNvPr>
@@ -9995,7 +9995,7 @@
           <p:cNvPr id="11" name="">
             <a:extLst xmlns:a="http://schemas.openxmlformats.org/drawingml/2006/main">
               <a:ext uri="{FF2B5EF4-FFF2-40B4-BE49-F238E27FC236}">
-                <a16:creationId xmlns:a16="http://schemas.microsoft.com/office/drawing/2014/main" id="{8FA52FF7-5C14-45E3-8A41-0C442F80EC26}"/>
+                <a16:creationId xmlns:a16="http://schemas.microsoft.com/office/drawing/2014/main" id="{7651CC41-489F-47B3-BE7F-C7F56579353B}"/>
               </a:ext>
             </a:extLst>
           </p:cNvPr>
@@ -10053,7 +10053,7 @@
           <p:cNvPr id="12" name="">
             <a:extLst xmlns:a="http://schemas.openxmlformats.org/drawingml/2006/main">
               <a:ext uri="{FF2B5EF4-FFF2-40B4-BE49-F238E27FC236}">
-                <a16:creationId xmlns:a16="http://schemas.microsoft.com/office/drawing/2014/main" id="{B5F3BCCA-4A90-4B5D-B16B-EC0C04F3A117}"/>
+                <a16:creationId xmlns:a16="http://schemas.microsoft.com/office/drawing/2014/main" id="{A37209A7-2179-4173-B9BC-5F7A531FE456}"/>
               </a:ext>
             </a:extLst>
           </p:cNvPr>
@@ -10088,7 +10088,7 @@
           <p:cNvPr id="13" name="">
             <a:extLst xmlns:a="http://schemas.openxmlformats.org/drawingml/2006/main">
               <a:ext uri="{FF2B5EF4-FFF2-40B4-BE49-F238E27FC236}">
-                <a16:creationId xmlns:a16="http://schemas.microsoft.com/office/drawing/2014/main" id="{EEF9CAF7-57A5-4FB3-8264-F702B4B0423A}"/>
+                <a16:creationId xmlns:a16="http://schemas.microsoft.com/office/drawing/2014/main" id="{60A3B8DB-0850-41B6-9EFC-A0189533BF14}"/>
               </a:ext>
             </a:extLst>
           </p:cNvPr>
@@ -10113,7 +10113,7 @@
         </p:spPr>
         <p:txBody>
           <a:bodyPr xmlns:a="http://schemas.openxmlformats.org/drawingml/2006/main" lIns="0" tIns="0" rIns="0" bIns="0" anchor="t">
-            <a:normAutofit fontScale="96020"/>
+            <a:normAutofit fontScale="98837"/>
           </a:bodyPr>
           <a:lstStyle xmlns:a="http://schemas.openxmlformats.org/drawingml/2006/main"/>
           <a:p xmlns:a="http://schemas.openxmlformats.org/drawingml/2006/main">
@@ -10136,7 +10136,7 @@
                 <a:ea typeface="Microsoft YaHei"/>
                 <a:cs typeface="Microsoft YaHei"/>
               </a:rPr>
-              <a:t>超时 / 无密钥 / 非法 JSON / NaN / 极端增益 / 仿真不稳定  ⇒  保持 IMC</a:t>
+              <a:t>超时 / 无密钥 / 非法工具 / NaN / 预算耗尽 / 仿真不稳定  ⇒  保持 IMC</a:t>
             </a:r>
           </a:p>
         </p:txBody>
@@ -10144,7 +10144,7 @@
     </p:spTree>
     <p:extLst>
       <p:ext uri="{BB962C8B-B14F-4D97-AF65-F5344CB8AC3E}">
-        <p14:creationId xmlns:p14="http://schemas.microsoft.com/office/powerpoint/2010/main" val="303942940"/>
+        <p14:creationId xmlns:p14="http://schemas.microsoft.com/office/powerpoint/2010/main" val="1045278045"/>
       </p:ext>
     </p:extLst>
   </p:cSld>
@@ -10168,7 +10168,7 @@
           <p:cNvPr id="33" name="">
             <a:extLst xmlns:a="http://schemas.openxmlformats.org/drawingml/2006/main">
               <a:ext uri="{FF2B5EF4-FFF2-40B4-BE49-F238E27FC236}">
-                <a16:creationId xmlns:a16="http://schemas.microsoft.com/office/drawing/2014/main" id="{83FC3F03-467D-42F0-93FF-9C3409B21D7B}"/>
+                <a16:creationId xmlns:a16="http://schemas.microsoft.com/office/drawing/2014/main" id="{A5BB1AE4-4D87-40B2-B740-CACEBBEDF08C}"/>
               </a:ext>
             </a:extLst>
           </p:cNvPr>
@@ -10226,7 +10226,7 @@
           <p:cNvPr id="2" name="">
             <a:extLst xmlns:a="http://schemas.openxmlformats.org/drawingml/2006/main">
               <a:ext uri="{FF2B5EF4-FFF2-40B4-BE49-F238E27FC236}">
-                <a16:creationId xmlns:a16="http://schemas.microsoft.com/office/drawing/2014/main" id="{2D780225-8B5E-40EA-A386-BCA783D9921B}"/>
+                <a16:creationId xmlns:a16="http://schemas.microsoft.com/office/drawing/2014/main" id="{DF3BA077-6F84-4AC8-9417-A3F3D519F163}"/>
               </a:ext>
             </a:extLst>
           </p:cNvPr>
@@ -10274,7 +10274,7 @@
                 <a:ea typeface="Microsoft YaHei"/>
                 <a:cs typeface="Microsoft YaHei"/>
               </a:rPr>
-              <a:t>ESP32 用三个节拍，把实时 PI 与 AI 调度分开</a:t>
+              <a:t>ESP32 三个节拍分开实时 PI 与 AI 调度</a:t>
             </a:r>
           </a:p>
         </p:txBody>
@@ -10284,19 +10284,19 @@
           <p:cNvPr id="3" name="">
             <a:extLst xmlns:a="http://schemas.openxmlformats.org/drawingml/2006/main">
               <a:ext uri="{FF2B5EF4-FFF2-40B4-BE49-F238E27FC236}">
-                <a16:creationId xmlns:a16="http://schemas.microsoft.com/office/drawing/2014/main" id="{7F316861-E8EB-4C3B-9EA6-6C0F62E77F4C}"/>
-              </a:ext>
-            </a:extLst>
-          </p:cNvPr>
-          <p:cNvSpPr>
-            <a:spLocks xmlns:a="http://schemas.openxmlformats.org/drawingml/2006/main" noGrp="1"/>
-          </p:cNvSpPr>
-          <p:nvPr/>
-        </p:nvSpPr>
-        <p:spPr>
-          <a:xfrm xmlns:a="http://schemas.openxmlformats.org/drawingml/2006/main">
-            <a:off x="11239500" y="6334125"/>
-            <a:ext cx="552450" cy="190500"/>
+                <a16:creationId xmlns:a16="http://schemas.microsoft.com/office/drawing/2014/main" id="{F71C81C4-6842-4425-A49A-1A19DBF11904}"/>
+              </a:ext>
+            </a:extLst>
+          </p:cNvPr>
+          <p:cNvSpPr>
+            <a:spLocks xmlns:a="http://schemas.openxmlformats.org/drawingml/2006/main" noGrp="1"/>
+          </p:cNvSpPr>
+          <p:nvPr/>
+        </p:nvSpPr>
+        <p:spPr>
+          <a:xfrm xmlns:a="http://schemas.openxmlformats.org/drawingml/2006/main">
+            <a:off x="10953750" y="6334125"/>
+            <a:ext cx="838200" cy="190500"/>
           </a:xfrm>
           <a:prstGeom xmlns:a="http://schemas.openxmlformats.org/drawingml/2006/main" prst="rect">
             <a:avLst/>
@@ -10342,7 +10342,7 @@
           <p:cNvPr id="4" name="">
             <a:extLst xmlns:a="http://schemas.openxmlformats.org/drawingml/2006/main">
               <a:ext uri="{FF2B5EF4-FFF2-40B4-BE49-F238E27FC236}">
-                <a16:creationId xmlns:a16="http://schemas.microsoft.com/office/drawing/2014/main" id="{0554A7DA-BC1C-4297-91A2-2AB40EC73AEF}"/>
+                <a16:creationId xmlns:a16="http://schemas.microsoft.com/office/drawing/2014/main" id="{CF2C29C1-2647-41FD-A081-EC71A1904A4E}"/>
               </a:ext>
             </a:extLst>
           </p:cNvPr>
@@ -10400,7 +10400,7 @@
           <p:cNvPr id="5" name="">
             <a:extLst xmlns:a="http://schemas.openxmlformats.org/drawingml/2006/main">
               <a:ext uri="{FF2B5EF4-FFF2-40B4-BE49-F238E27FC236}">
-                <a16:creationId xmlns:a16="http://schemas.microsoft.com/office/drawing/2014/main" id="{F9073618-EEC0-408F-979F-F5E922F8598B}"/>
+                <a16:creationId xmlns:a16="http://schemas.microsoft.com/office/drawing/2014/main" id="{AFACAB32-9E6A-4D6E-B51E-54142F3D6E50}"/>
               </a:ext>
             </a:extLst>
           </p:cNvPr>
@@ -10433,7 +10433,7 @@
           <p:cNvPr id="6" name="">
             <a:extLst xmlns:a="http://schemas.openxmlformats.org/drawingml/2006/main">
               <a:ext uri="{FF2B5EF4-FFF2-40B4-BE49-F238E27FC236}">
-                <a16:creationId xmlns:a16="http://schemas.microsoft.com/office/drawing/2014/main" id="{F16FE8D7-4BA2-4CA4-9F2F-382E604FF627}"/>
+                <a16:creationId xmlns:a16="http://schemas.microsoft.com/office/drawing/2014/main" id="{7B73C7D3-A5A9-4616-8495-3DB4D140C20B}"/>
               </a:ext>
             </a:extLst>
           </p:cNvPr>
@@ -10466,7 +10466,7 @@
           <p:cNvPr id="7" name="">
             <a:extLst xmlns:a="http://schemas.openxmlformats.org/drawingml/2006/main">
               <a:ext uri="{FF2B5EF4-FFF2-40B4-BE49-F238E27FC236}">
-                <a16:creationId xmlns:a16="http://schemas.microsoft.com/office/drawing/2014/main" id="{7959698A-6FDB-40C4-81C1-A1B2DC9AD4F7}"/>
+                <a16:creationId xmlns:a16="http://schemas.microsoft.com/office/drawing/2014/main" id="{CBE316BE-B748-4AF6-A834-88079DDE7976}"/>
               </a:ext>
             </a:extLst>
           </p:cNvPr>
@@ -10499,7 +10499,7 @@
           <p:cNvPr id="8" name="">
             <a:extLst xmlns:a="http://schemas.openxmlformats.org/drawingml/2006/main">
               <a:ext uri="{FF2B5EF4-FFF2-40B4-BE49-F238E27FC236}">
-                <a16:creationId xmlns:a16="http://schemas.microsoft.com/office/drawing/2014/main" id="{9BA4F8C5-FE14-4F75-B763-42E37E2EB875}"/>
+                <a16:creationId xmlns:a16="http://schemas.microsoft.com/office/drawing/2014/main" id="{FD046AB0-97A8-4526-9C0A-6C9944740639}"/>
               </a:ext>
             </a:extLst>
           </p:cNvPr>
@@ -10532,7 +10532,7 @@
           <p:cNvPr id="9" name="">
             <a:extLst xmlns:a="http://schemas.openxmlformats.org/drawingml/2006/main">
               <a:ext uri="{FF2B5EF4-FFF2-40B4-BE49-F238E27FC236}">
-                <a16:creationId xmlns:a16="http://schemas.microsoft.com/office/drawing/2014/main" id="{61C750FF-65AB-4F0D-A417-0BAE75417AAD}"/>
+                <a16:creationId xmlns:a16="http://schemas.microsoft.com/office/drawing/2014/main" id="{1B07E682-FC8C-4422-BD97-3CD66AA86C6A}"/>
               </a:ext>
             </a:extLst>
           </p:cNvPr>
@@ -10565,7 +10565,7 @@
           <p:cNvPr id="10" name="">
             <a:extLst xmlns:a="http://schemas.openxmlformats.org/drawingml/2006/main">
               <a:ext uri="{FF2B5EF4-FFF2-40B4-BE49-F238E27FC236}">
-                <a16:creationId xmlns:a16="http://schemas.microsoft.com/office/drawing/2014/main" id="{88733BCB-D6F0-482A-920C-8354787909BD}"/>
+                <a16:creationId xmlns:a16="http://schemas.microsoft.com/office/drawing/2014/main" id="{1C70631D-E29E-40B5-BFBE-ABF749FE8B11}"/>
               </a:ext>
             </a:extLst>
           </p:cNvPr>
@@ -10598,7 +10598,7 @@
           <p:cNvPr id="11" name="">
             <a:extLst xmlns:a="http://schemas.openxmlformats.org/drawingml/2006/main">
               <a:ext uri="{FF2B5EF4-FFF2-40B4-BE49-F238E27FC236}">
-                <a16:creationId xmlns:a16="http://schemas.microsoft.com/office/drawing/2014/main" id="{C4B7B366-62B5-4098-A245-15D3CCFDFF9F}"/>
+                <a16:creationId xmlns:a16="http://schemas.microsoft.com/office/drawing/2014/main" id="{720751A5-B31A-4CFF-A3DE-A22F846C24ED}"/>
               </a:ext>
             </a:extLst>
           </p:cNvPr>
@@ -10631,7 +10631,7 @@
           <p:cNvPr id="12" name="">
             <a:extLst xmlns:a="http://schemas.openxmlformats.org/drawingml/2006/main">
               <a:ext uri="{FF2B5EF4-FFF2-40B4-BE49-F238E27FC236}">
-                <a16:creationId xmlns:a16="http://schemas.microsoft.com/office/drawing/2014/main" id="{80B6E6C8-9D50-48DE-9D2C-712866A0F69B}"/>
+                <a16:creationId xmlns:a16="http://schemas.microsoft.com/office/drawing/2014/main" id="{CC7DBC84-69FD-44CF-A96A-78BC4244F437}"/>
               </a:ext>
             </a:extLst>
           </p:cNvPr>
@@ -10664,7 +10664,7 @@
           <p:cNvPr id="13" name="">
             <a:extLst xmlns:a="http://schemas.openxmlformats.org/drawingml/2006/main">
               <a:ext uri="{FF2B5EF4-FFF2-40B4-BE49-F238E27FC236}">
-                <a16:creationId xmlns:a16="http://schemas.microsoft.com/office/drawing/2014/main" id="{1CAC9FD7-DDA7-43F2-80B7-6689BF6B6168}"/>
+                <a16:creationId xmlns:a16="http://schemas.microsoft.com/office/drawing/2014/main" id="{99A2B1CB-3CBD-4F40-971D-66D610319580}"/>
               </a:ext>
             </a:extLst>
           </p:cNvPr>
@@ -10697,7 +10697,7 @@
           <p:cNvPr id="14" name="">
             <a:extLst xmlns:a="http://schemas.openxmlformats.org/drawingml/2006/main">
               <a:ext uri="{FF2B5EF4-FFF2-40B4-BE49-F238E27FC236}">
-                <a16:creationId xmlns:a16="http://schemas.microsoft.com/office/drawing/2014/main" id="{7FD6ABBF-598D-407D-A7E3-726074521C80}"/>
+                <a16:creationId xmlns:a16="http://schemas.microsoft.com/office/drawing/2014/main" id="{6B172FD4-22CD-4BD9-974B-74557B143176}"/>
               </a:ext>
             </a:extLst>
           </p:cNvPr>
@@ -10730,7 +10730,7 @@
           <p:cNvPr id="15" name="">
             <a:extLst xmlns:a="http://schemas.openxmlformats.org/drawingml/2006/main">
               <a:ext uri="{FF2B5EF4-FFF2-40B4-BE49-F238E27FC236}">
-                <a16:creationId xmlns:a16="http://schemas.microsoft.com/office/drawing/2014/main" id="{6B742DC7-90BA-4711-A1C4-FAAAF7C32D2C}"/>
+                <a16:creationId xmlns:a16="http://schemas.microsoft.com/office/drawing/2014/main" id="{1BF32E50-24CC-4D75-A828-3F38DBA94369}"/>
               </a:ext>
             </a:extLst>
           </p:cNvPr>
@@ -10788,7 +10788,7 @@
           <p:cNvPr id="16" name="">
             <a:extLst xmlns:a="http://schemas.openxmlformats.org/drawingml/2006/main">
               <a:ext uri="{FF2B5EF4-FFF2-40B4-BE49-F238E27FC236}">
-                <a16:creationId xmlns:a16="http://schemas.microsoft.com/office/drawing/2014/main" id="{65968973-DEBC-4EBA-A05A-DA2133439C2F}"/>
+                <a16:creationId xmlns:a16="http://schemas.microsoft.com/office/drawing/2014/main" id="{828B9B95-3FDA-459B-8B41-068A40086201}"/>
               </a:ext>
             </a:extLst>
           </p:cNvPr>
@@ -10846,7 +10846,7 @@
           <p:cNvPr id="17" name="">
             <a:extLst xmlns:a="http://schemas.openxmlformats.org/drawingml/2006/main">
               <a:ext uri="{FF2B5EF4-FFF2-40B4-BE49-F238E27FC236}">
-                <a16:creationId xmlns:a16="http://schemas.microsoft.com/office/drawing/2014/main" id="{67A0B3DB-B6DE-41E6-8C3F-9FFB977B086F}"/>
+                <a16:creationId xmlns:a16="http://schemas.microsoft.com/office/drawing/2014/main" id="{ED82599B-D45B-4439-9AC2-ABFC586E98AA}"/>
               </a:ext>
             </a:extLst>
           </p:cNvPr>
@@ -10904,7 +10904,7 @@
           <p:cNvPr id="18" name="">
             <a:extLst xmlns:a="http://schemas.openxmlformats.org/drawingml/2006/main">
               <a:ext uri="{FF2B5EF4-FFF2-40B4-BE49-F238E27FC236}">
-                <a16:creationId xmlns:a16="http://schemas.microsoft.com/office/drawing/2014/main" id="{9552050A-35F6-49C3-A602-CF0688BE39A6}"/>
+                <a16:creationId xmlns:a16="http://schemas.microsoft.com/office/drawing/2014/main" id="{A0E5337D-6FE5-4316-9434-F90202925C89}"/>
               </a:ext>
             </a:extLst>
           </p:cNvPr>
@@ -10937,7 +10937,7 @@
           <p:cNvPr id="19" name="">
             <a:extLst xmlns:a="http://schemas.openxmlformats.org/drawingml/2006/main">
               <a:ext uri="{FF2B5EF4-FFF2-40B4-BE49-F238E27FC236}">
-                <a16:creationId xmlns:a16="http://schemas.microsoft.com/office/drawing/2014/main" id="{A9445340-77F3-491E-BA69-BA12C679C9C3}"/>
+                <a16:creationId xmlns:a16="http://schemas.microsoft.com/office/drawing/2014/main" id="{C2B5DC22-145A-4B61-A5E2-AE0F1BBE2973}"/>
               </a:ext>
             </a:extLst>
           </p:cNvPr>
@@ -10970,7 +10970,7 @@
           <p:cNvPr id="20" name="">
             <a:extLst xmlns:a="http://schemas.openxmlformats.org/drawingml/2006/main">
               <a:ext uri="{FF2B5EF4-FFF2-40B4-BE49-F238E27FC236}">
-                <a16:creationId xmlns:a16="http://schemas.microsoft.com/office/drawing/2014/main" id="{AFFAEBD6-BAA3-4938-9CA9-E4997BFBE0A9}"/>
+                <a16:creationId xmlns:a16="http://schemas.microsoft.com/office/drawing/2014/main" id="{5A3DDE38-4737-4697-A03E-DA5826B15586}"/>
               </a:ext>
             </a:extLst>
           </p:cNvPr>
@@ -11003,7 +11003,7 @@
           <p:cNvPr id="21" name="">
             <a:extLst xmlns:a="http://schemas.openxmlformats.org/drawingml/2006/main">
               <a:ext uri="{FF2B5EF4-FFF2-40B4-BE49-F238E27FC236}">
-                <a16:creationId xmlns:a16="http://schemas.microsoft.com/office/drawing/2014/main" id="{FC01D5D0-CCF5-4718-9A6D-8A017569314D}"/>
+                <a16:creationId xmlns:a16="http://schemas.microsoft.com/office/drawing/2014/main" id="{94324DBE-B7F5-4033-A0E9-6A2E56C55AB2}"/>
               </a:ext>
             </a:extLst>
           </p:cNvPr>
@@ -11036,7 +11036,7 @@
           <p:cNvPr id="22" name="">
             <a:extLst xmlns:a="http://schemas.openxmlformats.org/drawingml/2006/main">
               <a:ext uri="{FF2B5EF4-FFF2-40B4-BE49-F238E27FC236}">
-                <a16:creationId xmlns:a16="http://schemas.microsoft.com/office/drawing/2014/main" id="{3F5A9C1F-A1F9-458E-A066-E726D488AE70}"/>
+                <a16:creationId xmlns:a16="http://schemas.microsoft.com/office/drawing/2014/main" id="{3161E336-5BDF-4FDE-9C97-7E6858EBCB48}"/>
               </a:ext>
             </a:extLst>
           </p:cNvPr>
@@ -11069,7 +11069,7 @@
           <p:cNvPr id="23" name="">
             <a:extLst xmlns:a="http://schemas.openxmlformats.org/drawingml/2006/main">
               <a:ext uri="{FF2B5EF4-FFF2-40B4-BE49-F238E27FC236}">
-                <a16:creationId xmlns:a16="http://schemas.microsoft.com/office/drawing/2014/main" id="{7BB9CEE5-C678-4CB3-B843-E3B54BD5C226}"/>
+                <a16:creationId xmlns:a16="http://schemas.microsoft.com/office/drawing/2014/main" id="{B7005333-CA8B-400B-8CD6-83311D83831D}"/>
               </a:ext>
             </a:extLst>
           </p:cNvPr>
@@ -11102,7 +11102,7 @@
           <p:cNvPr id="24" name="">
             <a:extLst xmlns:a="http://schemas.openxmlformats.org/drawingml/2006/main">
               <a:ext uri="{FF2B5EF4-FFF2-40B4-BE49-F238E27FC236}">
-                <a16:creationId xmlns:a16="http://schemas.microsoft.com/office/drawing/2014/main" id="{F5BFC187-7EE4-4761-8985-12CCE73401A2}"/>
+                <a16:creationId xmlns:a16="http://schemas.microsoft.com/office/drawing/2014/main" id="{EAABB2FC-14AE-4732-A04A-C38A4127A2E8}"/>
               </a:ext>
             </a:extLst>
           </p:cNvPr>
@@ -11160,7 +11160,7 @@
           <p:cNvPr id="25" name="">
             <a:extLst xmlns:a="http://schemas.openxmlformats.org/drawingml/2006/main">
               <a:ext uri="{FF2B5EF4-FFF2-40B4-BE49-F238E27FC236}">
-                <a16:creationId xmlns:a16="http://schemas.microsoft.com/office/drawing/2014/main" id="{89B8EB50-EF90-4A70-9586-5BB14E76B7D5}"/>
+                <a16:creationId xmlns:a16="http://schemas.microsoft.com/office/drawing/2014/main" id="{56E00DD5-9AD0-4B2B-BA6F-C470335C6311}"/>
               </a:ext>
             </a:extLst>
           </p:cNvPr>
@@ -11218,7 +11218,7 @@
           <p:cNvPr id="26" name="">
             <a:extLst xmlns:a="http://schemas.openxmlformats.org/drawingml/2006/main">
               <a:ext uri="{FF2B5EF4-FFF2-40B4-BE49-F238E27FC236}">
-                <a16:creationId xmlns:a16="http://schemas.microsoft.com/office/drawing/2014/main" id="{F0D09476-0699-4DB6-A758-E868AE9EA0A0}"/>
+                <a16:creationId xmlns:a16="http://schemas.microsoft.com/office/drawing/2014/main" id="{AD9AECFC-363F-403F-BC3D-C6578835F231}"/>
               </a:ext>
             </a:extLst>
           </p:cNvPr>
@@ -11276,7 +11276,7 @@
           <p:cNvPr id="27" name="">
             <a:extLst xmlns:a="http://schemas.openxmlformats.org/drawingml/2006/main">
               <a:ext uri="{FF2B5EF4-FFF2-40B4-BE49-F238E27FC236}">
-                <a16:creationId xmlns:a16="http://schemas.microsoft.com/office/drawing/2014/main" id="{365F6EBB-A1E8-4011-B0BB-32E53DBCBD40}"/>
+                <a16:creationId xmlns:a16="http://schemas.microsoft.com/office/drawing/2014/main" id="{171E6B19-7108-43BC-B937-7657B7CB901A}"/>
               </a:ext>
             </a:extLst>
           </p:cNvPr>
@@ -11309,7 +11309,7 @@
           <p:cNvPr id="28" name="">
             <a:extLst xmlns:a="http://schemas.openxmlformats.org/drawingml/2006/main">
               <a:ext uri="{FF2B5EF4-FFF2-40B4-BE49-F238E27FC236}">
-                <a16:creationId xmlns:a16="http://schemas.microsoft.com/office/drawing/2014/main" id="{41A3B6A2-E0F0-4DA0-B2A9-1DC71DF951EC}"/>
+                <a16:creationId xmlns:a16="http://schemas.microsoft.com/office/drawing/2014/main" id="{116AC66D-2CAA-4640-B0A6-6DFFB9E3F896}"/>
               </a:ext>
             </a:extLst>
           </p:cNvPr>
@@ -11342,7 +11342,7 @@
           <p:cNvPr id="29" name="">
             <a:extLst xmlns:a="http://schemas.openxmlformats.org/drawingml/2006/main">
               <a:ext uri="{FF2B5EF4-FFF2-40B4-BE49-F238E27FC236}">
-                <a16:creationId xmlns:a16="http://schemas.microsoft.com/office/drawing/2014/main" id="{53578FF1-4453-4682-A8CF-4056EA419B3D}"/>
+                <a16:creationId xmlns:a16="http://schemas.microsoft.com/office/drawing/2014/main" id="{7CBB1DDB-703B-4492-9AE9-FC85E1BBCB63}"/>
               </a:ext>
             </a:extLst>
           </p:cNvPr>
@@ -11375,7 +11375,7 @@
           <p:cNvPr id="30" name="">
             <a:extLst xmlns:a="http://schemas.openxmlformats.org/drawingml/2006/main">
               <a:ext uri="{FF2B5EF4-FFF2-40B4-BE49-F238E27FC236}">
-                <a16:creationId xmlns:a16="http://schemas.microsoft.com/office/drawing/2014/main" id="{55B6F926-E9D2-41DF-A43C-FAD7568706E0}"/>
+                <a16:creationId xmlns:a16="http://schemas.microsoft.com/office/drawing/2014/main" id="{95171717-14A3-4E09-918B-8731C32C260A}"/>
               </a:ext>
             </a:extLst>
           </p:cNvPr>
@@ -11408,7 +11408,7 @@
           <p:cNvPr id="31" name="">
             <a:extLst xmlns:a="http://schemas.openxmlformats.org/drawingml/2006/main">
               <a:ext uri="{FF2B5EF4-FFF2-40B4-BE49-F238E27FC236}">
-                <a16:creationId xmlns:a16="http://schemas.microsoft.com/office/drawing/2014/main" id="{40C18C7B-FF06-427D-9E8B-8B779896AF02}"/>
+                <a16:creationId xmlns:a16="http://schemas.microsoft.com/office/drawing/2014/main" id="{EB8D6EAB-9761-4EBC-8167-36C2E3112BC5}"/>
               </a:ext>
             </a:extLst>
           </p:cNvPr>
@@ -11466,7 +11466,7 @@
           <p:cNvPr id="32" name="">
             <a:extLst xmlns:a="http://schemas.openxmlformats.org/drawingml/2006/main">
               <a:ext uri="{FF2B5EF4-FFF2-40B4-BE49-F238E27FC236}">
-                <a16:creationId xmlns:a16="http://schemas.microsoft.com/office/drawing/2014/main" id="{ED1B8BC5-7662-4E8B-8329-38D76733BEA4}"/>
+                <a16:creationId xmlns:a16="http://schemas.microsoft.com/office/drawing/2014/main" id="{67BB43C3-DAB5-4948-B889-94019DFC10F8}"/>
               </a:ext>
             </a:extLst>
           </p:cNvPr>
@@ -11522,7 +11522,7 @@
     </p:spTree>
     <p:extLst>
       <p:ext uri="{BB962C8B-B14F-4D97-AF65-F5344CB8AC3E}">
-        <p14:creationId xmlns:p14="http://schemas.microsoft.com/office/powerpoint/2010/main" val="1731569190"/>
+        <p14:creationId xmlns:p14="http://schemas.microsoft.com/office/powerpoint/2010/main" val="334269616"/>
       </p:ext>
     </p:extLst>
   </p:cSld>
@@ -11546,7 +11546,7 @@
           <p:cNvPr id="30" name="">
             <a:extLst xmlns:a="http://schemas.openxmlformats.org/drawingml/2006/main">
               <a:ext uri="{FF2B5EF4-FFF2-40B4-BE49-F238E27FC236}">
-                <a16:creationId xmlns:a16="http://schemas.microsoft.com/office/drawing/2014/main" id="{245B1E9F-EC53-41E5-B650-AA089A5BB684}"/>
+                <a16:creationId xmlns:a16="http://schemas.microsoft.com/office/drawing/2014/main" id="{4437B7D8-894E-4519-95EF-414E8FA51449}"/>
               </a:ext>
             </a:extLst>
           </p:cNvPr>
@@ -11604,7 +11604,7 @@
           <p:cNvPr id="2" name="">
             <a:extLst xmlns:a="http://schemas.openxmlformats.org/drawingml/2006/main">
               <a:ext uri="{FF2B5EF4-FFF2-40B4-BE49-F238E27FC236}">
-                <a16:creationId xmlns:a16="http://schemas.microsoft.com/office/drawing/2014/main" id="{F6DE6CC3-499B-4580-899A-4EE2D91F344F}"/>
+                <a16:creationId xmlns:a16="http://schemas.microsoft.com/office/drawing/2014/main" id="{67B1C389-1922-4410-BDA2-14CE36872A0A}"/>
               </a:ext>
             </a:extLst>
           </p:cNvPr>
@@ -11662,19 +11662,19 @@
           <p:cNvPr id="3" name="">
             <a:extLst xmlns:a="http://schemas.openxmlformats.org/drawingml/2006/main">
               <a:ext uri="{FF2B5EF4-FFF2-40B4-BE49-F238E27FC236}">
-                <a16:creationId xmlns:a16="http://schemas.microsoft.com/office/drawing/2014/main" id="{D4F58585-6F6E-45D1-AB2A-60EB92F92A73}"/>
-              </a:ext>
-            </a:extLst>
-          </p:cNvPr>
-          <p:cNvSpPr>
-            <a:spLocks xmlns:a="http://schemas.openxmlformats.org/drawingml/2006/main" noGrp="1"/>
-          </p:cNvSpPr>
-          <p:nvPr/>
-        </p:nvSpPr>
-        <p:spPr>
-          <a:xfrm xmlns:a="http://schemas.openxmlformats.org/drawingml/2006/main">
-            <a:off x="11239500" y="6334125"/>
-            <a:ext cx="552450" cy="190500"/>
+                <a16:creationId xmlns:a16="http://schemas.microsoft.com/office/drawing/2014/main" id="{7ED4DA2D-7DE8-41C1-8FCA-66D969CCCF81}"/>
+              </a:ext>
+            </a:extLst>
+          </p:cNvPr>
+          <p:cNvSpPr>
+            <a:spLocks xmlns:a="http://schemas.openxmlformats.org/drawingml/2006/main" noGrp="1"/>
+          </p:cNvSpPr>
+          <p:nvPr/>
+        </p:nvSpPr>
+        <p:spPr>
+          <a:xfrm xmlns:a="http://schemas.openxmlformats.org/drawingml/2006/main">
+            <a:off x="10953750" y="6334125"/>
+            <a:ext cx="838200" cy="190500"/>
           </a:xfrm>
           <a:prstGeom xmlns:a="http://schemas.openxmlformats.org/drawingml/2006/main" prst="rect">
             <a:avLst/>
@@ -11720,7 +11720,7 @@
           <p:cNvPr id="4" name="">
             <a:extLst xmlns:a="http://schemas.openxmlformats.org/drawingml/2006/main">
               <a:ext uri="{FF2B5EF4-FFF2-40B4-BE49-F238E27FC236}">
-                <a16:creationId xmlns:a16="http://schemas.microsoft.com/office/drawing/2014/main" id="{6FF26E6F-3AAF-4625-8871-9B17D6404A1A}"/>
+                <a16:creationId xmlns:a16="http://schemas.microsoft.com/office/drawing/2014/main" id="{A43739E8-E871-4407-ACB1-7D24B559B2D6}"/>
               </a:ext>
             </a:extLst>
           </p:cNvPr>
@@ -11753,7 +11753,7 @@
           <p:cNvPr id="5" name="">
             <a:extLst xmlns:a="http://schemas.openxmlformats.org/drawingml/2006/main">
               <a:ext uri="{FF2B5EF4-FFF2-40B4-BE49-F238E27FC236}">
-                <a16:creationId xmlns:a16="http://schemas.microsoft.com/office/drawing/2014/main" id="{5FA5DD89-0ED3-46AA-ACEB-2058D4981589}"/>
+                <a16:creationId xmlns:a16="http://schemas.microsoft.com/office/drawing/2014/main" id="{70005681-0EAF-458C-B97C-87C9A7482C1E}"/>
               </a:ext>
             </a:extLst>
           </p:cNvPr>
@@ -11811,7 +11811,7 @@
           <p:cNvPr id="6" name="">
             <a:extLst xmlns:a="http://schemas.openxmlformats.org/drawingml/2006/main">
               <a:ext uri="{FF2B5EF4-FFF2-40B4-BE49-F238E27FC236}">
-                <a16:creationId xmlns:a16="http://schemas.microsoft.com/office/drawing/2014/main" id="{A8248AA2-C4BA-4643-AF6B-B83F6D72E5C0}"/>
+                <a16:creationId xmlns:a16="http://schemas.microsoft.com/office/drawing/2014/main" id="{4538EF4D-60D7-4494-BF32-B3D262542395}"/>
               </a:ext>
             </a:extLst>
           </p:cNvPr>
@@ -11844,7 +11844,7 @@
           <p:cNvPr id="7" name="">
             <a:extLst xmlns:a="http://schemas.openxmlformats.org/drawingml/2006/main">
               <a:ext uri="{FF2B5EF4-FFF2-40B4-BE49-F238E27FC236}">
-                <a16:creationId xmlns:a16="http://schemas.microsoft.com/office/drawing/2014/main" id="{76FE0B63-E441-4ED7-82CF-2F5FDB63698E}"/>
+                <a16:creationId xmlns:a16="http://schemas.microsoft.com/office/drawing/2014/main" id="{E301FA9A-0B78-432D-98D7-31E5D34AB9FC}"/>
               </a:ext>
             </a:extLst>
           </p:cNvPr>
@@ -11902,7 +11902,7 @@
           <p:cNvPr id="8" name="">
             <a:extLst xmlns:a="http://schemas.openxmlformats.org/drawingml/2006/main">
               <a:ext uri="{FF2B5EF4-FFF2-40B4-BE49-F238E27FC236}">
-                <a16:creationId xmlns:a16="http://schemas.microsoft.com/office/drawing/2014/main" id="{A3F37500-F8DC-4809-83E3-A39976D68FA2}"/>
+                <a16:creationId xmlns:a16="http://schemas.microsoft.com/office/drawing/2014/main" id="{3E0A96ED-CF6F-44CD-BC5F-5E021895E987}"/>
               </a:ext>
             </a:extLst>
           </p:cNvPr>
@@ -11960,7 +11960,7 @@
           <p:cNvPr id="9" name="">
             <a:extLst xmlns:a="http://schemas.openxmlformats.org/drawingml/2006/main">
               <a:ext uri="{FF2B5EF4-FFF2-40B4-BE49-F238E27FC236}">
-                <a16:creationId xmlns:a16="http://schemas.microsoft.com/office/drawing/2014/main" id="{F3618E9D-BDD9-4AB2-B09B-EA8909626258}"/>
+                <a16:creationId xmlns:a16="http://schemas.microsoft.com/office/drawing/2014/main" id="{6136E59A-3E0D-437C-B4A0-52E909F3F60D}"/>
               </a:ext>
             </a:extLst>
           </p:cNvPr>
@@ -11993,7 +11993,7 @@
           <p:cNvPr id="10" name="">
             <a:extLst xmlns:a="http://schemas.openxmlformats.org/drawingml/2006/main">
               <a:ext uri="{FF2B5EF4-FFF2-40B4-BE49-F238E27FC236}">
-                <a16:creationId xmlns:a16="http://schemas.microsoft.com/office/drawing/2014/main" id="{EED7C58E-542D-4A14-AAC2-BD48270A09B0}"/>
+                <a16:creationId xmlns:a16="http://schemas.microsoft.com/office/drawing/2014/main" id="{52844074-CEB2-45A6-9734-EFE41AA9CEAC}"/>
               </a:ext>
             </a:extLst>
           </p:cNvPr>
@@ -12051,7 +12051,7 @@
           <p:cNvPr id="11" name="">
             <a:extLst xmlns:a="http://schemas.openxmlformats.org/drawingml/2006/main">
               <a:ext uri="{FF2B5EF4-FFF2-40B4-BE49-F238E27FC236}">
-                <a16:creationId xmlns:a16="http://schemas.microsoft.com/office/drawing/2014/main" id="{42DA8EFF-4B3D-4A50-AC3E-4CFFFE61045E}"/>
+                <a16:creationId xmlns:a16="http://schemas.microsoft.com/office/drawing/2014/main" id="{37626911-96EC-4909-869A-22EAA62EADBE}"/>
               </a:ext>
             </a:extLst>
           </p:cNvPr>
@@ -12084,7 +12084,7 @@
           <p:cNvPr id="12" name="">
             <a:extLst xmlns:a="http://schemas.openxmlformats.org/drawingml/2006/main">
               <a:ext uri="{FF2B5EF4-FFF2-40B4-BE49-F238E27FC236}">
-                <a16:creationId xmlns:a16="http://schemas.microsoft.com/office/drawing/2014/main" id="{6CD5775C-E2ED-4D44-A56E-52532FDE645A}"/>
+                <a16:creationId xmlns:a16="http://schemas.microsoft.com/office/drawing/2014/main" id="{1A5141F9-B298-4FAE-9110-39E736569C07}"/>
               </a:ext>
             </a:extLst>
           </p:cNvPr>
@@ -12142,7 +12142,7 @@
           <p:cNvPr id="13" name="">
             <a:extLst xmlns:a="http://schemas.openxmlformats.org/drawingml/2006/main">
               <a:ext uri="{FF2B5EF4-FFF2-40B4-BE49-F238E27FC236}">
-                <a16:creationId xmlns:a16="http://schemas.microsoft.com/office/drawing/2014/main" id="{640CBD1F-4983-4B9A-AD21-2D3F8E5BB20E}"/>
+                <a16:creationId xmlns:a16="http://schemas.microsoft.com/office/drawing/2014/main" id="{40614E50-DFD4-4723-89C5-33DAD9B21A5C}"/>
               </a:ext>
             </a:extLst>
           </p:cNvPr>
@@ -12200,7 +12200,7 @@
           <p:cNvPr id="14" name="">
             <a:extLst xmlns:a="http://schemas.openxmlformats.org/drawingml/2006/main">
               <a:ext uri="{FF2B5EF4-FFF2-40B4-BE49-F238E27FC236}">
-                <a16:creationId xmlns:a16="http://schemas.microsoft.com/office/drawing/2014/main" id="{47C32D27-BD25-45C3-9DDD-30CAA90AAB9B}"/>
+                <a16:creationId xmlns:a16="http://schemas.microsoft.com/office/drawing/2014/main" id="{0E6771FB-440F-4A9D-93EC-87BE30422D68}"/>
               </a:ext>
             </a:extLst>
           </p:cNvPr>
@@ -12233,7 +12233,7 @@
           <p:cNvPr id="15" name="">
             <a:extLst xmlns:a="http://schemas.openxmlformats.org/drawingml/2006/main">
               <a:ext uri="{FF2B5EF4-FFF2-40B4-BE49-F238E27FC236}">
-                <a16:creationId xmlns:a16="http://schemas.microsoft.com/office/drawing/2014/main" id="{0840EE0C-A2AD-4218-A895-302E127C0BB7}"/>
+                <a16:creationId xmlns:a16="http://schemas.microsoft.com/office/drawing/2014/main" id="{C28FA175-25EA-4948-BD11-B50E4378287C}"/>
               </a:ext>
             </a:extLst>
           </p:cNvPr>
@@ -12291,7 +12291,7 @@
           <p:cNvPr id="16" name="">
             <a:extLst xmlns:a="http://schemas.openxmlformats.org/drawingml/2006/main">
               <a:ext uri="{FF2B5EF4-FFF2-40B4-BE49-F238E27FC236}">
-                <a16:creationId xmlns:a16="http://schemas.microsoft.com/office/drawing/2014/main" id="{4E15D239-925D-4BE1-8DE8-6AB1723E32C8}"/>
+                <a16:creationId xmlns:a16="http://schemas.microsoft.com/office/drawing/2014/main" id="{1658E0C7-EF05-4BF9-8007-3A4AC93A6194}"/>
               </a:ext>
             </a:extLst>
           </p:cNvPr>
@@ -12324,7 +12324,7 @@
           <p:cNvPr id="17" name="">
             <a:extLst xmlns:a="http://schemas.openxmlformats.org/drawingml/2006/main">
               <a:ext uri="{FF2B5EF4-FFF2-40B4-BE49-F238E27FC236}">
-                <a16:creationId xmlns:a16="http://schemas.microsoft.com/office/drawing/2014/main" id="{7AB3D243-075A-4ABD-8D65-75DE19337F5D}"/>
+                <a16:creationId xmlns:a16="http://schemas.microsoft.com/office/drawing/2014/main" id="{1671F0FB-2D03-4BDC-B6F7-F05ADDFBABC3}"/>
               </a:ext>
             </a:extLst>
           </p:cNvPr>
@@ -12382,7 +12382,7 @@
           <p:cNvPr id="18" name="">
             <a:extLst xmlns:a="http://schemas.openxmlformats.org/drawingml/2006/main">
               <a:ext uri="{FF2B5EF4-FFF2-40B4-BE49-F238E27FC236}">
-                <a16:creationId xmlns:a16="http://schemas.microsoft.com/office/drawing/2014/main" id="{7CE6F74C-73C9-4A2E-A1F9-D2675AEE8FA3}"/>
+                <a16:creationId xmlns:a16="http://schemas.microsoft.com/office/drawing/2014/main" id="{73B27D81-861A-4592-9B1C-8E4AC588707A}"/>
               </a:ext>
             </a:extLst>
           </p:cNvPr>
@@ -12440,7 +12440,7 @@
           <p:cNvPr id="19" name="">
             <a:extLst xmlns:a="http://schemas.openxmlformats.org/drawingml/2006/main">
               <a:ext uri="{FF2B5EF4-FFF2-40B4-BE49-F238E27FC236}">
-                <a16:creationId xmlns:a16="http://schemas.microsoft.com/office/drawing/2014/main" id="{EC40883B-47C2-4632-9C94-20C409FF9820}"/>
+                <a16:creationId xmlns:a16="http://schemas.microsoft.com/office/drawing/2014/main" id="{34D90D4D-D777-4E2B-A0A1-00CD9115B702}"/>
               </a:ext>
             </a:extLst>
           </p:cNvPr>
@@ -12473,7 +12473,7 @@
           <p:cNvPr id="20" name="">
             <a:extLst xmlns:a="http://schemas.openxmlformats.org/drawingml/2006/main">
               <a:ext uri="{FF2B5EF4-FFF2-40B4-BE49-F238E27FC236}">
-                <a16:creationId xmlns:a16="http://schemas.microsoft.com/office/drawing/2014/main" id="{8A873E71-8588-44AA-BF2D-992C9C7008EA}"/>
+                <a16:creationId xmlns:a16="http://schemas.microsoft.com/office/drawing/2014/main" id="{A376BCDE-4A3C-4AC0-84A7-2B70C97870BF}"/>
               </a:ext>
             </a:extLst>
           </p:cNvPr>
@@ -12531,7 +12531,7 @@
           <p:cNvPr id="21" name="">
             <a:extLst xmlns:a="http://schemas.openxmlformats.org/drawingml/2006/main">
               <a:ext uri="{FF2B5EF4-FFF2-40B4-BE49-F238E27FC236}">
-                <a16:creationId xmlns:a16="http://schemas.microsoft.com/office/drawing/2014/main" id="{60482FD1-24FC-46F3-ACE4-4D0A2CD7984B}"/>
+                <a16:creationId xmlns:a16="http://schemas.microsoft.com/office/drawing/2014/main" id="{757DEF2F-3101-4123-B64D-1F3ECBCB9AE2}"/>
               </a:ext>
             </a:extLst>
           </p:cNvPr>
@@ -12564,7 +12564,7 @@
           <p:cNvPr id="22" name="">
             <a:extLst xmlns:a="http://schemas.openxmlformats.org/drawingml/2006/main">
               <a:ext uri="{FF2B5EF4-FFF2-40B4-BE49-F238E27FC236}">
-                <a16:creationId xmlns:a16="http://schemas.microsoft.com/office/drawing/2014/main" id="{58FE393D-055E-4B3B-B882-549A65BE6073}"/>
+                <a16:creationId xmlns:a16="http://schemas.microsoft.com/office/drawing/2014/main" id="{A036FF55-7FA5-4F3B-AB76-166D97199864}"/>
               </a:ext>
             </a:extLst>
           </p:cNvPr>
@@ -12622,7 +12622,7 @@
           <p:cNvPr id="23" name="">
             <a:extLst xmlns:a="http://schemas.openxmlformats.org/drawingml/2006/main">
               <a:ext uri="{FF2B5EF4-FFF2-40B4-BE49-F238E27FC236}">
-                <a16:creationId xmlns:a16="http://schemas.microsoft.com/office/drawing/2014/main" id="{1ECAA6B8-8FD5-45CC-B79A-B8A842294C47}"/>
+                <a16:creationId xmlns:a16="http://schemas.microsoft.com/office/drawing/2014/main" id="{D916B131-53D6-45C5-B821-06AC07431A76}"/>
               </a:ext>
             </a:extLst>
           </p:cNvPr>
@@ -12680,7 +12680,7 @@
           <p:cNvPr id="24" name="">
             <a:extLst xmlns:a="http://schemas.openxmlformats.org/drawingml/2006/main">
               <a:ext uri="{FF2B5EF4-FFF2-40B4-BE49-F238E27FC236}">
-                <a16:creationId xmlns:a16="http://schemas.microsoft.com/office/drawing/2014/main" id="{4BA8C857-EC88-40C8-9A50-75277407B8EE}"/>
+                <a16:creationId xmlns:a16="http://schemas.microsoft.com/office/drawing/2014/main" id="{67A7F771-A446-4C46-9738-4F3B0FA5DD1C}"/>
               </a:ext>
             </a:extLst>
           </p:cNvPr>
@@ -12713,7 +12713,7 @@
           <p:cNvPr id="25" name="">
             <a:extLst xmlns:a="http://schemas.openxmlformats.org/drawingml/2006/main">
               <a:ext uri="{FF2B5EF4-FFF2-40B4-BE49-F238E27FC236}">
-                <a16:creationId xmlns:a16="http://schemas.microsoft.com/office/drawing/2014/main" id="{9F31EB98-E86C-4185-BFD0-48468F42ABD8}"/>
+                <a16:creationId xmlns:a16="http://schemas.microsoft.com/office/drawing/2014/main" id="{7901C416-3873-43BC-91B4-F8F6E3714D01}"/>
               </a:ext>
             </a:extLst>
           </p:cNvPr>
@@ -12771,7 +12771,7 @@
           <p:cNvPr id="26" name="">
             <a:extLst xmlns:a="http://schemas.openxmlformats.org/drawingml/2006/main">
               <a:ext uri="{FF2B5EF4-FFF2-40B4-BE49-F238E27FC236}">
-                <a16:creationId xmlns:a16="http://schemas.microsoft.com/office/drawing/2014/main" id="{CD06BFDE-F7C2-429D-98F1-98DF39787213}"/>
+                <a16:creationId xmlns:a16="http://schemas.microsoft.com/office/drawing/2014/main" id="{606618B8-05B8-4940-BF20-E821DE89099A}"/>
               </a:ext>
             </a:extLst>
           </p:cNvPr>
@@ -12829,7 +12829,7 @@
           <p:cNvPr id="27" name="">
             <a:extLst xmlns:a="http://schemas.openxmlformats.org/drawingml/2006/main">
               <a:ext uri="{FF2B5EF4-FFF2-40B4-BE49-F238E27FC236}">
-                <a16:creationId xmlns:a16="http://schemas.microsoft.com/office/drawing/2014/main" id="{C4012912-E0D6-414D-9DC7-FDCAD2592BA2}"/>
+                <a16:creationId xmlns:a16="http://schemas.microsoft.com/office/drawing/2014/main" id="{8D1FB354-1E8C-40A2-B229-5E12CC502D2C}"/>
               </a:ext>
             </a:extLst>
           </p:cNvPr>
@@ -12887,7 +12887,7 @@
           <p:cNvPr id="28" name="">
             <a:extLst xmlns:a="http://schemas.openxmlformats.org/drawingml/2006/main">
               <a:ext uri="{FF2B5EF4-FFF2-40B4-BE49-F238E27FC236}">
-                <a16:creationId xmlns:a16="http://schemas.microsoft.com/office/drawing/2014/main" id="{4743522B-543A-4B59-BDB4-707921655663}"/>
+                <a16:creationId xmlns:a16="http://schemas.microsoft.com/office/drawing/2014/main" id="{4D265788-3094-4B67-81F4-D18FECB1E8CC}"/>
               </a:ext>
             </a:extLst>
           </p:cNvPr>
@@ -12922,7 +12922,7 @@
           <p:cNvPr id="29" name="">
             <a:extLst xmlns:a="http://schemas.openxmlformats.org/drawingml/2006/main">
               <a:ext uri="{FF2B5EF4-FFF2-40B4-BE49-F238E27FC236}">
-                <a16:creationId xmlns:a16="http://schemas.microsoft.com/office/drawing/2014/main" id="{8EA2C922-6008-4256-B8C5-756959125787}"/>
+                <a16:creationId xmlns:a16="http://schemas.microsoft.com/office/drawing/2014/main" id="{A6FF6272-EE16-431D-BD14-37524AEBE8FB}"/>
               </a:ext>
             </a:extLst>
           </p:cNvPr>
@@ -12978,7 +12978,7 @@
     </p:spTree>
     <p:extLst>
       <p:ext uri="{BB962C8B-B14F-4D97-AF65-F5344CB8AC3E}">
-        <p14:creationId xmlns:p14="http://schemas.microsoft.com/office/powerpoint/2010/main" val="1951109121"/>
+        <p14:creationId xmlns:p14="http://schemas.microsoft.com/office/powerpoint/2010/main" val="2016052650"/>
       </p:ext>
     </p:extLst>
   </p:cSld>
@@ -13002,7 +13002,7 @@
           <p:cNvPr id="14" name="">
             <a:extLst xmlns:a="http://schemas.openxmlformats.org/drawingml/2006/main">
               <a:ext uri="{FF2B5EF4-FFF2-40B4-BE49-F238E27FC236}">
-                <a16:creationId xmlns:a16="http://schemas.microsoft.com/office/drawing/2014/main" id="{4163DBE3-2B61-4FB2-9994-F746157635A6}"/>
+                <a16:creationId xmlns:a16="http://schemas.microsoft.com/office/drawing/2014/main" id="{1C2B7424-BB15-44E0-B0F0-FD008F1357FA}"/>
               </a:ext>
             </a:extLst>
           </p:cNvPr>
@@ -13060,7 +13060,7 @@
           <p:cNvPr id="2" name="">
             <a:extLst xmlns:a="http://schemas.openxmlformats.org/drawingml/2006/main">
               <a:ext uri="{FF2B5EF4-FFF2-40B4-BE49-F238E27FC236}">
-                <a16:creationId xmlns:a16="http://schemas.microsoft.com/office/drawing/2014/main" id="{92FE378A-6B50-4C09-B708-FEA567C2ADD7}"/>
+                <a16:creationId xmlns:a16="http://schemas.microsoft.com/office/drawing/2014/main" id="{D1C2AA55-4C99-4BD5-932D-19395DA519CE}"/>
               </a:ext>
             </a:extLst>
           </p:cNvPr>
@@ -13108,7 +13108,7 @@
                 <a:ea typeface="Microsoft YaHei"/>
                 <a:cs typeface="Microsoft YaHei"/>
               </a:rPr>
-              <a:t>同一场景下，七条实际部署曲线都稳定；失败候选不会获得控制权</a:t>
+              <a:t>七条部署曲线都稳定；失败候选不获控制权</a:t>
             </a:r>
           </a:p>
         </p:txBody>
@@ -13118,19 +13118,19 @@
           <p:cNvPr id="3" name="">
             <a:extLst xmlns:a="http://schemas.openxmlformats.org/drawingml/2006/main">
               <a:ext uri="{FF2B5EF4-FFF2-40B4-BE49-F238E27FC236}">
-                <a16:creationId xmlns:a16="http://schemas.microsoft.com/office/drawing/2014/main" id="{CAFD7909-5AED-4B83-A616-45D654E0EB16}"/>
-              </a:ext>
-            </a:extLst>
-          </p:cNvPr>
-          <p:cNvSpPr>
-            <a:spLocks xmlns:a="http://schemas.openxmlformats.org/drawingml/2006/main" noGrp="1"/>
-          </p:cNvSpPr>
-          <p:nvPr/>
-        </p:nvSpPr>
-        <p:spPr>
-          <a:xfrm xmlns:a="http://schemas.openxmlformats.org/drawingml/2006/main">
-            <a:off x="11239500" y="6334125"/>
-            <a:ext cx="552450" cy="190500"/>
+                <a16:creationId xmlns:a16="http://schemas.microsoft.com/office/drawing/2014/main" id="{8ACB50F6-3C64-4F89-BC37-533A30FD523C}"/>
+              </a:ext>
+            </a:extLst>
+          </p:cNvPr>
+          <p:cNvSpPr>
+            <a:spLocks xmlns:a="http://schemas.openxmlformats.org/drawingml/2006/main" noGrp="1"/>
+          </p:cNvSpPr>
+          <p:nvPr/>
+        </p:nvSpPr>
+        <p:spPr>
+          <a:xfrm xmlns:a="http://schemas.openxmlformats.org/drawingml/2006/main">
+            <a:off x="10953750" y="6334125"/>
+            <a:ext cx="838200" cy="190500"/>
           </a:xfrm>
           <a:prstGeom xmlns:a="http://schemas.openxmlformats.org/drawingml/2006/main" prst="rect">
             <a:avLst/>
@@ -13183,7 +13183,7 @@
         </p:xfrm>
         <a:graphic xmlns:a="http://schemas.openxmlformats.org/drawingml/2006/main">
           <a:graphicData uri="http://schemas.openxmlformats.org/drawingml/2006/chart">
-            <c:chart xmlns:r="http://schemas.openxmlformats.org/officeDocument/2006/relationships" xmlns:c="http://schemas.openxmlformats.org/drawingml/2006/chart" r:id="R2d10bd2294e0426f"/>
+            <c:chart xmlns:r="http://schemas.openxmlformats.org/officeDocument/2006/relationships" xmlns:c="http://schemas.openxmlformats.org/drawingml/2006/chart" r:id="R2549e70aa22a4a90"/>
           </a:graphicData>
         </a:graphic>
       </p:graphicFrame>
@@ -13192,7 +13192,7 @@
           <p:cNvPr id="5" name="">
             <a:extLst xmlns:a="http://schemas.openxmlformats.org/drawingml/2006/main">
               <a:ext uri="{FF2B5EF4-FFF2-40B4-BE49-F238E27FC236}">
-                <a16:creationId xmlns:a16="http://schemas.microsoft.com/office/drawing/2014/main" id="{F0F4B0C0-AA5C-427D-94BD-734DF5007B50}"/>
+                <a16:creationId xmlns:a16="http://schemas.microsoft.com/office/drawing/2014/main" id="{150B3BB7-009A-4453-A46F-247C036ACDF7}"/>
               </a:ext>
             </a:extLst>
           </p:cNvPr>
@@ -13227,7 +13227,7 @@
           <p:cNvPr id="6" name="">
             <a:extLst xmlns:a="http://schemas.openxmlformats.org/drawingml/2006/main">
               <a:ext uri="{FF2B5EF4-FFF2-40B4-BE49-F238E27FC236}">
-                <a16:creationId xmlns:a16="http://schemas.microsoft.com/office/drawing/2014/main" id="{68C3FE8A-10CB-43BA-BADC-59137BD182F8}"/>
+                <a16:creationId xmlns:a16="http://schemas.microsoft.com/office/drawing/2014/main" id="{BC6D95DA-A2C3-4412-8231-7F3FDB7BF2FA}"/>
               </a:ext>
             </a:extLst>
           </p:cNvPr>
@@ -13285,7 +13285,7 @@
           <p:cNvPr id="7" name="">
             <a:extLst xmlns:a="http://schemas.openxmlformats.org/drawingml/2006/main">
               <a:ext uri="{FF2B5EF4-FFF2-40B4-BE49-F238E27FC236}">
-                <a16:creationId xmlns:a16="http://schemas.microsoft.com/office/drawing/2014/main" id="{FF5FF7E5-E7EC-4524-9755-90B5D9F7E7C1}"/>
+                <a16:creationId xmlns:a16="http://schemas.microsoft.com/office/drawing/2014/main" id="{3809E03B-0FCC-4601-9D73-73395812A478}"/>
               </a:ext>
             </a:extLst>
           </p:cNvPr>
@@ -13343,7 +13343,7 @@
           <p:cNvPr id="8" name="">
             <a:extLst xmlns:a="http://schemas.openxmlformats.org/drawingml/2006/main">
               <a:ext uri="{FF2B5EF4-FFF2-40B4-BE49-F238E27FC236}">
-                <a16:creationId xmlns:a16="http://schemas.microsoft.com/office/drawing/2014/main" id="{7E56C8ED-A348-43FC-B670-BDA54E05EDC5}"/>
+                <a16:creationId xmlns:a16="http://schemas.microsoft.com/office/drawing/2014/main" id="{A0EE0F1A-94FF-4DAC-AACD-23CC0525D7B1}"/>
               </a:ext>
             </a:extLst>
           </p:cNvPr>
@@ -13378,7 +13378,7 @@
           <p:cNvPr id="9" name="">
             <a:extLst xmlns:a="http://schemas.openxmlformats.org/drawingml/2006/main">
               <a:ext uri="{FF2B5EF4-FFF2-40B4-BE49-F238E27FC236}">
-                <a16:creationId xmlns:a16="http://schemas.microsoft.com/office/drawing/2014/main" id="{E1344A09-5DB6-4C27-9DD7-8A753A65C1F6}"/>
+                <a16:creationId xmlns:a16="http://schemas.microsoft.com/office/drawing/2014/main" id="{C87263CE-F9C1-4968-B5E5-EB4F1EBE9E25}"/>
               </a:ext>
             </a:extLst>
           </p:cNvPr>
@@ -13436,7 +13436,7 @@
           <p:cNvPr id="10" name="">
             <a:extLst xmlns:a="http://schemas.openxmlformats.org/drawingml/2006/main">
               <a:ext uri="{FF2B5EF4-FFF2-40B4-BE49-F238E27FC236}">
-                <a16:creationId xmlns:a16="http://schemas.microsoft.com/office/drawing/2014/main" id="{7A7378B4-1B71-476B-A735-3B11290B6934}"/>
+                <a16:creationId xmlns:a16="http://schemas.microsoft.com/office/drawing/2014/main" id="{5A4BFEB6-EE38-401C-A571-3CD72D329F7E}"/>
               </a:ext>
             </a:extLst>
           </p:cNvPr>
@@ -13494,7 +13494,7 @@
           <p:cNvPr id="11" name="">
             <a:extLst xmlns:a="http://schemas.openxmlformats.org/drawingml/2006/main">
               <a:ext uri="{FF2B5EF4-FFF2-40B4-BE49-F238E27FC236}">
-                <a16:creationId xmlns:a16="http://schemas.microsoft.com/office/drawing/2014/main" id="{9F4B3BF6-638D-4F25-8207-444D483363FE}"/>
+                <a16:creationId xmlns:a16="http://schemas.microsoft.com/office/drawing/2014/main" id="{E8FD986D-3273-4E70-A4D5-0CA220F30D2E}"/>
               </a:ext>
             </a:extLst>
           </p:cNvPr>
@@ -13529,7 +13529,7 @@
           <p:cNvPr id="12" name="">
             <a:extLst xmlns:a="http://schemas.openxmlformats.org/drawingml/2006/main">
               <a:ext uri="{FF2B5EF4-FFF2-40B4-BE49-F238E27FC236}">
-                <a16:creationId xmlns:a16="http://schemas.microsoft.com/office/drawing/2014/main" id="{7567D7D9-4FFB-4DC2-A8A7-79E30AC9D564}"/>
+                <a16:creationId xmlns:a16="http://schemas.microsoft.com/office/drawing/2014/main" id="{F51427D7-735D-4863-9323-810E1FB7DEE0}"/>
               </a:ext>
             </a:extLst>
           </p:cNvPr>
@@ -13587,7 +13587,7 @@
           <p:cNvPr id="13" name="">
             <a:extLst xmlns:a="http://schemas.openxmlformats.org/drawingml/2006/main">
               <a:ext uri="{FF2B5EF4-FFF2-40B4-BE49-F238E27FC236}">
-                <a16:creationId xmlns:a16="http://schemas.microsoft.com/office/drawing/2014/main" id="{42676FC4-2632-4B3A-B75A-927B394F6B59}"/>
+                <a16:creationId xmlns:a16="http://schemas.microsoft.com/office/drawing/2014/main" id="{ED3EF6F2-0782-4C02-96F4-BB6582A56709}"/>
               </a:ext>
             </a:extLst>
           </p:cNvPr>
@@ -13643,7 +13643,7 @@
     </p:spTree>
     <p:extLst>
       <p:ext uri="{BB962C8B-B14F-4D97-AF65-F5344CB8AC3E}">
-        <p14:creationId xmlns:p14="http://schemas.microsoft.com/office/powerpoint/2010/main" val="648341484"/>
+        <p14:creationId xmlns:p14="http://schemas.microsoft.com/office/powerpoint/2010/main" val="72888171"/>
       </p:ext>
     </p:extLst>
   </p:cSld>
@@ -13667,7 +13667,7 @@
           <p:cNvPr id="12" name="">
             <a:extLst xmlns:a="http://schemas.openxmlformats.org/drawingml/2006/main">
               <a:ext uri="{FF2B5EF4-FFF2-40B4-BE49-F238E27FC236}">
-                <a16:creationId xmlns:a16="http://schemas.microsoft.com/office/drawing/2014/main" id="{F5D7B192-EF59-4426-B195-0A68B1D33940}"/>
+                <a16:creationId xmlns:a16="http://schemas.microsoft.com/office/drawing/2014/main" id="{FCE7F073-8DCE-4907-A336-ACE7E404DBAE}"/>
               </a:ext>
             </a:extLst>
           </p:cNvPr>
@@ -13725,7 +13725,7 @@
           <p:cNvPr id="2" name="">
             <a:extLst xmlns:a="http://schemas.openxmlformats.org/drawingml/2006/main">
               <a:ext uri="{FF2B5EF4-FFF2-40B4-BE49-F238E27FC236}">
-                <a16:creationId xmlns:a16="http://schemas.microsoft.com/office/drawing/2014/main" id="{FB923070-3270-47B6-AE02-BB02CB997EFF}"/>
+                <a16:creationId xmlns:a16="http://schemas.microsoft.com/office/drawing/2014/main" id="{B277CCF0-016F-420A-832A-9D390FBE6D55}"/>
               </a:ext>
             </a:extLst>
           </p:cNvPr>
@@ -13783,19 +13783,19 @@
           <p:cNvPr id="3" name="">
             <a:extLst xmlns:a="http://schemas.openxmlformats.org/drawingml/2006/main">
               <a:ext uri="{FF2B5EF4-FFF2-40B4-BE49-F238E27FC236}">
-                <a16:creationId xmlns:a16="http://schemas.microsoft.com/office/drawing/2014/main" id="{3F202945-4B7B-4ED5-BAA2-9413AC7A1A62}"/>
-              </a:ext>
-            </a:extLst>
-          </p:cNvPr>
-          <p:cNvSpPr>
-            <a:spLocks xmlns:a="http://schemas.openxmlformats.org/drawingml/2006/main" noGrp="1"/>
-          </p:cNvSpPr>
-          <p:nvPr/>
-        </p:nvSpPr>
-        <p:spPr>
-          <a:xfrm xmlns:a="http://schemas.openxmlformats.org/drawingml/2006/main">
-            <a:off x="11239500" y="6334125"/>
-            <a:ext cx="552450" cy="190500"/>
+                <a16:creationId xmlns:a16="http://schemas.microsoft.com/office/drawing/2014/main" id="{837506B7-00F4-45DE-9B7A-0BCBF67148A5}"/>
+              </a:ext>
+            </a:extLst>
+          </p:cNvPr>
+          <p:cNvSpPr>
+            <a:spLocks xmlns:a="http://schemas.openxmlformats.org/drawingml/2006/main" noGrp="1"/>
+          </p:cNvSpPr>
+          <p:nvPr/>
+        </p:nvSpPr>
+        <p:spPr>
+          <a:xfrm xmlns:a="http://schemas.openxmlformats.org/drawingml/2006/main">
+            <a:off x="10953750" y="6334125"/>
+            <a:ext cx="838200" cy="190500"/>
           </a:xfrm>
           <a:prstGeom xmlns:a="http://schemas.openxmlformats.org/drawingml/2006/main" prst="rect">
             <a:avLst/>
@@ -13848,7 +13848,7 @@
         </p:xfrm>
         <a:graphic xmlns:a="http://schemas.openxmlformats.org/drawingml/2006/main">
           <a:graphicData uri="http://schemas.openxmlformats.org/drawingml/2006/chart">
-            <c:chart xmlns:r="http://schemas.openxmlformats.org/officeDocument/2006/relationships" xmlns:c="http://schemas.openxmlformats.org/drawingml/2006/chart" r:id="Rf0c3655b2c264742"/>
+            <c:chart xmlns:r="http://schemas.openxmlformats.org/officeDocument/2006/relationships" xmlns:c="http://schemas.openxmlformats.org/drawingml/2006/chart" r:id="R20e557f7a0154ca7"/>
           </a:graphicData>
         </a:graphic>
       </p:graphicFrame>
@@ -13857,7 +13857,7 @@
           <p:cNvPr id="5" name="">
             <a:extLst xmlns:a="http://schemas.openxmlformats.org/drawingml/2006/main">
               <a:ext uri="{FF2B5EF4-FFF2-40B4-BE49-F238E27FC236}">
-                <a16:creationId xmlns:a16="http://schemas.microsoft.com/office/drawing/2014/main" id="{4C058BA1-E178-4FC9-8ADF-2C97D7344A88}"/>
+                <a16:creationId xmlns:a16="http://schemas.microsoft.com/office/drawing/2014/main" id="{8C8C9B2C-26FA-45E9-AD59-FF80AA6C602B}"/>
               </a:ext>
             </a:extLst>
           </p:cNvPr>
@@ -13892,7 +13892,7 @@
           <p:cNvPr id="6" name="">
             <a:extLst xmlns:a="http://schemas.openxmlformats.org/drawingml/2006/main">
               <a:ext uri="{FF2B5EF4-FFF2-40B4-BE49-F238E27FC236}">
-                <a16:creationId xmlns:a16="http://schemas.microsoft.com/office/drawing/2014/main" id="{754F9612-6693-4F72-BCDB-225B3E62ABEE}"/>
+                <a16:creationId xmlns:a16="http://schemas.microsoft.com/office/drawing/2014/main" id="{7FD855D1-FD1B-4911-8D2C-7A77341117B7}"/>
               </a:ext>
             </a:extLst>
           </p:cNvPr>
@@ -13950,7 +13950,7 @@
           <p:cNvPr id="7" name="">
             <a:extLst xmlns:a="http://schemas.openxmlformats.org/drawingml/2006/main">
               <a:ext uri="{FF2B5EF4-FFF2-40B4-BE49-F238E27FC236}">
-                <a16:creationId xmlns:a16="http://schemas.microsoft.com/office/drawing/2014/main" id="{1AFFD4BB-096A-4B69-86EC-CDC4EF9FB81B}"/>
+                <a16:creationId xmlns:a16="http://schemas.microsoft.com/office/drawing/2014/main" id="{3445962B-DC23-44E7-A309-3FB8FE1A4C5D}"/>
               </a:ext>
             </a:extLst>
           </p:cNvPr>
@@ -14008,7 +14008,7 @@
           <p:cNvPr id="8" name="">
             <a:extLst xmlns:a="http://schemas.openxmlformats.org/drawingml/2006/main">
               <a:ext uri="{FF2B5EF4-FFF2-40B4-BE49-F238E27FC236}">
-                <a16:creationId xmlns:a16="http://schemas.microsoft.com/office/drawing/2014/main" id="{95DC6081-42B6-45E8-8848-084BFD2B3A47}"/>
+                <a16:creationId xmlns:a16="http://schemas.microsoft.com/office/drawing/2014/main" id="{086D6CF5-948C-48EF-AEED-794C62D07541}"/>
               </a:ext>
             </a:extLst>
           </p:cNvPr>
@@ -14043,7 +14043,7 @@
           <p:cNvPr id="9" name="">
             <a:extLst xmlns:a="http://schemas.openxmlformats.org/drawingml/2006/main">
               <a:ext uri="{FF2B5EF4-FFF2-40B4-BE49-F238E27FC236}">
-                <a16:creationId xmlns:a16="http://schemas.microsoft.com/office/drawing/2014/main" id="{06A6B1E2-3180-44A5-8ECE-BCE1E75209F4}"/>
+                <a16:creationId xmlns:a16="http://schemas.microsoft.com/office/drawing/2014/main" id="{C8560F7A-94FC-4A74-8D7E-9439E8D35222}"/>
               </a:ext>
             </a:extLst>
           </p:cNvPr>
@@ -14101,7 +14101,7 @@
           <p:cNvPr id="10" name="">
             <a:extLst xmlns:a="http://schemas.openxmlformats.org/drawingml/2006/main">
               <a:ext uri="{FF2B5EF4-FFF2-40B4-BE49-F238E27FC236}">
-                <a16:creationId xmlns:a16="http://schemas.microsoft.com/office/drawing/2014/main" id="{C5B9C6E7-0E60-4E55-A270-48083F58AD84}"/>
+                <a16:creationId xmlns:a16="http://schemas.microsoft.com/office/drawing/2014/main" id="{431CB00E-F91E-47EA-800D-D98B9B5302F6}"/>
               </a:ext>
             </a:extLst>
           </p:cNvPr>
@@ -14159,7 +14159,7 @@
           <p:cNvPr id="11" name="">
             <a:extLst xmlns:a="http://schemas.openxmlformats.org/drawingml/2006/main">
               <a:ext uri="{FF2B5EF4-FFF2-40B4-BE49-F238E27FC236}">
-                <a16:creationId xmlns:a16="http://schemas.microsoft.com/office/drawing/2014/main" id="{6DA4957B-EAAE-43FA-810C-DB258C5A6E4E}"/>
+                <a16:creationId xmlns:a16="http://schemas.microsoft.com/office/drawing/2014/main" id="{34C1A429-7AFF-4526-A4C2-CA8DD9F7066D}"/>
               </a:ext>
             </a:extLst>
           </p:cNvPr>
@@ -14215,7 +14215,7 @@
     </p:spTree>
     <p:extLst>
       <p:ext uri="{BB962C8B-B14F-4D97-AF65-F5344CB8AC3E}">
-        <p14:creationId xmlns:p14="http://schemas.microsoft.com/office/powerpoint/2010/main" val="129430208"/>
+        <p14:creationId xmlns:p14="http://schemas.microsoft.com/office/powerpoint/2010/main" val="1751562231"/>
       </p:ext>
     </p:extLst>
   </p:cSld>
@@ -14239,7 +14239,7 @@
           <p:cNvPr id="12" name="">
             <a:extLst xmlns:a="http://schemas.openxmlformats.org/drawingml/2006/main">
               <a:ext uri="{FF2B5EF4-FFF2-40B4-BE49-F238E27FC236}">
-                <a16:creationId xmlns:a16="http://schemas.microsoft.com/office/drawing/2014/main" id="{7DD51D07-B63B-4975-8A89-DA67A48935B2}"/>
+                <a16:creationId xmlns:a16="http://schemas.microsoft.com/office/drawing/2014/main" id="{4E7EF1FA-C4CE-4AB7-A0FA-EB3EADF74DC2}"/>
               </a:ext>
             </a:extLst>
           </p:cNvPr>
@@ -14297,7 +14297,7 @@
           <p:cNvPr id="2" name="">
             <a:extLst xmlns:a="http://schemas.openxmlformats.org/drawingml/2006/main">
               <a:ext uri="{FF2B5EF4-FFF2-40B4-BE49-F238E27FC236}">
-                <a16:creationId xmlns:a16="http://schemas.microsoft.com/office/drawing/2014/main" id="{5D3071CB-8597-4941-AF98-6CF50E93835F}"/>
+                <a16:creationId xmlns:a16="http://schemas.microsoft.com/office/drawing/2014/main" id="{01EEF1CD-9369-4DD3-91E4-0F710684CF06}"/>
               </a:ext>
             </a:extLst>
           </p:cNvPr>
@@ -14345,7 +14345,7 @@
                 <a:ea typeface="Microsoft YaHei"/>
                 <a:cs typeface="Microsoft YaHei"/>
               </a:rPr>
-              <a:t>FNN 被拒绝时，两条曲线必须分开说清楚</a:t>
+              <a:t>FNN 被拒绝时，实际与候选曲线必须分开</a:t>
             </a:r>
           </a:p>
         </p:txBody>
@@ -14355,19 +14355,19 @@
           <p:cNvPr id="3" name="">
             <a:extLst xmlns:a="http://schemas.openxmlformats.org/drawingml/2006/main">
               <a:ext uri="{FF2B5EF4-FFF2-40B4-BE49-F238E27FC236}">
-                <a16:creationId xmlns:a16="http://schemas.microsoft.com/office/drawing/2014/main" id="{50B48FB0-8D37-458C-906F-3D20D333B696}"/>
-              </a:ext>
-            </a:extLst>
-          </p:cNvPr>
-          <p:cNvSpPr>
-            <a:spLocks xmlns:a="http://schemas.openxmlformats.org/drawingml/2006/main" noGrp="1"/>
-          </p:cNvSpPr>
-          <p:nvPr/>
-        </p:nvSpPr>
-        <p:spPr>
-          <a:xfrm xmlns:a="http://schemas.openxmlformats.org/drawingml/2006/main">
-            <a:off x="11239500" y="6334125"/>
-            <a:ext cx="552450" cy="190500"/>
+                <a16:creationId xmlns:a16="http://schemas.microsoft.com/office/drawing/2014/main" id="{B704424F-4309-4674-A7AA-01B29FDE2580}"/>
+              </a:ext>
+            </a:extLst>
+          </p:cNvPr>
+          <p:cNvSpPr>
+            <a:spLocks xmlns:a="http://schemas.openxmlformats.org/drawingml/2006/main" noGrp="1"/>
+          </p:cNvSpPr>
+          <p:nvPr/>
+        </p:nvSpPr>
+        <p:spPr>
+          <a:xfrm xmlns:a="http://schemas.openxmlformats.org/drawingml/2006/main">
+            <a:off x="10953750" y="6334125"/>
+            <a:ext cx="838200" cy="190500"/>
           </a:xfrm>
           <a:prstGeom xmlns:a="http://schemas.openxmlformats.org/drawingml/2006/main" prst="rect">
             <a:avLst/>
@@ -14420,7 +14420,7 @@
         </p:xfrm>
         <a:graphic xmlns:a="http://schemas.openxmlformats.org/drawingml/2006/main">
           <a:graphicData uri="http://schemas.openxmlformats.org/drawingml/2006/chart">
-            <c:chart xmlns:r="http://schemas.openxmlformats.org/officeDocument/2006/relationships" xmlns:c="http://schemas.openxmlformats.org/drawingml/2006/chart" r:id="Rfdfb8f2338524e05"/>
+            <c:chart xmlns:r="http://schemas.openxmlformats.org/officeDocument/2006/relationships" xmlns:c="http://schemas.openxmlformats.org/drawingml/2006/chart" r:id="R75dbb3935c884417"/>
           </a:graphicData>
         </a:graphic>
       </p:graphicFrame>
@@ -14429,7 +14429,7 @@
           <p:cNvPr id="5" name="">
             <a:extLst xmlns:a="http://schemas.openxmlformats.org/drawingml/2006/main">
               <a:ext uri="{FF2B5EF4-FFF2-40B4-BE49-F238E27FC236}">
-                <a16:creationId xmlns:a16="http://schemas.microsoft.com/office/drawing/2014/main" id="{D833F559-A5AF-4F4E-A92A-362709AE2CC9}"/>
+                <a16:creationId xmlns:a16="http://schemas.microsoft.com/office/drawing/2014/main" id="{4192BFD1-0F32-4E02-8DCF-9A6CA0B4C695}"/>
               </a:ext>
             </a:extLst>
           </p:cNvPr>
@@ -14464,7 +14464,7 @@
           <p:cNvPr id="6" name="">
             <a:extLst xmlns:a="http://schemas.openxmlformats.org/drawingml/2006/main">
               <a:ext uri="{FF2B5EF4-FFF2-40B4-BE49-F238E27FC236}">
-                <a16:creationId xmlns:a16="http://schemas.microsoft.com/office/drawing/2014/main" id="{BC800388-7413-4DF5-A633-0C7D0094FC67}"/>
+                <a16:creationId xmlns:a16="http://schemas.microsoft.com/office/drawing/2014/main" id="{8D0DE3D8-AA13-4EB5-A7D6-531CDF280CCC}"/>
               </a:ext>
             </a:extLst>
           </p:cNvPr>
@@ -14522,7 +14522,7 @@
           <p:cNvPr id="7" name="">
             <a:extLst xmlns:a="http://schemas.openxmlformats.org/drawingml/2006/main">
               <a:ext uri="{FF2B5EF4-FFF2-40B4-BE49-F238E27FC236}">
-                <a16:creationId xmlns:a16="http://schemas.microsoft.com/office/drawing/2014/main" id="{E9797048-FD35-4B2C-A8B3-9B9895894823}"/>
+                <a16:creationId xmlns:a16="http://schemas.microsoft.com/office/drawing/2014/main" id="{6CFE99E6-EDC1-4973-BEAE-588509E4AAFC}"/>
               </a:ext>
             </a:extLst>
           </p:cNvPr>
@@ -14603,7 +14603,7 @@
           <p:cNvPr id="8" name="">
             <a:extLst xmlns:a="http://schemas.openxmlformats.org/drawingml/2006/main">
               <a:ext uri="{FF2B5EF4-FFF2-40B4-BE49-F238E27FC236}">
-                <a16:creationId xmlns:a16="http://schemas.microsoft.com/office/drawing/2014/main" id="{E4430EE7-380B-4335-A5B5-FB805874E614}"/>
+                <a16:creationId xmlns:a16="http://schemas.microsoft.com/office/drawing/2014/main" id="{20F9EC3F-5769-41C1-B7F4-C08ABFDC7C58}"/>
               </a:ext>
             </a:extLst>
           </p:cNvPr>
@@ -14638,7 +14638,7 @@
           <p:cNvPr id="9" name="">
             <a:extLst xmlns:a="http://schemas.openxmlformats.org/drawingml/2006/main">
               <a:ext uri="{FF2B5EF4-FFF2-40B4-BE49-F238E27FC236}">
-                <a16:creationId xmlns:a16="http://schemas.microsoft.com/office/drawing/2014/main" id="{09CA0A45-653A-47D1-896E-FF5DAE18BFDC}"/>
+                <a16:creationId xmlns:a16="http://schemas.microsoft.com/office/drawing/2014/main" id="{8E2CB12E-A1F7-4415-A041-75F812EEE857}"/>
               </a:ext>
             </a:extLst>
           </p:cNvPr>
@@ -14696,7 +14696,7 @@
           <p:cNvPr id="10" name="">
             <a:extLst xmlns:a="http://schemas.openxmlformats.org/drawingml/2006/main">
               <a:ext uri="{FF2B5EF4-FFF2-40B4-BE49-F238E27FC236}">
-                <a16:creationId xmlns:a16="http://schemas.microsoft.com/office/drawing/2014/main" id="{32BAF5D3-7C23-4F82-9E04-79978AC963DB}"/>
+                <a16:creationId xmlns:a16="http://schemas.microsoft.com/office/drawing/2014/main" id="{E04A6BAC-72D4-4C78-B534-6B10F43D9398}"/>
               </a:ext>
             </a:extLst>
           </p:cNvPr>
@@ -14777,7 +14777,7 @@
           <p:cNvPr id="11" name="">
             <a:extLst xmlns:a="http://schemas.openxmlformats.org/drawingml/2006/main">
               <a:ext uri="{FF2B5EF4-FFF2-40B4-BE49-F238E27FC236}">
-                <a16:creationId xmlns:a16="http://schemas.microsoft.com/office/drawing/2014/main" id="{9C860B28-F838-4678-BCD0-D524DEFF5CA4}"/>
+                <a16:creationId xmlns:a16="http://schemas.microsoft.com/office/drawing/2014/main" id="{68D0607D-82E9-4380-AFED-8E2A919000D2}"/>
               </a:ext>
             </a:extLst>
           </p:cNvPr>
@@ -14833,7 +14833,7 @@
     </p:spTree>
     <p:extLst>
       <p:ext uri="{BB962C8B-B14F-4D97-AF65-F5344CB8AC3E}">
-        <p14:creationId xmlns:p14="http://schemas.microsoft.com/office/powerpoint/2010/main" val="593641988"/>
+        <p14:creationId xmlns:p14="http://schemas.microsoft.com/office/powerpoint/2010/main" val="1397896830"/>
       </p:ext>
     </p:extLst>
   </p:cSld>
@@ -14857,7 +14857,7 @@
           <p:cNvPr id="21" name="">
             <a:extLst xmlns:a="http://schemas.openxmlformats.org/drawingml/2006/main">
               <a:ext uri="{FF2B5EF4-FFF2-40B4-BE49-F238E27FC236}">
-                <a16:creationId xmlns:a16="http://schemas.microsoft.com/office/drawing/2014/main" id="{619366DB-08AB-47B2-BA5F-3C458D8F407D}"/>
+                <a16:creationId xmlns:a16="http://schemas.microsoft.com/office/drawing/2014/main" id="{169191BA-E4C4-4769-A85F-3CC06186FC2F}"/>
               </a:ext>
             </a:extLst>
           </p:cNvPr>
@@ -14915,7 +14915,7 @@
           <p:cNvPr id="2" name="">
             <a:extLst xmlns:a="http://schemas.openxmlformats.org/drawingml/2006/main">
               <a:ext uri="{FF2B5EF4-FFF2-40B4-BE49-F238E27FC236}">
-                <a16:creationId xmlns:a16="http://schemas.microsoft.com/office/drawing/2014/main" id="{4B5CD609-C5D9-4D2B-88B8-A1CCB3675ABA}"/>
+                <a16:creationId xmlns:a16="http://schemas.microsoft.com/office/drawing/2014/main" id="{BE9CF803-86CE-4B0D-8D83-17761F7F2639}"/>
               </a:ext>
             </a:extLst>
           </p:cNvPr>
@@ -14973,19 +14973,19 @@
           <p:cNvPr id="3" name="">
             <a:extLst xmlns:a="http://schemas.openxmlformats.org/drawingml/2006/main">
               <a:ext uri="{FF2B5EF4-FFF2-40B4-BE49-F238E27FC236}">
-                <a16:creationId xmlns:a16="http://schemas.microsoft.com/office/drawing/2014/main" id="{AE18EF8B-0666-4783-9523-7CFAF261E845}"/>
-              </a:ext>
-            </a:extLst>
-          </p:cNvPr>
-          <p:cNvSpPr>
-            <a:spLocks xmlns:a="http://schemas.openxmlformats.org/drawingml/2006/main" noGrp="1"/>
-          </p:cNvSpPr>
-          <p:nvPr/>
-        </p:nvSpPr>
-        <p:spPr>
-          <a:xfrm xmlns:a="http://schemas.openxmlformats.org/drawingml/2006/main">
-            <a:off x="11239500" y="6334125"/>
-            <a:ext cx="552450" cy="190500"/>
+                <a16:creationId xmlns:a16="http://schemas.microsoft.com/office/drawing/2014/main" id="{EC41DDEE-D28C-4842-B4C6-A5734E9A1F69}"/>
+              </a:ext>
+            </a:extLst>
+          </p:cNvPr>
+          <p:cNvSpPr>
+            <a:spLocks xmlns:a="http://schemas.openxmlformats.org/drawingml/2006/main" noGrp="1"/>
+          </p:cNvSpPr>
+          <p:nvPr/>
+        </p:nvSpPr>
+        <p:spPr>
+          <a:xfrm xmlns:a="http://schemas.openxmlformats.org/drawingml/2006/main">
+            <a:off x="10953750" y="6334125"/>
+            <a:ext cx="838200" cy="190500"/>
           </a:xfrm>
           <a:prstGeom xmlns:a="http://schemas.openxmlformats.org/drawingml/2006/main" prst="rect">
             <a:avLst/>
@@ -15031,7 +15031,7 @@
           <p:cNvPr id="4" name="">
             <a:extLst xmlns:a="http://schemas.openxmlformats.org/drawingml/2006/main">
               <a:ext uri="{FF2B5EF4-FFF2-40B4-BE49-F238E27FC236}">
-                <a16:creationId xmlns:a16="http://schemas.microsoft.com/office/drawing/2014/main" id="{1C3EAB94-6D1F-4E32-BEF6-999524AC6790}"/>
+                <a16:creationId xmlns:a16="http://schemas.microsoft.com/office/drawing/2014/main" id="{1CB99AF2-F764-4730-913C-21538835EDCC}"/>
               </a:ext>
             </a:extLst>
           </p:cNvPr>
@@ -15066,7 +15066,7 @@
           <p:cNvPr id="5" name="">
             <a:extLst xmlns:a="http://schemas.openxmlformats.org/drawingml/2006/main">
               <a:ext uri="{FF2B5EF4-FFF2-40B4-BE49-F238E27FC236}">
-                <a16:creationId xmlns:a16="http://schemas.microsoft.com/office/drawing/2014/main" id="{52ED4F1E-6556-4D71-A8E1-6CE85BE1C9B9}"/>
+                <a16:creationId xmlns:a16="http://schemas.microsoft.com/office/drawing/2014/main" id="{57125FE1-AD89-4B5C-9A55-0817B84B5CEB}"/>
               </a:ext>
             </a:extLst>
           </p:cNvPr>
@@ -15124,7 +15124,7 @@
           <p:cNvPr id="6" name="">
             <a:extLst xmlns:a="http://schemas.openxmlformats.org/drawingml/2006/main">
               <a:ext uri="{FF2B5EF4-FFF2-40B4-BE49-F238E27FC236}">
-                <a16:creationId xmlns:a16="http://schemas.microsoft.com/office/drawing/2014/main" id="{BD269DE4-F726-46CE-ACA7-686C839D4F75}"/>
+                <a16:creationId xmlns:a16="http://schemas.microsoft.com/office/drawing/2014/main" id="{736FF2BD-73DE-4047-902B-FF413F449F98}"/>
               </a:ext>
             </a:extLst>
           </p:cNvPr>
@@ -15182,7 +15182,7 @@
           <p:cNvPr id="7" name="">
             <a:extLst xmlns:a="http://schemas.openxmlformats.org/drawingml/2006/main">
               <a:ext uri="{FF2B5EF4-FFF2-40B4-BE49-F238E27FC236}">
-                <a16:creationId xmlns:a16="http://schemas.microsoft.com/office/drawing/2014/main" id="{6D92407C-A41C-498C-8DDC-7EAA7398C66C}"/>
+                <a16:creationId xmlns:a16="http://schemas.microsoft.com/office/drawing/2014/main" id="{38F83E13-DC6D-4E0F-A0AF-E972BBFF4E8F}"/>
               </a:ext>
             </a:extLst>
           </p:cNvPr>
@@ -15215,7 +15215,7 @@
           <p:cNvPr id="8" name="">
             <a:extLst xmlns:a="http://schemas.openxmlformats.org/drawingml/2006/main">
               <a:ext uri="{FF2B5EF4-FFF2-40B4-BE49-F238E27FC236}">
-                <a16:creationId xmlns:a16="http://schemas.microsoft.com/office/drawing/2014/main" id="{946C9E3E-3811-4376-8F64-8E7204795B05}"/>
+                <a16:creationId xmlns:a16="http://schemas.microsoft.com/office/drawing/2014/main" id="{83A12EF9-3214-4EC4-A44F-6E146D88E9C4}"/>
               </a:ext>
             </a:extLst>
           </p:cNvPr>
@@ -15250,7 +15250,7 @@
           <p:cNvPr id="9" name="">
             <a:extLst xmlns:a="http://schemas.openxmlformats.org/drawingml/2006/main">
               <a:ext uri="{FF2B5EF4-FFF2-40B4-BE49-F238E27FC236}">
-                <a16:creationId xmlns:a16="http://schemas.microsoft.com/office/drawing/2014/main" id="{286CC5F1-9D96-4A6F-8760-97890D4DFC3F}"/>
+                <a16:creationId xmlns:a16="http://schemas.microsoft.com/office/drawing/2014/main" id="{FFAA4EA3-60CF-4F4F-B4BF-D6DB89197921}"/>
               </a:ext>
             </a:extLst>
           </p:cNvPr>
@@ -15308,7 +15308,7 @@
           <p:cNvPr id="10" name="">
             <a:extLst xmlns:a="http://schemas.openxmlformats.org/drawingml/2006/main">
               <a:ext uri="{FF2B5EF4-FFF2-40B4-BE49-F238E27FC236}">
-                <a16:creationId xmlns:a16="http://schemas.microsoft.com/office/drawing/2014/main" id="{A2F6F693-CE79-4D3A-8A40-C8C0EA6DD52F}"/>
+                <a16:creationId xmlns:a16="http://schemas.microsoft.com/office/drawing/2014/main" id="{0E011631-7065-4E6D-B029-D1A70A08A100}"/>
               </a:ext>
             </a:extLst>
           </p:cNvPr>
@@ -15389,7 +15389,7 @@
           <p:cNvPr id="11" name="">
             <a:extLst xmlns:a="http://schemas.openxmlformats.org/drawingml/2006/main">
               <a:ext uri="{FF2B5EF4-FFF2-40B4-BE49-F238E27FC236}">
-                <a16:creationId xmlns:a16="http://schemas.microsoft.com/office/drawing/2014/main" id="{BE294184-6370-4796-A333-2F0475897AAE}"/>
+                <a16:creationId xmlns:a16="http://schemas.microsoft.com/office/drawing/2014/main" id="{A39B6B30-1AD3-41C3-8F6F-56A2E72ACDC5}"/>
               </a:ext>
             </a:extLst>
           </p:cNvPr>
@@ -15422,7 +15422,7 @@
           <p:cNvPr id="12" name="">
             <a:extLst xmlns:a="http://schemas.openxmlformats.org/drawingml/2006/main">
               <a:ext uri="{FF2B5EF4-FFF2-40B4-BE49-F238E27FC236}">
-                <a16:creationId xmlns:a16="http://schemas.microsoft.com/office/drawing/2014/main" id="{77463BE5-1B30-4F8D-AF53-AC395C0DA84C}"/>
+                <a16:creationId xmlns:a16="http://schemas.microsoft.com/office/drawing/2014/main" id="{13F4F76E-D188-4524-AF79-88A752E9F5FF}"/>
               </a:ext>
             </a:extLst>
           </p:cNvPr>
@@ -15457,7 +15457,7 @@
           <p:cNvPr id="13" name="">
             <a:extLst xmlns:a="http://schemas.openxmlformats.org/drawingml/2006/main">
               <a:ext uri="{FF2B5EF4-FFF2-40B4-BE49-F238E27FC236}">
-                <a16:creationId xmlns:a16="http://schemas.microsoft.com/office/drawing/2014/main" id="{E289C17D-25E4-4ADA-A593-88829E72620F}"/>
+                <a16:creationId xmlns:a16="http://schemas.microsoft.com/office/drawing/2014/main" id="{27D628AC-0687-42B2-BC62-0A3446E30D5D}"/>
               </a:ext>
             </a:extLst>
           </p:cNvPr>
@@ -15515,7 +15515,7 @@
           <p:cNvPr id="14" name="">
             <a:extLst xmlns:a="http://schemas.openxmlformats.org/drawingml/2006/main">
               <a:ext uri="{FF2B5EF4-FFF2-40B4-BE49-F238E27FC236}">
-                <a16:creationId xmlns:a16="http://schemas.microsoft.com/office/drawing/2014/main" id="{03498F29-84E5-436F-88EF-ACDEE6AE396E}"/>
+                <a16:creationId xmlns:a16="http://schemas.microsoft.com/office/drawing/2014/main" id="{2E7D7E72-403C-4A34-9D15-206DE447FAFD}"/>
               </a:ext>
             </a:extLst>
           </p:cNvPr>
@@ -15596,7 +15596,7 @@
           <p:cNvPr id="15" name="">
             <a:extLst xmlns:a="http://schemas.openxmlformats.org/drawingml/2006/main">
               <a:ext uri="{FF2B5EF4-FFF2-40B4-BE49-F238E27FC236}">
-                <a16:creationId xmlns:a16="http://schemas.microsoft.com/office/drawing/2014/main" id="{7F526ECE-DFC7-4813-971C-57110049B122}"/>
+                <a16:creationId xmlns:a16="http://schemas.microsoft.com/office/drawing/2014/main" id="{42C6FEBA-5927-416C-81DB-1700987F5E91}"/>
               </a:ext>
             </a:extLst>
           </p:cNvPr>
@@ -15629,7 +15629,7 @@
           <p:cNvPr id="16" name="">
             <a:extLst xmlns:a="http://schemas.openxmlformats.org/drawingml/2006/main">
               <a:ext uri="{FF2B5EF4-FFF2-40B4-BE49-F238E27FC236}">
-                <a16:creationId xmlns:a16="http://schemas.microsoft.com/office/drawing/2014/main" id="{AF8AF039-7532-4BEB-9544-B200B45E1CAB}"/>
+                <a16:creationId xmlns:a16="http://schemas.microsoft.com/office/drawing/2014/main" id="{4B2D2750-BC67-4223-A6EC-DD13FB8E5869}"/>
               </a:ext>
             </a:extLst>
           </p:cNvPr>
@@ -15664,7 +15664,7 @@
           <p:cNvPr id="17" name="">
             <a:extLst xmlns:a="http://schemas.openxmlformats.org/drawingml/2006/main">
               <a:ext uri="{FF2B5EF4-FFF2-40B4-BE49-F238E27FC236}">
-                <a16:creationId xmlns:a16="http://schemas.microsoft.com/office/drawing/2014/main" id="{D90A913D-0761-4278-9ABD-C49F5545D344}"/>
+                <a16:creationId xmlns:a16="http://schemas.microsoft.com/office/drawing/2014/main" id="{9B3ACB0E-310D-4627-A8B7-86C3E72920DE}"/>
               </a:ext>
             </a:extLst>
           </p:cNvPr>
@@ -15722,7 +15722,7 @@
           <p:cNvPr id="18" name="">
             <a:extLst xmlns:a="http://schemas.openxmlformats.org/drawingml/2006/main">
               <a:ext uri="{FF2B5EF4-FFF2-40B4-BE49-F238E27FC236}">
-                <a16:creationId xmlns:a16="http://schemas.microsoft.com/office/drawing/2014/main" id="{1A589B71-5598-49FA-A16F-89CB3292101F}"/>
+                <a16:creationId xmlns:a16="http://schemas.microsoft.com/office/drawing/2014/main" id="{1E10291D-8B9A-472B-919B-F68FF45F8FBE}"/>
               </a:ext>
             </a:extLst>
           </p:cNvPr>
@@ -15780,7 +15780,7 @@
           <p:cNvPr id="19" name="">
             <a:extLst xmlns:a="http://schemas.openxmlformats.org/drawingml/2006/main">
               <a:ext uri="{FF2B5EF4-FFF2-40B4-BE49-F238E27FC236}">
-                <a16:creationId xmlns:a16="http://schemas.microsoft.com/office/drawing/2014/main" id="{648718A0-A68A-48DC-9806-63448F4B0DC6}"/>
+                <a16:creationId xmlns:a16="http://schemas.microsoft.com/office/drawing/2014/main" id="{8325020A-54CE-4010-901B-89216B4241ED}"/>
               </a:ext>
             </a:extLst>
           </p:cNvPr>
@@ -15815,7 +15815,7 @@
           <p:cNvPr id="20" name="">
             <a:extLst xmlns:a="http://schemas.openxmlformats.org/drawingml/2006/main">
               <a:ext uri="{FF2B5EF4-FFF2-40B4-BE49-F238E27FC236}">
-                <a16:creationId xmlns:a16="http://schemas.microsoft.com/office/drawing/2014/main" id="{BFAE107B-086A-420F-8EEA-CBCB0797A145}"/>
+                <a16:creationId xmlns:a16="http://schemas.microsoft.com/office/drawing/2014/main" id="{3DA6AC11-C08D-4C40-8ED9-A2D694E1B320}"/>
               </a:ext>
             </a:extLst>
           </p:cNvPr>
@@ -15871,7 +15871,7 @@
     </p:spTree>
     <p:extLst>
       <p:ext uri="{BB962C8B-B14F-4D97-AF65-F5344CB8AC3E}">
-        <p14:creationId xmlns:p14="http://schemas.microsoft.com/office/powerpoint/2010/main" val="137562201"/>
+        <p14:creationId xmlns:p14="http://schemas.microsoft.com/office/powerpoint/2010/main" val="293611861"/>
       </p:ext>
     </p:extLst>
   </p:cSld>
@@ -15895,7 +15895,7 @@
           <p:cNvPr id="11" name="">
             <a:extLst xmlns:a="http://schemas.openxmlformats.org/drawingml/2006/main">
               <a:ext uri="{FF2B5EF4-FFF2-40B4-BE49-F238E27FC236}">
-                <a16:creationId xmlns:a16="http://schemas.microsoft.com/office/drawing/2014/main" id="{3AE526A0-33BA-47F5-83A2-54C01A8B5392}"/>
+                <a16:creationId xmlns:a16="http://schemas.microsoft.com/office/drawing/2014/main" id="{4FD9E79A-1A85-4AEB-8BF6-C7D7506F785B}"/>
               </a:ext>
             </a:extLst>
           </p:cNvPr>
@@ -15953,7 +15953,7 @@
           <p:cNvPr id="2" name="">
             <a:extLst xmlns:a="http://schemas.openxmlformats.org/drawingml/2006/main">
               <a:ext uri="{FF2B5EF4-FFF2-40B4-BE49-F238E27FC236}">
-                <a16:creationId xmlns:a16="http://schemas.microsoft.com/office/drawing/2014/main" id="{1EEC29CC-D2DC-412C-BAD0-524E0312E437}"/>
+                <a16:creationId xmlns:a16="http://schemas.microsoft.com/office/drawing/2014/main" id="{2335303A-E9CD-464B-919A-D0413F7AEE2A}"/>
               </a:ext>
             </a:extLst>
           </p:cNvPr>
@@ -16011,19 +16011,19 @@
           <p:cNvPr id="3" name="">
             <a:extLst xmlns:a="http://schemas.openxmlformats.org/drawingml/2006/main">
               <a:ext uri="{FF2B5EF4-FFF2-40B4-BE49-F238E27FC236}">
-                <a16:creationId xmlns:a16="http://schemas.microsoft.com/office/drawing/2014/main" id="{4643FC35-9433-44AE-9A6C-FF7DC804B630}"/>
-              </a:ext>
-            </a:extLst>
-          </p:cNvPr>
-          <p:cNvSpPr>
-            <a:spLocks xmlns:a="http://schemas.openxmlformats.org/drawingml/2006/main" noGrp="1"/>
-          </p:cNvSpPr>
-          <p:nvPr/>
-        </p:nvSpPr>
-        <p:spPr>
-          <a:xfrm xmlns:a="http://schemas.openxmlformats.org/drawingml/2006/main">
-            <a:off x="11239500" y="6334125"/>
-            <a:ext cx="552450" cy="190500"/>
+                <a16:creationId xmlns:a16="http://schemas.microsoft.com/office/drawing/2014/main" id="{6CCFE427-6589-4223-9A14-7B0E8BD71229}"/>
+              </a:ext>
+            </a:extLst>
+          </p:cNvPr>
+          <p:cNvSpPr>
+            <a:spLocks xmlns:a="http://schemas.openxmlformats.org/drawingml/2006/main" noGrp="1"/>
+          </p:cNvSpPr>
+          <p:nvPr/>
+        </p:nvSpPr>
+        <p:spPr>
+          <a:xfrm xmlns:a="http://schemas.openxmlformats.org/drawingml/2006/main">
+            <a:off x="10953750" y="6334125"/>
+            <a:ext cx="838200" cy="190500"/>
           </a:xfrm>
           <a:prstGeom xmlns:a="http://schemas.openxmlformats.org/drawingml/2006/main" prst="rect">
             <a:avLst/>
@@ -16069,7 +16069,7 @@
           <p:cNvPr id="4" name="">
             <a:extLst xmlns:a="http://schemas.openxmlformats.org/drawingml/2006/main">
               <a:ext uri="{FF2B5EF4-FFF2-40B4-BE49-F238E27FC236}">
-                <a16:creationId xmlns:a16="http://schemas.microsoft.com/office/drawing/2014/main" id="{37AFACDB-482B-4DDF-9DD8-5FF7E51567B6}"/>
+                <a16:creationId xmlns:a16="http://schemas.microsoft.com/office/drawing/2014/main" id="{A90D991D-8BDA-4269-B370-C700170C20EF}"/>
               </a:ext>
             </a:extLst>
           </p:cNvPr>
@@ -16127,7 +16127,7 @@
           <p:cNvPr id="5" name="">
             <a:extLst xmlns:a="http://schemas.openxmlformats.org/drawingml/2006/main">
               <a:ext uri="{FF2B5EF4-FFF2-40B4-BE49-F238E27FC236}">
-                <a16:creationId xmlns:a16="http://schemas.microsoft.com/office/drawing/2014/main" id="{EA32056E-A6D6-43CA-BFBB-316EAA0491E0}"/>
+                <a16:creationId xmlns:a16="http://schemas.microsoft.com/office/drawing/2014/main" id="{E4668E80-F50F-4DAD-83EC-61F9796408C4}"/>
               </a:ext>
             </a:extLst>
           </p:cNvPr>
@@ -16160,7 +16160,7 @@
           <p:cNvPr id="6" name="">
             <a:extLst xmlns:a="http://schemas.openxmlformats.org/drawingml/2006/main">
               <a:ext uri="{FF2B5EF4-FFF2-40B4-BE49-F238E27FC236}">
-                <a16:creationId xmlns:a16="http://schemas.microsoft.com/office/drawing/2014/main" id="{B4F6A4EF-0493-4D56-9FA6-4E3B59481C64}"/>
+                <a16:creationId xmlns:a16="http://schemas.microsoft.com/office/drawing/2014/main" id="{8CAD891C-2257-4BF1-91F2-DFA3C5E716F7}"/>
               </a:ext>
             </a:extLst>
           </p:cNvPr>
@@ -16218,7 +16218,7 @@
           <p:cNvPr id="7" name="">
             <a:extLst xmlns:a="http://schemas.openxmlformats.org/drawingml/2006/main">
               <a:ext uri="{FF2B5EF4-FFF2-40B4-BE49-F238E27FC236}">
-                <a16:creationId xmlns:a16="http://schemas.microsoft.com/office/drawing/2014/main" id="{CE003830-3A0B-4403-9BA0-688E0717A6C8}"/>
+                <a16:creationId xmlns:a16="http://schemas.microsoft.com/office/drawing/2014/main" id="{16729135-5281-409E-8E42-1B37B1A11666}"/>
               </a:ext>
             </a:extLst>
           </p:cNvPr>
@@ -16251,7 +16251,7 @@
           <p:cNvPr id="8" name="">
             <a:extLst xmlns:a="http://schemas.openxmlformats.org/drawingml/2006/main">
               <a:ext uri="{FF2B5EF4-FFF2-40B4-BE49-F238E27FC236}">
-                <a16:creationId xmlns:a16="http://schemas.microsoft.com/office/drawing/2014/main" id="{F75D397F-C28D-44F1-8E06-2D14E3B2A0FC}"/>
+                <a16:creationId xmlns:a16="http://schemas.microsoft.com/office/drawing/2014/main" id="{DCB5FC42-D31B-4C8E-939F-3ECAD69268B9}"/>
               </a:ext>
             </a:extLst>
           </p:cNvPr>
@@ -16309,7 +16309,7 @@
           <p:cNvPr id="9" name="">
             <a:extLst xmlns:a="http://schemas.openxmlformats.org/drawingml/2006/main">
               <a:ext uri="{FF2B5EF4-FFF2-40B4-BE49-F238E27FC236}">
-                <a16:creationId xmlns:a16="http://schemas.microsoft.com/office/drawing/2014/main" id="{AE3B6F2B-02A6-439E-B68F-02ED18EF9162}"/>
+                <a16:creationId xmlns:a16="http://schemas.microsoft.com/office/drawing/2014/main" id="{A2BB3F2F-AE9F-40C7-8181-7CE1D2517E24}"/>
               </a:ext>
             </a:extLst>
           </p:cNvPr>
@@ -16367,7 +16367,7 @@
           <p:cNvPr id="10" name="">
             <a:extLst xmlns:a="http://schemas.openxmlformats.org/drawingml/2006/main">
               <a:ext uri="{FF2B5EF4-FFF2-40B4-BE49-F238E27FC236}">
-                <a16:creationId xmlns:a16="http://schemas.microsoft.com/office/drawing/2014/main" id="{E08D7DD1-8604-46E9-94B2-5EC768C0BFF9}"/>
+                <a16:creationId xmlns:a16="http://schemas.microsoft.com/office/drawing/2014/main" id="{5CAF5D6F-8CAF-4BD1-AAAC-1093201F9EF8}"/>
               </a:ext>
             </a:extLst>
           </p:cNvPr>
@@ -16423,7 +16423,7 @@
     </p:spTree>
     <p:extLst>
       <p:ext uri="{BB962C8B-B14F-4D97-AF65-F5344CB8AC3E}">
-        <p14:creationId xmlns:p14="http://schemas.microsoft.com/office/powerpoint/2010/main" val="497641861"/>
+        <p14:creationId xmlns:p14="http://schemas.microsoft.com/office/powerpoint/2010/main" val="294902858"/>
       </p:ext>
     </p:extLst>
   </p:cSld>
@@ -16447,7 +16447,7 @@
           <p:cNvPr id="14" name="">
             <a:extLst xmlns:a="http://schemas.openxmlformats.org/drawingml/2006/main">
               <a:ext uri="{FF2B5EF4-FFF2-40B4-BE49-F238E27FC236}">
-                <a16:creationId xmlns:a16="http://schemas.microsoft.com/office/drawing/2014/main" id="{461AD808-E1F4-41FD-B45D-AF8120BF855F}"/>
+                <a16:creationId xmlns:a16="http://schemas.microsoft.com/office/drawing/2014/main" id="{D2D7CEB1-0E56-42DD-8BFA-D1E0E8FB8621}"/>
               </a:ext>
             </a:extLst>
           </p:cNvPr>
@@ -16505,7 +16505,7 @@
           <p:cNvPr id="2" name="">
             <a:extLst xmlns:a="http://schemas.openxmlformats.org/drawingml/2006/main">
               <a:ext uri="{FF2B5EF4-FFF2-40B4-BE49-F238E27FC236}">
-                <a16:creationId xmlns:a16="http://schemas.microsoft.com/office/drawing/2014/main" id="{210189E2-3B8E-4440-9668-0990E42AEA91}"/>
+                <a16:creationId xmlns:a16="http://schemas.microsoft.com/office/drawing/2014/main" id="{B629B2F0-2A25-44D3-9C7B-43F9443E4F4C}"/>
               </a:ext>
             </a:extLst>
           </p:cNvPr>
@@ -16563,19 +16563,19 @@
           <p:cNvPr id="3" name="">
             <a:extLst xmlns:a="http://schemas.openxmlformats.org/drawingml/2006/main">
               <a:ext uri="{FF2B5EF4-FFF2-40B4-BE49-F238E27FC236}">
-                <a16:creationId xmlns:a16="http://schemas.microsoft.com/office/drawing/2014/main" id="{D0F1647E-BC65-4B25-AF14-5DE58DF6205C}"/>
-              </a:ext>
-            </a:extLst>
-          </p:cNvPr>
-          <p:cNvSpPr>
-            <a:spLocks xmlns:a="http://schemas.openxmlformats.org/drawingml/2006/main" noGrp="1"/>
-          </p:cNvSpPr>
-          <p:nvPr/>
-        </p:nvSpPr>
-        <p:spPr>
-          <a:xfrm xmlns:a="http://schemas.openxmlformats.org/drawingml/2006/main">
-            <a:off x="11239500" y="6334125"/>
-            <a:ext cx="552450" cy="190500"/>
+                <a16:creationId xmlns:a16="http://schemas.microsoft.com/office/drawing/2014/main" id="{2A27E5E6-CDA5-4E06-9899-63E430629F62}"/>
+              </a:ext>
+            </a:extLst>
+          </p:cNvPr>
+          <p:cNvSpPr>
+            <a:spLocks xmlns:a="http://schemas.openxmlformats.org/drawingml/2006/main" noGrp="1"/>
+          </p:cNvSpPr>
+          <p:nvPr/>
+        </p:nvSpPr>
+        <p:spPr>
+          <a:xfrm xmlns:a="http://schemas.openxmlformats.org/drawingml/2006/main">
+            <a:off x="10953750" y="6334125"/>
+            <a:ext cx="838200" cy="190500"/>
           </a:xfrm>
           <a:prstGeom xmlns:a="http://schemas.openxmlformats.org/drawingml/2006/main" prst="rect">
             <a:avLst/>
@@ -16621,7 +16621,7 @@
           <p:cNvPr id="4" name="">
             <a:extLst xmlns:a="http://schemas.openxmlformats.org/drawingml/2006/main">
               <a:ext uri="{FF2B5EF4-FFF2-40B4-BE49-F238E27FC236}">
-                <a16:creationId xmlns:a16="http://schemas.microsoft.com/office/drawing/2014/main" id="{E05CC433-E21C-4409-99C1-BA0684C55FC6}"/>
+                <a16:creationId xmlns:a16="http://schemas.microsoft.com/office/drawing/2014/main" id="{FF69661D-51C5-40E0-BB9E-88D4BBB66956}"/>
               </a:ext>
             </a:extLst>
           </p:cNvPr>
@@ -16656,7 +16656,7 @@
           <p:cNvPr id="5" name="">
             <a:extLst xmlns:a="http://schemas.openxmlformats.org/drawingml/2006/main">
               <a:ext uri="{FF2B5EF4-FFF2-40B4-BE49-F238E27FC236}">
-                <a16:creationId xmlns:a16="http://schemas.microsoft.com/office/drawing/2014/main" id="{BFE5F3CB-80AB-4293-A14B-68CA0164C73C}"/>
+                <a16:creationId xmlns:a16="http://schemas.microsoft.com/office/drawing/2014/main" id="{18EE978B-378E-49E4-A58A-9BE412599CD2}"/>
               </a:ext>
             </a:extLst>
           </p:cNvPr>
@@ -16714,7 +16714,7 @@
           <p:cNvPr id="6" name="">
             <a:extLst xmlns:a="http://schemas.openxmlformats.org/drawingml/2006/main">
               <a:ext uri="{FF2B5EF4-FFF2-40B4-BE49-F238E27FC236}">
-                <a16:creationId xmlns:a16="http://schemas.microsoft.com/office/drawing/2014/main" id="{01A52D49-D290-47DA-85F4-CC81B031BA67}"/>
+                <a16:creationId xmlns:a16="http://schemas.microsoft.com/office/drawing/2014/main" id="{556F341A-07E5-4FE3-9124-A0FAA4B4AEC7}"/>
               </a:ext>
             </a:extLst>
           </p:cNvPr>
@@ -16864,7 +16864,7 @@
           <p:cNvPr id="7" name="">
             <a:extLst xmlns:a="http://schemas.openxmlformats.org/drawingml/2006/main">
               <a:ext uri="{FF2B5EF4-FFF2-40B4-BE49-F238E27FC236}">
-                <a16:creationId xmlns:a16="http://schemas.microsoft.com/office/drawing/2014/main" id="{131C0541-FAB4-46B9-B6F1-6DA45157BF3A}"/>
+                <a16:creationId xmlns:a16="http://schemas.microsoft.com/office/drawing/2014/main" id="{1B7F47B5-0270-4F32-8347-8C2EE1031581}"/>
               </a:ext>
             </a:extLst>
           </p:cNvPr>
@@ -16899,7 +16899,7 @@
           <p:cNvPr id="8" name="">
             <a:extLst xmlns:a="http://schemas.openxmlformats.org/drawingml/2006/main">
               <a:ext uri="{FF2B5EF4-FFF2-40B4-BE49-F238E27FC236}">
-                <a16:creationId xmlns:a16="http://schemas.microsoft.com/office/drawing/2014/main" id="{37441CE0-617A-4780-ACAE-5F660461EE35}"/>
+                <a16:creationId xmlns:a16="http://schemas.microsoft.com/office/drawing/2014/main" id="{5A3FB10C-A5EF-4234-A7AF-4290D22C6692}"/>
               </a:ext>
             </a:extLst>
           </p:cNvPr>
@@ -16957,7 +16957,7 @@
           <p:cNvPr id="9" name="">
             <a:extLst xmlns:a="http://schemas.openxmlformats.org/drawingml/2006/main">
               <a:ext uri="{FF2B5EF4-FFF2-40B4-BE49-F238E27FC236}">
-                <a16:creationId xmlns:a16="http://schemas.microsoft.com/office/drawing/2014/main" id="{31EE3C36-19D4-4AA6-B8D2-A9F1A5A1513D}"/>
+                <a16:creationId xmlns:a16="http://schemas.microsoft.com/office/drawing/2014/main" id="{66B53DFD-7460-4677-A60C-2D3DD4C1923C}"/>
               </a:ext>
             </a:extLst>
           </p:cNvPr>
@@ -17084,7 +17084,7 @@
           <p:cNvPr id="10" name="">
             <a:extLst xmlns:a="http://schemas.openxmlformats.org/drawingml/2006/main">
               <a:ext uri="{FF2B5EF4-FFF2-40B4-BE49-F238E27FC236}">
-                <a16:creationId xmlns:a16="http://schemas.microsoft.com/office/drawing/2014/main" id="{2510C8F3-6CF0-4B4A-B5B2-4F95B7116314}"/>
+                <a16:creationId xmlns:a16="http://schemas.microsoft.com/office/drawing/2014/main" id="{4A5626DF-46AA-4F24-8FAE-030323E3F308}"/>
               </a:ext>
             </a:extLst>
           </p:cNvPr>
@@ -17119,7 +17119,7 @@
           <p:cNvPr id="11" name="">
             <a:extLst xmlns:a="http://schemas.openxmlformats.org/drawingml/2006/main">
               <a:ext uri="{FF2B5EF4-FFF2-40B4-BE49-F238E27FC236}">
-                <a16:creationId xmlns:a16="http://schemas.microsoft.com/office/drawing/2014/main" id="{657B37ED-5928-444C-A747-7FF2FEABD54E}"/>
+                <a16:creationId xmlns:a16="http://schemas.microsoft.com/office/drawing/2014/main" id="{F69C4F58-41A4-41A8-9082-1FCA88E04A44}"/>
               </a:ext>
             </a:extLst>
           </p:cNvPr>
@@ -17177,7 +17177,7 @@
           <p:cNvPr id="12" name="">
             <a:extLst xmlns:a="http://schemas.openxmlformats.org/drawingml/2006/main">
               <a:ext uri="{FF2B5EF4-FFF2-40B4-BE49-F238E27FC236}">
-                <a16:creationId xmlns:a16="http://schemas.microsoft.com/office/drawing/2014/main" id="{A39EF6E1-B7E6-40B7-B0D5-DB024D27AA18}"/>
+                <a16:creationId xmlns:a16="http://schemas.microsoft.com/office/drawing/2014/main" id="{DFF4F071-7E51-4DAE-9AA1-F5524E44257B}"/>
               </a:ext>
             </a:extLst>
           </p:cNvPr>
@@ -17304,7 +17304,7 @@
           <p:cNvPr id="13" name="">
             <a:extLst xmlns:a="http://schemas.openxmlformats.org/drawingml/2006/main">
               <a:ext uri="{FF2B5EF4-FFF2-40B4-BE49-F238E27FC236}">
-                <a16:creationId xmlns:a16="http://schemas.microsoft.com/office/drawing/2014/main" id="{16A46A87-30B4-44E0-B570-C2898642384C}"/>
+                <a16:creationId xmlns:a16="http://schemas.microsoft.com/office/drawing/2014/main" id="{B02A08C1-D856-4767-8B40-4EF25176A7AB}"/>
               </a:ext>
             </a:extLst>
           </p:cNvPr>
@@ -17360,7 +17360,7 @@
     </p:spTree>
     <p:extLst>
       <p:ext uri="{BB962C8B-B14F-4D97-AF65-F5344CB8AC3E}">
-        <p14:creationId xmlns:p14="http://schemas.microsoft.com/office/powerpoint/2010/main" val="197201473"/>
+        <p14:creationId xmlns:p14="http://schemas.microsoft.com/office/powerpoint/2010/main" val="2009712489"/>
       </p:ext>
     </p:extLst>
   </p:cSld>
@@ -17384,7 +17384,7 @@
           <p:cNvPr id="35" name="">
             <a:extLst xmlns:a="http://schemas.openxmlformats.org/drawingml/2006/main">
               <a:ext uri="{FF2B5EF4-FFF2-40B4-BE49-F238E27FC236}">
-                <a16:creationId xmlns:a16="http://schemas.microsoft.com/office/drawing/2014/main" id="{56B92817-3323-430A-A629-861D3044567B}"/>
+                <a16:creationId xmlns:a16="http://schemas.microsoft.com/office/drawing/2014/main" id="{1D8F4FF7-3350-4B45-8471-734B0FD9531A}"/>
               </a:ext>
             </a:extLst>
           </p:cNvPr>
@@ -17442,7 +17442,7 @@
           <p:cNvPr id="2" name="">
             <a:extLst xmlns:a="http://schemas.openxmlformats.org/drawingml/2006/main">
               <a:ext uri="{FF2B5EF4-FFF2-40B4-BE49-F238E27FC236}">
-                <a16:creationId xmlns:a16="http://schemas.microsoft.com/office/drawing/2014/main" id="{3C2873CC-473E-484C-A37D-A2A47E612156}"/>
+                <a16:creationId xmlns:a16="http://schemas.microsoft.com/office/drawing/2014/main" id="{54BC4A8B-3B85-496D-B2B6-42FED161133A}"/>
               </a:ext>
             </a:extLst>
           </p:cNvPr>
@@ -17500,19 +17500,19 @@
           <p:cNvPr id="3" name="">
             <a:extLst xmlns:a="http://schemas.openxmlformats.org/drawingml/2006/main">
               <a:ext uri="{FF2B5EF4-FFF2-40B4-BE49-F238E27FC236}">
-                <a16:creationId xmlns:a16="http://schemas.microsoft.com/office/drawing/2014/main" id="{0D0A5008-27EE-4FE4-9837-3610E47CBA4C}"/>
-              </a:ext>
-            </a:extLst>
-          </p:cNvPr>
-          <p:cNvSpPr>
-            <a:spLocks xmlns:a="http://schemas.openxmlformats.org/drawingml/2006/main" noGrp="1"/>
-          </p:cNvSpPr>
-          <p:nvPr/>
-        </p:nvSpPr>
-        <p:spPr>
-          <a:xfrm xmlns:a="http://schemas.openxmlformats.org/drawingml/2006/main">
-            <a:off x="11239500" y="6334125"/>
-            <a:ext cx="552450" cy="190500"/>
+                <a16:creationId xmlns:a16="http://schemas.microsoft.com/office/drawing/2014/main" id="{0BE52085-DF8F-4183-8A30-2C1F88405AF0}"/>
+              </a:ext>
+            </a:extLst>
+          </p:cNvPr>
+          <p:cNvSpPr>
+            <a:spLocks xmlns:a="http://schemas.openxmlformats.org/drawingml/2006/main" noGrp="1"/>
+          </p:cNvSpPr>
+          <p:nvPr/>
+        </p:nvSpPr>
+        <p:spPr>
+          <a:xfrm xmlns:a="http://schemas.openxmlformats.org/drawingml/2006/main">
+            <a:off x="10953750" y="6334125"/>
+            <a:ext cx="838200" cy="190500"/>
           </a:xfrm>
           <a:prstGeom xmlns:a="http://schemas.openxmlformats.org/drawingml/2006/main" prst="rect">
             <a:avLst/>
@@ -17558,7 +17558,7 @@
           <p:cNvPr id="4" name="">
             <a:extLst xmlns:a="http://schemas.openxmlformats.org/drawingml/2006/main">
               <a:ext uri="{FF2B5EF4-FFF2-40B4-BE49-F238E27FC236}">
-                <a16:creationId xmlns:a16="http://schemas.microsoft.com/office/drawing/2014/main" id="{0E56B4E5-1572-421B-8A8F-4547ACAAD231}"/>
+                <a16:creationId xmlns:a16="http://schemas.microsoft.com/office/drawing/2014/main" id="{6033A757-9114-47F3-9807-0522B0EB5953}"/>
               </a:ext>
             </a:extLst>
           </p:cNvPr>
@@ -17593,7 +17593,7 @@
           <p:cNvPr id="5" name="">
             <a:extLst xmlns:a="http://schemas.openxmlformats.org/drawingml/2006/main">
               <a:ext uri="{FF2B5EF4-FFF2-40B4-BE49-F238E27FC236}">
-                <a16:creationId xmlns:a16="http://schemas.microsoft.com/office/drawing/2014/main" id="{FC3A2A9E-E8EC-40A0-905E-58C17C1F6456}"/>
+                <a16:creationId xmlns:a16="http://schemas.microsoft.com/office/drawing/2014/main" id="{A6349349-F620-42AC-915C-854E90ADAD2D}"/>
               </a:ext>
             </a:extLst>
           </p:cNvPr>
@@ -17641,7 +17641,7 @@
                 <a:ea typeface="Microsoft YaHei"/>
                 <a:cs typeface="Microsoft YaHei"/>
               </a:rPr>
-              <a:t>离线调参 / 训练 / LLM</a:t>
+              <a:t>离线调参 / 训练 / Agent上位机</a:t>
             </a:r>
           </a:p>
         </p:txBody>
@@ -17651,7 +17651,7 @@
           <p:cNvPr id="6" name="">
             <a:extLst xmlns:a="http://schemas.openxmlformats.org/drawingml/2006/main">
               <a:ext uri="{FF2B5EF4-FFF2-40B4-BE49-F238E27FC236}">
-                <a16:creationId xmlns:a16="http://schemas.microsoft.com/office/drawing/2014/main" id="{C1FCD34D-714C-46A8-9500-FE393F43192F}"/>
+                <a16:creationId xmlns:a16="http://schemas.microsoft.com/office/drawing/2014/main" id="{9F961F8F-7FDA-4F6E-A169-5561C749B5AE}"/>
               </a:ext>
             </a:extLst>
           </p:cNvPr>
@@ -17699,7 +17699,7 @@
                 <a:ea typeface="Microsoft YaHei"/>
                 <a:cs typeface="Microsoft YaHei"/>
               </a:rPr>
-              <a:t>Z-N · IMC · BO · Safe BO · FNN/RL训练 · LLM</a:t>
+              <a:t>Z-N · IMC · BO · Safe BO · FNN/RL训练 · LLM Agent</a:t>
             </a:r>
           </a:p>
           <a:p xmlns:a="http://schemas.openxmlformats.org/drawingml/2006/main">
@@ -17722,7 +17722,7 @@
                 <a:ea typeface="Microsoft YaHei"/>
                 <a:cs typeface="Microsoft YaHei"/>
               </a:rPr>
-              <a:t>只导出通过验收的增益或冻结策略</a:t>
+              <a:t>Agent只编排仿真；仅导出已验收参数</a:t>
             </a:r>
           </a:p>
         </p:txBody>
@@ -17732,7 +17732,7 @@
           <p:cNvPr id="7" name="">
             <a:extLst xmlns:a="http://schemas.openxmlformats.org/drawingml/2006/main">
               <a:ext uri="{FF2B5EF4-FFF2-40B4-BE49-F238E27FC236}">
-                <a16:creationId xmlns:a16="http://schemas.microsoft.com/office/drawing/2014/main" id="{5F83B309-E046-41D9-85DA-3B327EDE7FF1}"/>
+                <a16:creationId xmlns:a16="http://schemas.microsoft.com/office/drawing/2014/main" id="{46079ACC-2C3F-4E5A-81E2-D759110C5F07}"/>
               </a:ext>
             </a:extLst>
           </p:cNvPr>
@@ -17767,7 +17767,7 @@
           <p:cNvPr id="8" name="">
             <a:extLst xmlns:a="http://schemas.openxmlformats.org/drawingml/2006/main">
               <a:ext uri="{FF2B5EF4-FFF2-40B4-BE49-F238E27FC236}">
-                <a16:creationId xmlns:a16="http://schemas.microsoft.com/office/drawing/2014/main" id="{E9B83DC9-DA0C-41E7-8940-55029D694EAE}"/>
+                <a16:creationId xmlns:a16="http://schemas.microsoft.com/office/drawing/2014/main" id="{20964756-7C98-4843-ABD2-3234D6B410D6}"/>
               </a:ext>
             </a:extLst>
           </p:cNvPr>
@@ -17825,7 +17825,7 @@
           <p:cNvPr id="9" name="">
             <a:extLst xmlns:a="http://schemas.openxmlformats.org/drawingml/2006/main">
               <a:ext uri="{FF2B5EF4-FFF2-40B4-BE49-F238E27FC236}">
-                <a16:creationId xmlns:a16="http://schemas.microsoft.com/office/drawing/2014/main" id="{A66F0932-1ACB-445C-B4E2-4CCC41BCE8E8}"/>
+                <a16:creationId xmlns:a16="http://schemas.microsoft.com/office/drawing/2014/main" id="{85E32EE1-82D5-4BFF-A462-0BE50FFC5E32}"/>
               </a:ext>
             </a:extLst>
           </p:cNvPr>
@@ -17883,7 +17883,7 @@
           <p:cNvPr id="10" name="">
             <a:extLst xmlns:a="http://schemas.openxmlformats.org/drawingml/2006/main">
               <a:ext uri="{FF2B5EF4-FFF2-40B4-BE49-F238E27FC236}">
-                <a16:creationId xmlns:a16="http://schemas.microsoft.com/office/drawing/2014/main" id="{0D136B5B-FA6B-4BC3-9B1F-DA89AFFA305A}"/>
+                <a16:creationId xmlns:a16="http://schemas.microsoft.com/office/drawing/2014/main" id="{FF2BCE51-E80B-4440-A02B-10CA4468308F}"/>
               </a:ext>
             </a:extLst>
           </p:cNvPr>
@@ -17916,7 +17916,7 @@
           <p:cNvPr id="11" name="">
             <a:extLst xmlns:a="http://schemas.openxmlformats.org/drawingml/2006/main">
               <a:ext uri="{FF2B5EF4-FFF2-40B4-BE49-F238E27FC236}">
-                <a16:creationId xmlns:a16="http://schemas.microsoft.com/office/drawing/2014/main" id="{F7789DDE-CCE8-4F46-AC49-0C1ACB702948}"/>
+                <a16:creationId xmlns:a16="http://schemas.microsoft.com/office/drawing/2014/main" id="{90C0B15F-5865-4B1E-A14C-CCDA3C3ACE0A}"/>
               </a:ext>
             </a:extLst>
           </p:cNvPr>
@@ -17951,7 +17951,7 @@
           <p:cNvPr id="12" name="">
             <a:extLst xmlns:a="http://schemas.openxmlformats.org/drawingml/2006/main">
               <a:ext uri="{FF2B5EF4-FFF2-40B4-BE49-F238E27FC236}">
-                <a16:creationId xmlns:a16="http://schemas.microsoft.com/office/drawing/2014/main" id="{FE7386FB-63EB-4478-981D-6358FAC2892A}"/>
+                <a16:creationId xmlns:a16="http://schemas.microsoft.com/office/drawing/2014/main" id="{FB460F95-4817-410B-80BB-C4B82D3B76A1}"/>
               </a:ext>
             </a:extLst>
           </p:cNvPr>
@@ -18009,7 +18009,7 @@
           <p:cNvPr id="13" name="">
             <a:extLst xmlns:a="http://schemas.openxmlformats.org/drawingml/2006/main">
               <a:ext uri="{FF2B5EF4-FFF2-40B4-BE49-F238E27FC236}">
-                <a16:creationId xmlns:a16="http://schemas.microsoft.com/office/drawing/2014/main" id="{3526CF35-E592-4A76-99F4-ADA44D87E23D}"/>
+                <a16:creationId xmlns:a16="http://schemas.microsoft.com/office/drawing/2014/main" id="{843BE46C-C85F-4E02-9B58-4A0D26E4C045}"/>
               </a:ext>
             </a:extLst>
           </p:cNvPr>
@@ -18067,7 +18067,7 @@
           <p:cNvPr id="14" name="">
             <a:extLst xmlns:a="http://schemas.openxmlformats.org/drawingml/2006/main">
               <a:ext uri="{FF2B5EF4-FFF2-40B4-BE49-F238E27FC236}">
-                <a16:creationId xmlns:a16="http://schemas.microsoft.com/office/drawing/2014/main" id="{E066DD7A-960A-4402-8B97-C89C811DCC26}"/>
+                <a16:creationId xmlns:a16="http://schemas.microsoft.com/office/drawing/2014/main" id="{3FA53717-9DF7-4EBA-8015-87144E9FB7D0}"/>
               </a:ext>
             </a:extLst>
           </p:cNvPr>
@@ -18100,7 +18100,7 @@
           <p:cNvPr id="15" name="">
             <a:extLst xmlns:a="http://schemas.openxmlformats.org/drawingml/2006/main">
               <a:ext uri="{FF2B5EF4-FFF2-40B4-BE49-F238E27FC236}">
-                <a16:creationId xmlns:a16="http://schemas.microsoft.com/office/drawing/2014/main" id="{DB2FB528-4F31-4406-9F0C-8D49769CDA08}"/>
+                <a16:creationId xmlns:a16="http://schemas.microsoft.com/office/drawing/2014/main" id="{8D7BDC0E-9773-404A-BC83-BA84D32663C2}"/>
               </a:ext>
             </a:extLst>
           </p:cNvPr>
@@ -18135,7 +18135,7 @@
           <p:cNvPr id="16" name="">
             <a:extLst xmlns:a="http://schemas.openxmlformats.org/drawingml/2006/main">
               <a:ext uri="{FF2B5EF4-FFF2-40B4-BE49-F238E27FC236}">
-                <a16:creationId xmlns:a16="http://schemas.microsoft.com/office/drawing/2014/main" id="{6142BABC-A5F4-4520-8A9C-FB7789F48497}"/>
+                <a16:creationId xmlns:a16="http://schemas.microsoft.com/office/drawing/2014/main" id="{E6DE2F63-B05D-4ED1-B94A-D3C48784AD5A}"/>
               </a:ext>
             </a:extLst>
           </p:cNvPr>
@@ -18193,7 +18193,7 @@
           <p:cNvPr id="17" name="">
             <a:extLst xmlns:a="http://schemas.openxmlformats.org/drawingml/2006/main">
               <a:ext uri="{FF2B5EF4-FFF2-40B4-BE49-F238E27FC236}">
-                <a16:creationId xmlns:a16="http://schemas.microsoft.com/office/drawing/2014/main" id="{91B1A5C0-53F6-4114-BA3A-6F950B4B8F96}"/>
+                <a16:creationId xmlns:a16="http://schemas.microsoft.com/office/drawing/2014/main" id="{2056A61C-46C6-4EF7-851B-869A3824354D}"/>
               </a:ext>
             </a:extLst>
           </p:cNvPr>
@@ -18274,7 +18274,7 @@
           <p:cNvPr id="18" name="">
             <a:extLst xmlns:a="http://schemas.openxmlformats.org/drawingml/2006/main">
               <a:ext uri="{FF2B5EF4-FFF2-40B4-BE49-F238E27FC236}">
-                <a16:creationId xmlns:a16="http://schemas.microsoft.com/office/drawing/2014/main" id="{5D54EA82-6A26-4CC9-92FF-12AE264A5AD3}"/>
+                <a16:creationId xmlns:a16="http://schemas.microsoft.com/office/drawing/2014/main" id="{44CE87CC-DE8E-4FE3-ADA5-15BFE7F805EF}"/>
               </a:ext>
             </a:extLst>
           </p:cNvPr>
@@ -18307,7 +18307,7 @@
           <p:cNvPr id="19" name="">
             <a:extLst xmlns:a="http://schemas.openxmlformats.org/drawingml/2006/main">
               <a:ext uri="{FF2B5EF4-FFF2-40B4-BE49-F238E27FC236}">
-                <a16:creationId xmlns:a16="http://schemas.microsoft.com/office/drawing/2014/main" id="{FF7C7B68-30CB-4A87-B0C6-D458271C7AEE}"/>
+                <a16:creationId xmlns:a16="http://schemas.microsoft.com/office/drawing/2014/main" id="{E04560EA-F07E-43AA-B54F-9BDE9E73197D}"/>
               </a:ext>
             </a:extLst>
           </p:cNvPr>
@@ -18342,7 +18342,7 @@
           <p:cNvPr id="20" name="">
             <a:extLst xmlns:a="http://schemas.openxmlformats.org/drawingml/2006/main">
               <a:ext uri="{FF2B5EF4-FFF2-40B4-BE49-F238E27FC236}">
-                <a16:creationId xmlns:a16="http://schemas.microsoft.com/office/drawing/2014/main" id="{BB617C6C-94CE-4E88-A1B0-4B3EC21380E2}"/>
+                <a16:creationId xmlns:a16="http://schemas.microsoft.com/office/drawing/2014/main" id="{5CA73724-030C-4F7D-9353-ABE4A3FD8E57}"/>
               </a:ext>
             </a:extLst>
           </p:cNvPr>
@@ -18400,7 +18400,7 @@
           <p:cNvPr id="21" name="">
             <a:extLst xmlns:a="http://schemas.openxmlformats.org/drawingml/2006/main">
               <a:ext uri="{FF2B5EF4-FFF2-40B4-BE49-F238E27FC236}">
-                <a16:creationId xmlns:a16="http://schemas.microsoft.com/office/drawing/2014/main" id="{0DD628F6-94F1-4405-8375-F0C22A968711}"/>
+                <a16:creationId xmlns:a16="http://schemas.microsoft.com/office/drawing/2014/main" id="{F3829507-B385-479E-8D5A-FCE53647D30B}"/>
               </a:ext>
             </a:extLst>
           </p:cNvPr>
@@ -18481,7 +18481,7 @@
           <p:cNvPr id="22" name="">
             <a:extLst xmlns:a="http://schemas.openxmlformats.org/drawingml/2006/main">
               <a:ext uri="{FF2B5EF4-FFF2-40B4-BE49-F238E27FC236}">
-                <a16:creationId xmlns:a16="http://schemas.microsoft.com/office/drawing/2014/main" id="{7544FCE1-B9AD-4A38-9621-3473B417F712}"/>
+                <a16:creationId xmlns:a16="http://schemas.microsoft.com/office/drawing/2014/main" id="{9BF0323A-7704-4204-9BC3-57869F1E2780}"/>
               </a:ext>
             </a:extLst>
           </p:cNvPr>
@@ -18514,7 +18514,7 @@
           <p:cNvPr id="23" name="">
             <a:extLst xmlns:a="http://schemas.openxmlformats.org/drawingml/2006/main">
               <a:ext uri="{FF2B5EF4-FFF2-40B4-BE49-F238E27FC236}">
-                <a16:creationId xmlns:a16="http://schemas.microsoft.com/office/drawing/2014/main" id="{B0950540-A3DA-4257-BE87-70CEC3E19A3C}"/>
+                <a16:creationId xmlns:a16="http://schemas.microsoft.com/office/drawing/2014/main" id="{B203EBAD-E115-4291-89BE-9CDBC6EC1F9A}"/>
               </a:ext>
             </a:extLst>
           </p:cNvPr>
@@ -18549,7 +18549,7 @@
           <p:cNvPr id="24" name="">
             <a:extLst xmlns:a="http://schemas.openxmlformats.org/drawingml/2006/main">
               <a:ext uri="{FF2B5EF4-FFF2-40B4-BE49-F238E27FC236}">
-                <a16:creationId xmlns:a16="http://schemas.microsoft.com/office/drawing/2014/main" id="{C78167E3-D1FE-4F68-B20B-282C7DDF7B19}"/>
+                <a16:creationId xmlns:a16="http://schemas.microsoft.com/office/drawing/2014/main" id="{80F2F2AE-7029-45CC-BF41-29C6DD3CA45C}"/>
               </a:ext>
             </a:extLst>
           </p:cNvPr>
@@ -18607,7 +18607,7 @@
           <p:cNvPr id="25" name="">
             <a:extLst xmlns:a="http://schemas.openxmlformats.org/drawingml/2006/main">
               <a:ext uri="{FF2B5EF4-FFF2-40B4-BE49-F238E27FC236}">
-                <a16:creationId xmlns:a16="http://schemas.microsoft.com/office/drawing/2014/main" id="{5C2B7662-94C0-4A29-9DF5-477B4B1C7B01}"/>
+                <a16:creationId xmlns:a16="http://schemas.microsoft.com/office/drawing/2014/main" id="{0AC10CB5-715A-4CC6-9372-1DC663F529E4}"/>
               </a:ext>
             </a:extLst>
           </p:cNvPr>
@@ -18665,7 +18665,7 @@
           <p:cNvPr id="26" name="">
             <a:extLst xmlns:a="http://schemas.openxmlformats.org/drawingml/2006/main">
               <a:ext uri="{FF2B5EF4-FFF2-40B4-BE49-F238E27FC236}">
-                <a16:creationId xmlns:a16="http://schemas.microsoft.com/office/drawing/2014/main" id="{EAE1265F-F21E-4545-84FB-8FC3235D695E}"/>
+                <a16:creationId xmlns:a16="http://schemas.microsoft.com/office/drawing/2014/main" id="{C22C6A62-88E1-4D98-B293-152295352038}"/>
               </a:ext>
             </a:extLst>
           </p:cNvPr>
@@ -18700,7 +18700,7 @@
           <p:cNvPr id="27" name="">
             <a:extLst xmlns:a="http://schemas.openxmlformats.org/drawingml/2006/main">
               <a:ext uri="{FF2B5EF4-FFF2-40B4-BE49-F238E27FC236}">
-                <a16:creationId xmlns:a16="http://schemas.microsoft.com/office/drawing/2014/main" id="{85E84DCC-4389-415F-8838-1EF403148895}"/>
+                <a16:creationId xmlns:a16="http://schemas.microsoft.com/office/drawing/2014/main" id="{868B47DA-8CFF-4A28-9601-99A81538F550}"/>
               </a:ext>
             </a:extLst>
           </p:cNvPr>
@@ -18758,7 +18758,7 @@
           <p:cNvPr id="28" name="">
             <a:extLst xmlns:a="http://schemas.openxmlformats.org/drawingml/2006/main">
               <a:ext uri="{FF2B5EF4-FFF2-40B4-BE49-F238E27FC236}">
-                <a16:creationId xmlns:a16="http://schemas.microsoft.com/office/drawing/2014/main" id="{046BD9A0-4AA9-41FD-8BBA-97DC27DEDEC4}"/>
+                <a16:creationId xmlns:a16="http://schemas.microsoft.com/office/drawing/2014/main" id="{3605F328-B9C1-47D8-81D7-9D69AD807AC2}"/>
               </a:ext>
             </a:extLst>
           </p:cNvPr>
@@ -18816,7 +18816,7 @@
           <p:cNvPr id="29" name="">
             <a:extLst xmlns:a="http://schemas.openxmlformats.org/drawingml/2006/main">
               <a:ext uri="{FF2B5EF4-FFF2-40B4-BE49-F238E27FC236}">
-                <a16:creationId xmlns:a16="http://schemas.microsoft.com/office/drawing/2014/main" id="{EDB9D917-7B77-4DA5-8126-D2D48BF0BE13}"/>
+                <a16:creationId xmlns:a16="http://schemas.microsoft.com/office/drawing/2014/main" id="{ED51D593-51C8-4B21-B805-ABE2545F11D9}"/>
               </a:ext>
             </a:extLst>
           </p:cNvPr>
@@ -18849,7 +18849,7 @@
           <p:cNvPr id="30" name="">
             <a:extLst xmlns:a="http://schemas.openxmlformats.org/drawingml/2006/main">
               <a:ext uri="{FF2B5EF4-FFF2-40B4-BE49-F238E27FC236}">
-                <a16:creationId xmlns:a16="http://schemas.microsoft.com/office/drawing/2014/main" id="{BBF6F54E-FA2D-4EF3-836A-D88793A7A992}"/>
+                <a16:creationId xmlns:a16="http://schemas.microsoft.com/office/drawing/2014/main" id="{B0A403B3-D15B-41F9-912E-2A9936A25E5E}"/>
               </a:ext>
             </a:extLst>
           </p:cNvPr>
@@ -18882,7 +18882,7 @@
           <p:cNvPr id="31" name="">
             <a:extLst xmlns:a="http://schemas.openxmlformats.org/drawingml/2006/main">
               <a:ext uri="{FF2B5EF4-FFF2-40B4-BE49-F238E27FC236}">
-                <a16:creationId xmlns:a16="http://schemas.microsoft.com/office/drawing/2014/main" id="{9E90D8FD-07BB-4D76-AD2E-450F77F1DADB}"/>
+                <a16:creationId xmlns:a16="http://schemas.microsoft.com/office/drawing/2014/main" id="{A7306FFF-D89D-47D4-B920-2BB7433B9203}"/>
               </a:ext>
             </a:extLst>
           </p:cNvPr>
@@ -18915,7 +18915,7 @@
           <p:cNvPr id="32" name="">
             <a:extLst xmlns:a="http://schemas.openxmlformats.org/drawingml/2006/main">
               <a:ext uri="{FF2B5EF4-FFF2-40B4-BE49-F238E27FC236}">
-                <a16:creationId xmlns:a16="http://schemas.microsoft.com/office/drawing/2014/main" id="{5A8939C5-3491-4215-98A4-4467C1E6FA8C}"/>
+                <a16:creationId xmlns:a16="http://schemas.microsoft.com/office/drawing/2014/main" id="{7ED56E84-7164-42FD-9CC9-A7E9C39CE1DF}"/>
               </a:ext>
             </a:extLst>
           </p:cNvPr>
@@ -18948,7 +18948,7 @@
           <p:cNvPr id="33" name="">
             <a:extLst xmlns:a="http://schemas.openxmlformats.org/drawingml/2006/main">
               <a:ext uri="{FF2B5EF4-FFF2-40B4-BE49-F238E27FC236}">
-                <a16:creationId xmlns:a16="http://schemas.microsoft.com/office/drawing/2014/main" id="{C6D58C4F-87DA-4410-AAD6-1908DD16B4AE}"/>
+                <a16:creationId xmlns:a16="http://schemas.microsoft.com/office/drawing/2014/main" id="{820FDC64-0588-4C3A-8F0C-79C72E47DF78}"/>
               </a:ext>
             </a:extLst>
           </p:cNvPr>
@@ -18981,7 +18981,7 @@
           <p:cNvPr id="34" name="">
             <a:extLst xmlns:a="http://schemas.openxmlformats.org/drawingml/2006/main">
               <a:ext uri="{FF2B5EF4-FFF2-40B4-BE49-F238E27FC236}">
-                <a16:creationId xmlns:a16="http://schemas.microsoft.com/office/drawing/2014/main" id="{401E69A6-75CE-4523-8607-FA6EB6657733}"/>
+                <a16:creationId xmlns:a16="http://schemas.microsoft.com/office/drawing/2014/main" id="{E872C790-8506-49E9-8D65-A5757EE71AE7}"/>
               </a:ext>
             </a:extLst>
           </p:cNvPr>
@@ -19037,7 +19037,7 @@
     </p:spTree>
     <p:extLst>
       <p:ext uri="{BB962C8B-B14F-4D97-AF65-F5344CB8AC3E}">
-        <p14:creationId xmlns:p14="http://schemas.microsoft.com/office/powerpoint/2010/main" val="496394623"/>
+        <p14:creationId xmlns:p14="http://schemas.microsoft.com/office/powerpoint/2010/main" val="2131525764"/>
       </p:ext>
     </p:extLst>
   </p:cSld>
@@ -19061,7 +19061,7 @@
           <p:cNvPr id="12" name="">
             <a:extLst xmlns:a="http://schemas.openxmlformats.org/drawingml/2006/main">
               <a:ext uri="{FF2B5EF4-FFF2-40B4-BE49-F238E27FC236}">
-                <a16:creationId xmlns:a16="http://schemas.microsoft.com/office/drawing/2014/main" id="{6B8E8D4A-141E-49FA-8662-CBBABA767539}"/>
+                <a16:creationId xmlns:a16="http://schemas.microsoft.com/office/drawing/2014/main" id="{824EFE28-9523-4E0E-A7EB-959C45118C63}"/>
               </a:ext>
             </a:extLst>
           </p:cNvPr>
@@ -19119,7 +19119,7 @@
           <p:cNvPr id="2" name="">
             <a:extLst xmlns:a="http://schemas.openxmlformats.org/drawingml/2006/main">
               <a:ext uri="{FF2B5EF4-FFF2-40B4-BE49-F238E27FC236}">
-                <a16:creationId xmlns:a16="http://schemas.microsoft.com/office/drawing/2014/main" id="{A6BFBBFA-0C69-44D6-9970-073B57B91166}"/>
+                <a16:creationId xmlns:a16="http://schemas.microsoft.com/office/drawing/2014/main" id="{8A15BBDD-27FF-45F8-848C-368E0C0B1871}"/>
               </a:ext>
             </a:extLst>
           </p:cNvPr>
@@ -19177,19 +19177,19 @@
           <p:cNvPr id="3" name="">
             <a:extLst xmlns:a="http://schemas.openxmlformats.org/drawingml/2006/main">
               <a:ext uri="{FF2B5EF4-FFF2-40B4-BE49-F238E27FC236}">
-                <a16:creationId xmlns:a16="http://schemas.microsoft.com/office/drawing/2014/main" id="{ACF05556-18C0-46C6-BD2B-9F5066EA2991}"/>
-              </a:ext>
-            </a:extLst>
-          </p:cNvPr>
-          <p:cNvSpPr>
-            <a:spLocks xmlns:a="http://schemas.openxmlformats.org/drawingml/2006/main" noGrp="1"/>
-          </p:cNvSpPr>
-          <p:nvPr/>
-        </p:nvSpPr>
-        <p:spPr>
-          <a:xfrm xmlns:a="http://schemas.openxmlformats.org/drawingml/2006/main">
-            <a:off x="11239500" y="6334125"/>
-            <a:ext cx="552450" cy="190500"/>
+                <a16:creationId xmlns:a16="http://schemas.microsoft.com/office/drawing/2014/main" id="{23B97366-BF7B-49E3-A37D-24A894D7B81F}"/>
+              </a:ext>
+            </a:extLst>
+          </p:cNvPr>
+          <p:cNvSpPr>
+            <a:spLocks xmlns:a="http://schemas.openxmlformats.org/drawingml/2006/main" noGrp="1"/>
+          </p:cNvSpPr>
+          <p:nvPr/>
+        </p:nvSpPr>
+        <p:spPr>
+          <a:xfrm xmlns:a="http://schemas.openxmlformats.org/drawingml/2006/main">
+            <a:off x="10953750" y="6334125"/>
+            <a:ext cx="838200" cy="190500"/>
           </a:xfrm>
           <a:prstGeom xmlns:a="http://schemas.openxmlformats.org/drawingml/2006/main" prst="rect">
             <a:avLst/>
@@ -19242,7 +19242,7 @@
         </p:xfrm>
         <a:graphic xmlns:a="http://schemas.openxmlformats.org/drawingml/2006/main">
           <a:graphicData uri="http://schemas.openxmlformats.org/drawingml/2006/chart">
-            <c:chart xmlns:r="http://schemas.openxmlformats.org/officeDocument/2006/relationships" xmlns:c="http://schemas.openxmlformats.org/drawingml/2006/chart" r:id="R5aa5f55538304ac9"/>
+            <c:chart xmlns:r="http://schemas.openxmlformats.org/officeDocument/2006/relationships" xmlns:c="http://schemas.openxmlformats.org/drawingml/2006/chart" r:id="Rb339c2f6941b4c70"/>
           </a:graphicData>
         </a:graphic>
       </p:graphicFrame>
@@ -19251,7 +19251,7 @@
           <p:cNvPr id="5" name="">
             <a:extLst xmlns:a="http://schemas.openxmlformats.org/drawingml/2006/main">
               <a:ext uri="{FF2B5EF4-FFF2-40B4-BE49-F238E27FC236}">
-                <a16:creationId xmlns:a16="http://schemas.microsoft.com/office/drawing/2014/main" id="{397A863C-5664-428F-B0C4-552495BD9C2B}"/>
+                <a16:creationId xmlns:a16="http://schemas.microsoft.com/office/drawing/2014/main" id="{04E1A7C5-B701-453B-939F-21ECB907E3E9}"/>
               </a:ext>
             </a:extLst>
           </p:cNvPr>
@@ -19286,7 +19286,7 @@
           <p:cNvPr id="6" name="">
             <a:extLst xmlns:a="http://schemas.openxmlformats.org/drawingml/2006/main">
               <a:ext uri="{FF2B5EF4-FFF2-40B4-BE49-F238E27FC236}">
-                <a16:creationId xmlns:a16="http://schemas.microsoft.com/office/drawing/2014/main" id="{36EF2F53-3883-4925-A753-8B2B20018C72}"/>
+                <a16:creationId xmlns:a16="http://schemas.microsoft.com/office/drawing/2014/main" id="{C8AED4AE-42DD-43AD-8578-1BC4C007FE90}"/>
               </a:ext>
             </a:extLst>
           </p:cNvPr>
@@ -19344,7 +19344,7 @@
           <p:cNvPr id="7" name="">
             <a:extLst xmlns:a="http://schemas.openxmlformats.org/drawingml/2006/main">
               <a:ext uri="{FF2B5EF4-FFF2-40B4-BE49-F238E27FC236}">
-                <a16:creationId xmlns:a16="http://schemas.microsoft.com/office/drawing/2014/main" id="{B3A74F6E-56F2-4C09-856B-F23A8CB9FFEE}"/>
+                <a16:creationId xmlns:a16="http://schemas.microsoft.com/office/drawing/2014/main" id="{5253A564-3D9E-4AD6-BE6D-962347A07703}"/>
               </a:ext>
             </a:extLst>
           </p:cNvPr>
@@ -19402,7 +19402,7 @@
           <p:cNvPr id="8" name="">
             <a:extLst xmlns:a="http://schemas.openxmlformats.org/drawingml/2006/main">
               <a:ext uri="{FF2B5EF4-FFF2-40B4-BE49-F238E27FC236}">
-                <a16:creationId xmlns:a16="http://schemas.microsoft.com/office/drawing/2014/main" id="{1587F501-42C2-48DE-BB37-CD4BC013BB6B}"/>
+                <a16:creationId xmlns:a16="http://schemas.microsoft.com/office/drawing/2014/main" id="{D2D7D35D-482F-4DC9-8745-13C4F7861BE3}"/>
               </a:ext>
             </a:extLst>
           </p:cNvPr>
@@ -19437,7 +19437,7 @@
           <p:cNvPr id="9" name="">
             <a:extLst xmlns:a="http://schemas.openxmlformats.org/drawingml/2006/main">
               <a:ext uri="{FF2B5EF4-FFF2-40B4-BE49-F238E27FC236}">
-                <a16:creationId xmlns:a16="http://schemas.microsoft.com/office/drawing/2014/main" id="{CA0FDDA7-891F-4A22-BFDE-D49C11EDDC7E}"/>
+                <a16:creationId xmlns:a16="http://schemas.microsoft.com/office/drawing/2014/main" id="{91EED91B-8375-4DDF-A187-20D685031295}"/>
               </a:ext>
             </a:extLst>
           </p:cNvPr>
@@ -19495,7 +19495,7 @@
           <p:cNvPr id="10" name="">
             <a:extLst xmlns:a="http://schemas.openxmlformats.org/drawingml/2006/main">
               <a:ext uri="{FF2B5EF4-FFF2-40B4-BE49-F238E27FC236}">
-                <a16:creationId xmlns:a16="http://schemas.microsoft.com/office/drawing/2014/main" id="{8739536E-774E-40ED-9C97-012F6AB82DBB}"/>
+                <a16:creationId xmlns:a16="http://schemas.microsoft.com/office/drawing/2014/main" id="{891BB46B-0049-4D91-8FEC-C132DF5CF89E}"/>
               </a:ext>
             </a:extLst>
           </p:cNvPr>
@@ -19553,7 +19553,7 @@
           <p:cNvPr id="11" name="">
             <a:extLst xmlns:a="http://schemas.openxmlformats.org/drawingml/2006/main">
               <a:ext uri="{FF2B5EF4-FFF2-40B4-BE49-F238E27FC236}">
-                <a16:creationId xmlns:a16="http://schemas.microsoft.com/office/drawing/2014/main" id="{F053099B-80A4-429E-AB8F-A9DACDE5E195}"/>
+                <a16:creationId xmlns:a16="http://schemas.microsoft.com/office/drawing/2014/main" id="{0DC93523-998C-4920-88D9-385A88C389DE}"/>
               </a:ext>
             </a:extLst>
           </p:cNvPr>
@@ -19609,7 +19609,7 @@
     </p:spTree>
     <p:extLst>
       <p:ext uri="{BB962C8B-B14F-4D97-AF65-F5344CB8AC3E}">
-        <p14:creationId xmlns:p14="http://schemas.microsoft.com/office/powerpoint/2010/main" val="347114024"/>
+        <p14:creationId xmlns:p14="http://schemas.microsoft.com/office/powerpoint/2010/main" val="1685764885"/>
       </p:ext>
     </p:extLst>
   </p:cSld>
@@ -19633,7 +19633,7 @@
           <p:cNvPr id="12" name="">
             <a:extLst xmlns:a="http://schemas.openxmlformats.org/drawingml/2006/main">
               <a:ext uri="{FF2B5EF4-FFF2-40B4-BE49-F238E27FC236}">
-                <a16:creationId xmlns:a16="http://schemas.microsoft.com/office/drawing/2014/main" id="{B9FB40E1-D135-4213-8623-8B292D7BD1AB}"/>
+                <a16:creationId xmlns:a16="http://schemas.microsoft.com/office/drawing/2014/main" id="{A95AFAC1-8A63-4DCB-BDA0-E21928CF7EC9}"/>
               </a:ext>
             </a:extLst>
           </p:cNvPr>
@@ -19691,7 +19691,7 @@
           <p:cNvPr id="2" name="">
             <a:extLst xmlns:a="http://schemas.openxmlformats.org/drawingml/2006/main">
               <a:ext uri="{FF2B5EF4-FFF2-40B4-BE49-F238E27FC236}">
-                <a16:creationId xmlns:a16="http://schemas.microsoft.com/office/drawing/2014/main" id="{034A217B-82B2-48C6-8326-0C94739FC116}"/>
+                <a16:creationId xmlns:a16="http://schemas.microsoft.com/office/drawing/2014/main" id="{CC4CC546-3BD3-4F7B-BD4C-F05A289F6DBD}"/>
               </a:ext>
             </a:extLst>
           </p:cNvPr>
@@ -19749,19 +19749,19 @@
           <p:cNvPr id="3" name="">
             <a:extLst xmlns:a="http://schemas.openxmlformats.org/drawingml/2006/main">
               <a:ext uri="{FF2B5EF4-FFF2-40B4-BE49-F238E27FC236}">
-                <a16:creationId xmlns:a16="http://schemas.microsoft.com/office/drawing/2014/main" id="{BAE4D08F-E958-4FF3-807A-39ED28B657C0}"/>
-              </a:ext>
-            </a:extLst>
-          </p:cNvPr>
-          <p:cNvSpPr>
-            <a:spLocks xmlns:a="http://schemas.openxmlformats.org/drawingml/2006/main" noGrp="1"/>
-          </p:cNvSpPr>
-          <p:nvPr/>
-        </p:nvSpPr>
-        <p:spPr>
-          <a:xfrm xmlns:a="http://schemas.openxmlformats.org/drawingml/2006/main">
-            <a:off x="11239500" y="6334125"/>
-            <a:ext cx="552450" cy="190500"/>
+                <a16:creationId xmlns:a16="http://schemas.microsoft.com/office/drawing/2014/main" id="{FF931252-CD88-4831-A0F5-1188BF1FA87D}"/>
+              </a:ext>
+            </a:extLst>
+          </p:cNvPr>
+          <p:cNvSpPr>
+            <a:spLocks xmlns:a="http://schemas.openxmlformats.org/drawingml/2006/main" noGrp="1"/>
+          </p:cNvSpPr>
+          <p:nvPr/>
+        </p:nvSpPr>
+        <p:spPr>
+          <a:xfrm xmlns:a="http://schemas.openxmlformats.org/drawingml/2006/main">
+            <a:off x="10953750" y="6334125"/>
+            <a:ext cx="838200" cy="190500"/>
           </a:xfrm>
           <a:prstGeom xmlns:a="http://schemas.openxmlformats.org/drawingml/2006/main" prst="rect">
             <a:avLst/>
@@ -19807,7 +19807,7 @@
           <p:cNvPr id="4" name="">
             <a:extLst xmlns:a="http://schemas.openxmlformats.org/drawingml/2006/main">
               <a:ext uri="{FF2B5EF4-FFF2-40B4-BE49-F238E27FC236}">
-                <a16:creationId xmlns:a16="http://schemas.microsoft.com/office/drawing/2014/main" id="{3EBF48FA-2A67-4089-B264-AAA06350D278}"/>
+                <a16:creationId xmlns:a16="http://schemas.microsoft.com/office/drawing/2014/main" id="{B961427D-6D6C-4ACC-A3C7-167F633278F6}"/>
               </a:ext>
             </a:extLst>
           </p:cNvPr>
@@ -19842,7 +19842,7 @@
           <p:cNvPr id="5" name="">
             <a:extLst xmlns:a="http://schemas.openxmlformats.org/drawingml/2006/main">
               <a:ext uri="{FF2B5EF4-FFF2-40B4-BE49-F238E27FC236}">
-                <a16:creationId xmlns:a16="http://schemas.microsoft.com/office/drawing/2014/main" id="{A94F2480-2F2E-4165-9A42-0D4392FBEFA3}"/>
+                <a16:creationId xmlns:a16="http://schemas.microsoft.com/office/drawing/2014/main" id="{9AAD4340-37A8-4318-9010-104C531AEAAF}"/>
               </a:ext>
             </a:extLst>
           </p:cNvPr>
@@ -19900,7 +19900,7 @@
           <p:cNvPr id="6" name="">
             <a:extLst xmlns:a="http://schemas.openxmlformats.org/drawingml/2006/main">
               <a:ext uri="{FF2B5EF4-FFF2-40B4-BE49-F238E27FC236}">
-                <a16:creationId xmlns:a16="http://schemas.microsoft.com/office/drawing/2014/main" id="{B025BDBE-2ECA-436B-9A58-ED141C431758}"/>
+                <a16:creationId xmlns:a16="http://schemas.microsoft.com/office/drawing/2014/main" id="{2DE8786C-9C6A-4C22-B91B-BF30A0F18103}"/>
               </a:ext>
             </a:extLst>
           </p:cNvPr>
@@ -20004,7 +20004,7 @@
           <p:cNvPr id="7" name="">
             <a:extLst xmlns:a="http://schemas.openxmlformats.org/drawingml/2006/main">
               <a:ext uri="{FF2B5EF4-FFF2-40B4-BE49-F238E27FC236}">
-                <a16:creationId xmlns:a16="http://schemas.microsoft.com/office/drawing/2014/main" id="{2CA6D497-7A28-474B-B7D7-585D55B8AF91}"/>
+                <a16:creationId xmlns:a16="http://schemas.microsoft.com/office/drawing/2014/main" id="{BDCD8EBC-1B75-4C49-9D02-546A6AF17CF4}"/>
               </a:ext>
             </a:extLst>
           </p:cNvPr>
@@ -20039,7 +20039,7 @@
           <p:cNvPr id="8" name="">
             <a:extLst xmlns:a="http://schemas.openxmlformats.org/drawingml/2006/main">
               <a:ext uri="{FF2B5EF4-FFF2-40B4-BE49-F238E27FC236}">
-                <a16:creationId xmlns:a16="http://schemas.microsoft.com/office/drawing/2014/main" id="{6962C0FE-196F-40B5-8F63-1E5CEFBC2429}"/>
+                <a16:creationId xmlns:a16="http://schemas.microsoft.com/office/drawing/2014/main" id="{BE031476-A96C-4C61-860D-9B684F1CDCB3}"/>
               </a:ext>
             </a:extLst>
           </p:cNvPr>
@@ -20097,7 +20097,7 @@
           <p:cNvPr id="9" name="">
             <a:extLst xmlns:a="http://schemas.openxmlformats.org/drawingml/2006/main">
               <a:ext uri="{FF2B5EF4-FFF2-40B4-BE49-F238E27FC236}">
-                <a16:creationId xmlns:a16="http://schemas.microsoft.com/office/drawing/2014/main" id="{20C8DFB1-DF04-4283-9830-5DE801A7A9C9}"/>
+                <a16:creationId xmlns:a16="http://schemas.microsoft.com/office/drawing/2014/main" id="{CAE685EE-21B9-41D8-939B-E92D75644A9C}"/>
               </a:ext>
             </a:extLst>
           </p:cNvPr>
@@ -20201,7 +20201,7 @@
           <p:cNvPr id="10" name="">
             <a:extLst xmlns:a="http://schemas.openxmlformats.org/drawingml/2006/main">
               <a:ext uri="{FF2B5EF4-FFF2-40B4-BE49-F238E27FC236}">
-                <a16:creationId xmlns:a16="http://schemas.microsoft.com/office/drawing/2014/main" id="{0C370F09-73D4-4C58-A980-607455133E1A}"/>
+                <a16:creationId xmlns:a16="http://schemas.microsoft.com/office/drawing/2014/main" id="{18558790-7415-40B7-9FF4-70406AA6C3B2}"/>
               </a:ext>
             </a:extLst>
           </p:cNvPr>
@@ -20259,7 +20259,7 @@
           <p:cNvPr id="11" name="">
             <a:extLst xmlns:a="http://schemas.openxmlformats.org/drawingml/2006/main">
               <a:ext uri="{FF2B5EF4-FFF2-40B4-BE49-F238E27FC236}">
-                <a16:creationId xmlns:a16="http://schemas.microsoft.com/office/drawing/2014/main" id="{A4426C16-A4A1-4896-BBBB-2B162DF92BD3}"/>
+                <a16:creationId xmlns:a16="http://schemas.microsoft.com/office/drawing/2014/main" id="{0DA28CE2-6A00-4E8A-9C07-93789DCB1D4A}"/>
               </a:ext>
             </a:extLst>
           </p:cNvPr>
@@ -20315,7 +20315,7 @@
     </p:spTree>
     <p:extLst>
       <p:ext uri="{BB962C8B-B14F-4D97-AF65-F5344CB8AC3E}">
-        <p14:creationId xmlns:p14="http://schemas.microsoft.com/office/powerpoint/2010/main" val="1474087101"/>
+        <p14:creationId xmlns:p14="http://schemas.microsoft.com/office/powerpoint/2010/main" val="1392177554"/>
       </p:ext>
     </p:extLst>
   </p:cSld>
@@ -20339,7 +20339,7 @@
           <p:cNvPr id="23" name="">
             <a:extLst xmlns:a="http://schemas.openxmlformats.org/drawingml/2006/main">
               <a:ext uri="{FF2B5EF4-FFF2-40B4-BE49-F238E27FC236}">
-                <a16:creationId xmlns:a16="http://schemas.microsoft.com/office/drawing/2014/main" id="{82EA47AB-5F83-4712-AD00-676045AC9C80}"/>
+                <a16:creationId xmlns:a16="http://schemas.microsoft.com/office/drawing/2014/main" id="{C52D23F6-DFE3-4C78-B015-B07A3D275A87}"/>
               </a:ext>
             </a:extLst>
           </p:cNvPr>
@@ -20397,7 +20397,7 @@
           <p:cNvPr id="2" name="">
             <a:extLst xmlns:a="http://schemas.openxmlformats.org/drawingml/2006/main">
               <a:ext uri="{FF2B5EF4-FFF2-40B4-BE49-F238E27FC236}">
-                <a16:creationId xmlns:a16="http://schemas.microsoft.com/office/drawing/2014/main" id="{AF918BD9-509F-4F81-8A12-FF6B1FB1A9AC}"/>
+                <a16:creationId xmlns:a16="http://schemas.microsoft.com/office/drawing/2014/main" id="{9C5EEC13-01D3-42A8-AA4D-A32ED4AE6F21}"/>
               </a:ext>
             </a:extLst>
           </p:cNvPr>
@@ -20455,19 +20455,19 @@
           <p:cNvPr id="3" name="">
             <a:extLst xmlns:a="http://schemas.openxmlformats.org/drawingml/2006/main">
               <a:ext uri="{FF2B5EF4-FFF2-40B4-BE49-F238E27FC236}">
-                <a16:creationId xmlns:a16="http://schemas.microsoft.com/office/drawing/2014/main" id="{203ED987-8DE3-4CFE-B60F-72294707DA49}"/>
-              </a:ext>
-            </a:extLst>
-          </p:cNvPr>
-          <p:cNvSpPr>
-            <a:spLocks xmlns:a="http://schemas.openxmlformats.org/drawingml/2006/main" noGrp="1"/>
-          </p:cNvSpPr>
-          <p:nvPr/>
-        </p:nvSpPr>
-        <p:spPr>
-          <a:xfrm xmlns:a="http://schemas.openxmlformats.org/drawingml/2006/main">
-            <a:off x="11239500" y="6334125"/>
-            <a:ext cx="552450" cy="190500"/>
+                <a16:creationId xmlns:a16="http://schemas.microsoft.com/office/drawing/2014/main" id="{EB449924-6735-4852-91BB-F783F27423A0}"/>
+              </a:ext>
+            </a:extLst>
+          </p:cNvPr>
+          <p:cNvSpPr>
+            <a:spLocks xmlns:a="http://schemas.openxmlformats.org/drawingml/2006/main" noGrp="1"/>
+          </p:cNvSpPr>
+          <p:nvPr/>
+        </p:nvSpPr>
+        <p:spPr>
+          <a:xfrm xmlns:a="http://schemas.openxmlformats.org/drawingml/2006/main">
+            <a:off x="10953750" y="6334125"/>
+            <a:ext cx="838200" cy="190500"/>
           </a:xfrm>
           <a:prstGeom xmlns:a="http://schemas.openxmlformats.org/drawingml/2006/main" prst="rect">
             <a:avLst/>
@@ -20513,7 +20513,7 @@
           <p:cNvPr id="4" name="">
             <a:extLst xmlns:a="http://schemas.openxmlformats.org/drawingml/2006/main">
               <a:ext uri="{FF2B5EF4-FFF2-40B4-BE49-F238E27FC236}">
-                <a16:creationId xmlns:a16="http://schemas.microsoft.com/office/drawing/2014/main" id="{6484C9D4-F1E6-4AF2-96AA-FB0B4E8D9439}"/>
+                <a16:creationId xmlns:a16="http://schemas.microsoft.com/office/drawing/2014/main" id="{B27EC05F-02CA-4257-9C27-93620C8CEFA9}"/>
               </a:ext>
             </a:extLst>
           </p:cNvPr>
@@ -20548,7 +20548,7 @@
           <p:cNvPr id="5" name="">
             <a:extLst xmlns:a="http://schemas.openxmlformats.org/drawingml/2006/main">
               <a:ext uri="{FF2B5EF4-FFF2-40B4-BE49-F238E27FC236}">
-                <a16:creationId xmlns:a16="http://schemas.microsoft.com/office/drawing/2014/main" id="{B7AF0DAB-14B4-4C83-8FE0-759E88C411DA}"/>
+                <a16:creationId xmlns:a16="http://schemas.microsoft.com/office/drawing/2014/main" id="{E3B9699F-051B-4D8C-A93A-F99542B1CB63}"/>
               </a:ext>
             </a:extLst>
           </p:cNvPr>
@@ -20606,7 +20606,7 @@
           <p:cNvPr id="6" name="">
             <a:extLst xmlns:a="http://schemas.openxmlformats.org/drawingml/2006/main">
               <a:ext uri="{FF2B5EF4-FFF2-40B4-BE49-F238E27FC236}">
-                <a16:creationId xmlns:a16="http://schemas.microsoft.com/office/drawing/2014/main" id="{5DB9A571-147F-4F0F-8640-932983061EC2}"/>
+                <a16:creationId xmlns:a16="http://schemas.microsoft.com/office/drawing/2014/main" id="{8F774D66-59D5-41B7-8DFD-35740FF867D2}"/>
               </a:ext>
             </a:extLst>
           </p:cNvPr>
@@ -20664,7 +20664,7 @@
           <p:cNvPr id="7" name="">
             <a:extLst xmlns:a="http://schemas.openxmlformats.org/drawingml/2006/main">
               <a:ext uri="{FF2B5EF4-FFF2-40B4-BE49-F238E27FC236}">
-                <a16:creationId xmlns:a16="http://schemas.microsoft.com/office/drawing/2014/main" id="{AC967F52-B37D-4C38-9EBE-F4ED4B146826}"/>
+                <a16:creationId xmlns:a16="http://schemas.microsoft.com/office/drawing/2014/main" id="{E9395B9D-E6FA-4EBF-BA5D-3A01734DCBBA}"/>
               </a:ext>
             </a:extLst>
           </p:cNvPr>
@@ -20697,7 +20697,7 @@
           <p:cNvPr id="8" name="">
             <a:extLst xmlns:a="http://schemas.openxmlformats.org/drawingml/2006/main">
               <a:ext uri="{FF2B5EF4-FFF2-40B4-BE49-F238E27FC236}">
-                <a16:creationId xmlns:a16="http://schemas.microsoft.com/office/drawing/2014/main" id="{FA14B8A7-397A-4281-BDA3-C3C654915499}"/>
+                <a16:creationId xmlns:a16="http://schemas.microsoft.com/office/drawing/2014/main" id="{276F21DF-52E7-436F-9F0F-87FB3609C53D}"/>
               </a:ext>
             </a:extLst>
           </p:cNvPr>
@@ -20732,7 +20732,7 @@
           <p:cNvPr id="9" name="">
             <a:extLst xmlns:a="http://schemas.openxmlformats.org/drawingml/2006/main">
               <a:ext uri="{FF2B5EF4-FFF2-40B4-BE49-F238E27FC236}">
-                <a16:creationId xmlns:a16="http://schemas.microsoft.com/office/drawing/2014/main" id="{540D263A-4D24-4FEF-B5CA-A82984999DCC}"/>
+                <a16:creationId xmlns:a16="http://schemas.microsoft.com/office/drawing/2014/main" id="{734DB9BD-B4A5-4B57-A174-86B6763865C8}"/>
               </a:ext>
             </a:extLst>
           </p:cNvPr>
@@ -20790,7 +20790,7 @@
           <p:cNvPr id="10" name="">
             <a:extLst xmlns:a="http://schemas.openxmlformats.org/drawingml/2006/main">
               <a:ext uri="{FF2B5EF4-FFF2-40B4-BE49-F238E27FC236}">
-                <a16:creationId xmlns:a16="http://schemas.microsoft.com/office/drawing/2014/main" id="{CA7D270C-FE48-4B5B-9EEF-C02E50B0C797}"/>
+                <a16:creationId xmlns:a16="http://schemas.microsoft.com/office/drawing/2014/main" id="{0A86C2B6-7B33-45A2-A875-C088D387A798}"/>
               </a:ext>
             </a:extLst>
           </p:cNvPr>
@@ -20848,7 +20848,7 @@
           <p:cNvPr id="11" name="">
             <a:extLst xmlns:a="http://schemas.openxmlformats.org/drawingml/2006/main">
               <a:ext uri="{FF2B5EF4-FFF2-40B4-BE49-F238E27FC236}">
-                <a16:creationId xmlns:a16="http://schemas.microsoft.com/office/drawing/2014/main" id="{401C50D3-D6E6-4179-8BD0-032A8306F95E}"/>
+                <a16:creationId xmlns:a16="http://schemas.microsoft.com/office/drawing/2014/main" id="{4EBBEC74-2A1C-4232-BDA3-054755F84B7E}"/>
               </a:ext>
             </a:extLst>
           </p:cNvPr>
@@ -20881,7 +20881,7 @@
           <p:cNvPr id="12" name="">
             <a:extLst xmlns:a="http://schemas.openxmlformats.org/drawingml/2006/main">
               <a:ext uri="{FF2B5EF4-FFF2-40B4-BE49-F238E27FC236}">
-                <a16:creationId xmlns:a16="http://schemas.microsoft.com/office/drawing/2014/main" id="{ED69D53E-BC59-499A-84FD-1D4184853150}"/>
+                <a16:creationId xmlns:a16="http://schemas.microsoft.com/office/drawing/2014/main" id="{571FF7B8-2343-4084-BA30-DEEC5E2DE4C3}"/>
               </a:ext>
             </a:extLst>
           </p:cNvPr>
@@ -20916,7 +20916,7 @@
           <p:cNvPr id="13" name="">
             <a:extLst xmlns:a="http://schemas.openxmlformats.org/drawingml/2006/main">
               <a:ext uri="{FF2B5EF4-FFF2-40B4-BE49-F238E27FC236}">
-                <a16:creationId xmlns:a16="http://schemas.microsoft.com/office/drawing/2014/main" id="{5A92B49A-FB45-4D5A-BDC3-97D4A4B66EDA}"/>
+                <a16:creationId xmlns:a16="http://schemas.microsoft.com/office/drawing/2014/main" id="{B5F66E0B-C70B-485B-BD19-D00CB335777C}"/>
               </a:ext>
             </a:extLst>
           </p:cNvPr>
@@ -20974,7 +20974,7 @@
           <p:cNvPr id="14" name="">
             <a:extLst xmlns:a="http://schemas.openxmlformats.org/drawingml/2006/main">
               <a:ext uri="{FF2B5EF4-FFF2-40B4-BE49-F238E27FC236}">
-                <a16:creationId xmlns:a16="http://schemas.microsoft.com/office/drawing/2014/main" id="{16019BDD-44F4-473A-B7F0-693DDF758049}"/>
+                <a16:creationId xmlns:a16="http://schemas.microsoft.com/office/drawing/2014/main" id="{DB9B4946-8FE1-45DE-A015-C729B11CE8B5}"/>
               </a:ext>
             </a:extLst>
           </p:cNvPr>
@@ -21032,7 +21032,7 @@
           <p:cNvPr id="15" name="">
             <a:extLst xmlns:a="http://schemas.openxmlformats.org/drawingml/2006/main">
               <a:ext uri="{FF2B5EF4-FFF2-40B4-BE49-F238E27FC236}">
-                <a16:creationId xmlns:a16="http://schemas.microsoft.com/office/drawing/2014/main" id="{F8DAFF8C-3204-4421-99EA-98CE010F9625}"/>
+                <a16:creationId xmlns:a16="http://schemas.microsoft.com/office/drawing/2014/main" id="{E6522A03-7F52-4080-AB52-FA85CB5CA3FD}"/>
               </a:ext>
             </a:extLst>
           </p:cNvPr>
@@ -21065,7 +21065,7 @@
           <p:cNvPr id="16" name="">
             <a:extLst xmlns:a="http://schemas.openxmlformats.org/drawingml/2006/main">
               <a:ext uri="{FF2B5EF4-FFF2-40B4-BE49-F238E27FC236}">
-                <a16:creationId xmlns:a16="http://schemas.microsoft.com/office/drawing/2014/main" id="{52F3AC2D-710A-44AB-A709-2D2D1ABB946A}"/>
+                <a16:creationId xmlns:a16="http://schemas.microsoft.com/office/drawing/2014/main" id="{C4261175-061A-43A8-939F-B6DBDB1D35EB}"/>
               </a:ext>
             </a:extLst>
           </p:cNvPr>
@@ -21100,7 +21100,7 @@
           <p:cNvPr id="17" name="">
             <a:extLst xmlns:a="http://schemas.openxmlformats.org/drawingml/2006/main">
               <a:ext uri="{FF2B5EF4-FFF2-40B4-BE49-F238E27FC236}">
-                <a16:creationId xmlns:a16="http://schemas.microsoft.com/office/drawing/2014/main" id="{AA596616-9026-493A-8DCB-2A7009A258F2}"/>
+                <a16:creationId xmlns:a16="http://schemas.microsoft.com/office/drawing/2014/main" id="{AC6FA390-EC72-4B5D-A9CF-CA49BF28B4E2}"/>
               </a:ext>
             </a:extLst>
           </p:cNvPr>
@@ -21158,7 +21158,7 @@
           <p:cNvPr id="18" name="">
             <a:extLst xmlns:a="http://schemas.openxmlformats.org/drawingml/2006/main">
               <a:ext uri="{FF2B5EF4-FFF2-40B4-BE49-F238E27FC236}">
-                <a16:creationId xmlns:a16="http://schemas.microsoft.com/office/drawing/2014/main" id="{220C631C-1835-4312-94F5-44849B179D67}"/>
+                <a16:creationId xmlns:a16="http://schemas.microsoft.com/office/drawing/2014/main" id="{5CD6B45F-251F-4503-9094-92336FED7285}"/>
               </a:ext>
             </a:extLst>
           </p:cNvPr>
@@ -21216,7 +21216,7 @@
           <p:cNvPr id="19" name="">
             <a:extLst xmlns:a="http://schemas.openxmlformats.org/drawingml/2006/main">
               <a:ext uri="{FF2B5EF4-FFF2-40B4-BE49-F238E27FC236}">
-                <a16:creationId xmlns:a16="http://schemas.microsoft.com/office/drawing/2014/main" id="{B7225818-96EE-491F-B648-6924F3133FB9}"/>
+                <a16:creationId xmlns:a16="http://schemas.microsoft.com/office/drawing/2014/main" id="{54DACC31-572E-4EC8-84CE-F07F38271829}"/>
               </a:ext>
             </a:extLst>
           </p:cNvPr>
@@ -21251,7 +21251,7 @@
           <p:cNvPr id="20" name="">
             <a:extLst xmlns:a="http://schemas.openxmlformats.org/drawingml/2006/main">
               <a:ext uri="{FF2B5EF4-FFF2-40B4-BE49-F238E27FC236}">
-                <a16:creationId xmlns:a16="http://schemas.microsoft.com/office/drawing/2014/main" id="{D24B81CD-FE64-480F-AEB5-C99E871C202A}"/>
+                <a16:creationId xmlns:a16="http://schemas.microsoft.com/office/drawing/2014/main" id="{7921DA38-3392-4FE3-92CC-6E8783901D23}"/>
               </a:ext>
             </a:extLst>
           </p:cNvPr>
@@ -21309,7 +21309,7 @@
           <p:cNvPr id="21" name="">
             <a:extLst xmlns:a="http://schemas.openxmlformats.org/drawingml/2006/main">
               <a:ext uri="{FF2B5EF4-FFF2-40B4-BE49-F238E27FC236}">
-                <a16:creationId xmlns:a16="http://schemas.microsoft.com/office/drawing/2014/main" id="{23864C01-3E84-4A7E-AF03-5FDC89A2DF55}"/>
+                <a16:creationId xmlns:a16="http://schemas.microsoft.com/office/drawing/2014/main" id="{9D5028A8-E233-47D6-BE36-CB7CBC0BB524}"/>
               </a:ext>
             </a:extLst>
           </p:cNvPr>
@@ -21367,7 +21367,7 @@
           <p:cNvPr id="22" name="">
             <a:extLst xmlns:a="http://schemas.openxmlformats.org/drawingml/2006/main">
               <a:ext uri="{FF2B5EF4-FFF2-40B4-BE49-F238E27FC236}">
-                <a16:creationId xmlns:a16="http://schemas.microsoft.com/office/drawing/2014/main" id="{15796BF7-77AA-48C3-9074-38F4C8823DF6}"/>
+                <a16:creationId xmlns:a16="http://schemas.microsoft.com/office/drawing/2014/main" id="{0DDEE691-ACE7-449A-B191-A8EDD974682E}"/>
               </a:ext>
             </a:extLst>
           </p:cNvPr>
@@ -21423,7 +21423,7 @@
     </p:spTree>
     <p:extLst>
       <p:ext uri="{BB962C8B-B14F-4D97-AF65-F5344CB8AC3E}">
-        <p14:creationId xmlns:p14="http://schemas.microsoft.com/office/powerpoint/2010/main" val="1844425308"/>
+        <p14:creationId xmlns:p14="http://schemas.microsoft.com/office/powerpoint/2010/main" val="462564441"/>
       </p:ext>
     </p:extLst>
   </p:cSld>
@@ -21447,7 +21447,7 @@
           <p:cNvPr id="23" name="">
             <a:extLst xmlns:a="http://schemas.openxmlformats.org/drawingml/2006/main">
               <a:ext uri="{FF2B5EF4-FFF2-40B4-BE49-F238E27FC236}">
-                <a16:creationId xmlns:a16="http://schemas.microsoft.com/office/drawing/2014/main" id="{B80E1EDD-45DD-490C-99B8-62F2E3EF7124}"/>
+                <a16:creationId xmlns:a16="http://schemas.microsoft.com/office/drawing/2014/main" id="{4391E244-3349-4F71-870D-29E5DE3E6326}"/>
               </a:ext>
             </a:extLst>
           </p:cNvPr>
@@ -21505,7 +21505,7 @@
           <p:cNvPr id="2" name="">
             <a:extLst xmlns:a="http://schemas.openxmlformats.org/drawingml/2006/main">
               <a:ext uri="{FF2B5EF4-FFF2-40B4-BE49-F238E27FC236}">
-                <a16:creationId xmlns:a16="http://schemas.microsoft.com/office/drawing/2014/main" id="{D84D652C-22D6-42D4-BEDF-0749D63B305E}"/>
+                <a16:creationId xmlns:a16="http://schemas.microsoft.com/office/drawing/2014/main" id="{744DFA4F-BA7E-48FC-8839-641E22710A3C}"/>
               </a:ext>
             </a:extLst>
           </p:cNvPr>
@@ -21553,7 +21553,7 @@
                 <a:ea typeface="Microsoft YaHei"/>
                 <a:cs typeface="Microsoft YaHei"/>
               </a:rPr>
-              <a:t>IMC 通过 λ 直接选择“快多少、稳多少”</a:t>
+              <a:t>IMC 用 λ 选择快慢与鲁棒性</a:t>
             </a:r>
           </a:p>
         </p:txBody>
@@ -21563,19 +21563,19 @@
           <p:cNvPr id="3" name="">
             <a:extLst xmlns:a="http://schemas.openxmlformats.org/drawingml/2006/main">
               <a:ext uri="{FF2B5EF4-FFF2-40B4-BE49-F238E27FC236}">
-                <a16:creationId xmlns:a16="http://schemas.microsoft.com/office/drawing/2014/main" id="{00327763-316A-4FD6-A89F-D5A80F246417}"/>
-              </a:ext>
-            </a:extLst>
-          </p:cNvPr>
-          <p:cNvSpPr>
-            <a:spLocks xmlns:a="http://schemas.openxmlformats.org/drawingml/2006/main" noGrp="1"/>
-          </p:cNvSpPr>
-          <p:nvPr/>
-        </p:nvSpPr>
-        <p:spPr>
-          <a:xfrm xmlns:a="http://schemas.openxmlformats.org/drawingml/2006/main">
-            <a:off x="11239500" y="6334125"/>
-            <a:ext cx="552450" cy="190500"/>
+                <a16:creationId xmlns:a16="http://schemas.microsoft.com/office/drawing/2014/main" id="{0366125F-6BB4-4E8D-87E9-6016CA9CDFF1}"/>
+              </a:ext>
+            </a:extLst>
+          </p:cNvPr>
+          <p:cNvSpPr>
+            <a:spLocks xmlns:a="http://schemas.openxmlformats.org/drawingml/2006/main" noGrp="1"/>
+          </p:cNvSpPr>
+          <p:nvPr/>
+        </p:nvSpPr>
+        <p:spPr>
+          <a:xfrm xmlns:a="http://schemas.openxmlformats.org/drawingml/2006/main">
+            <a:off x="10953750" y="6334125"/>
+            <a:ext cx="838200" cy="190500"/>
           </a:xfrm>
           <a:prstGeom xmlns:a="http://schemas.openxmlformats.org/drawingml/2006/main" prst="rect">
             <a:avLst/>
@@ -21621,7 +21621,7 @@
           <p:cNvPr id="4" name="">
             <a:extLst xmlns:a="http://schemas.openxmlformats.org/drawingml/2006/main">
               <a:ext uri="{FF2B5EF4-FFF2-40B4-BE49-F238E27FC236}">
-                <a16:creationId xmlns:a16="http://schemas.microsoft.com/office/drawing/2014/main" id="{01454EB7-2048-4F9A-BDD5-02144312D6D0}"/>
+                <a16:creationId xmlns:a16="http://schemas.microsoft.com/office/drawing/2014/main" id="{70B03056-05DE-4EC0-8468-0B75B63CF82B}"/>
               </a:ext>
             </a:extLst>
           </p:cNvPr>
@@ -21656,7 +21656,7 @@
           <p:cNvPr id="5" name="">
             <a:extLst xmlns:a="http://schemas.openxmlformats.org/drawingml/2006/main">
               <a:ext uri="{FF2B5EF4-FFF2-40B4-BE49-F238E27FC236}">
-                <a16:creationId xmlns:a16="http://schemas.microsoft.com/office/drawing/2014/main" id="{C8FA8130-0DF0-405E-9C47-96BF0603D9C1}"/>
+                <a16:creationId xmlns:a16="http://schemas.microsoft.com/office/drawing/2014/main" id="{426EEE2F-B63C-4C0E-83DC-C625CE377DB9}"/>
               </a:ext>
             </a:extLst>
           </p:cNvPr>
@@ -21714,7 +21714,7 @@
           <p:cNvPr id="6" name="">
             <a:extLst xmlns:a="http://schemas.openxmlformats.org/drawingml/2006/main">
               <a:ext uri="{FF2B5EF4-FFF2-40B4-BE49-F238E27FC236}">
-                <a16:creationId xmlns:a16="http://schemas.microsoft.com/office/drawing/2014/main" id="{6DCFEE96-E010-48F4-9F0A-CCD17D898501}"/>
+                <a16:creationId xmlns:a16="http://schemas.microsoft.com/office/drawing/2014/main" id="{F341EDD7-8410-4E0D-920E-59A65D2A9BDD}"/>
               </a:ext>
             </a:extLst>
           </p:cNvPr>
@@ -21772,7 +21772,7 @@
           <p:cNvPr id="7" name="">
             <a:extLst xmlns:a="http://schemas.openxmlformats.org/drawingml/2006/main">
               <a:ext uri="{FF2B5EF4-FFF2-40B4-BE49-F238E27FC236}">
-                <a16:creationId xmlns:a16="http://schemas.microsoft.com/office/drawing/2014/main" id="{2AE29A6C-0101-4F30-B461-A95DA26737CC}"/>
+                <a16:creationId xmlns:a16="http://schemas.microsoft.com/office/drawing/2014/main" id="{ED79A45F-4C3A-4EB7-9652-0299EE746EF5}"/>
               </a:ext>
             </a:extLst>
           </p:cNvPr>
@@ -21805,7 +21805,7 @@
           <p:cNvPr id="8" name="">
             <a:extLst xmlns:a="http://schemas.openxmlformats.org/drawingml/2006/main">
               <a:ext uri="{FF2B5EF4-FFF2-40B4-BE49-F238E27FC236}">
-                <a16:creationId xmlns:a16="http://schemas.microsoft.com/office/drawing/2014/main" id="{229215C5-F27B-4821-BB44-5A887BEF2908}"/>
+                <a16:creationId xmlns:a16="http://schemas.microsoft.com/office/drawing/2014/main" id="{D8B5CBE2-D6CD-45DD-88F9-238F92CC4D94}"/>
               </a:ext>
             </a:extLst>
           </p:cNvPr>
@@ -21840,7 +21840,7 @@
           <p:cNvPr id="9" name="">
             <a:extLst xmlns:a="http://schemas.openxmlformats.org/drawingml/2006/main">
               <a:ext uri="{FF2B5EF4-FFF2-40B4-BE49-F238E27FC236}">
-                <a16:creationId xmlns:a16="http://schemas.microsoft.com/office/drawing/2014/main" id="{8FD11219-E30D-4EC8-8EB3-4BF6D175D2A4}"/>
+                <a16:creationId xmlns:a16="http://schemas.microsoft.com/office/drawing/2014/main" id="{4910764E-62DC-4419-86F5-B204E275AF8B}"/>
               </a:ext>
             </a:extLst>
           </p:cNvPr>
@@ -21898,7 +21898,7 @@
           <p:cNvPr id="10" name="">
             <a:extLst xmlns:a="http://schemas.openxmlformats.org/drawingml/2006/main">
               <a:ext uri="{FF2B5EF4-FFF2-40B4-BE49-F238E27FC236}">
-                <a16:creationId xmlns:a16="http://schemas.microsoft.com/office/drawing/2014/main" id="{4597A200-B3D9-4A01-80A6-BE0D98A0A389}"/>
+                <a16:creationId xmlns:a16="http://schemas.microsoft.com/office/drawing/2014/main" id="{03BFCFED-2B6B-4315-9228-EA5AD9D1657B}"/>
               </a:ext>
             </a:extLst>
           </p:cNvPr>
@@ -21956,7 +21956,7 @@
           <p:cNvPr id="11" name="">
             <a:extLst xmlns:a="http://schemas.openxmlformats.org/drawingml/2006/main">
               <a:ext uri="{FF2B5EF4-FFF2-40B4-BE49-F238E27FC236}">
-                <a16:creationId xmlns:a16="http://schemas.microsoft.com/office/drawing/2014/main" id="{38D7DCD1-55AE-48F5-ABA0-020F919BB270}"/>
+                <a16:creationId xmlns:a16="http://schemas.microsoft.com/office/drawing/2014/main" id="{08187A17-1E38-46B4-8304-CDEA74E0478B}"/>
               </a:ext>
             </a:extLst>
           </p:cNvPr>
@@ -21989,7 +21989,7 @@
           <p:cNvPr id="12" name="">
             <a:extLst xmlns:a="http://schemas.openxmlformats.org/drawingml/2006/main">
               <a:ext uri="{FF2B5EF4-FFF2-40B4-BE49-F238E27FC236}">
-                <a16:creationId xmlns:a16="http://schemas.microsoft.com/office/drawing/2014/main" id="{87F40F90-B45A-43D0-8983-64615DB3D404}"/>
+                <a16:creationId xmlns:a16="http://schemas.microsoft.com/office/drawing/2014/main" id="{ADB5DCEF-7E2C-4B3B-9FBD-4DB73EF8E470}"/>
               </a:ext>
             </a:extLst>
           </p:cNvPr>
@@ -22024,7 +22024,7 @@
           <p:cNvPr id="13" name="">
             <a:extLst xmlns:a="http://schemas.openxmlformats.org/drawingml/2006/main">
               <a:ext uri="{FF2B5EF4-FFF2-40B4-BE49-F238E27FC236}">
-                <a16:creationId xmlns:a16="http://schemas.microsoft.com/office/drawing/2014/main" id="{514215D8-9262-469F-A0B9-CA115E298191}"/>
+                <a16:creationId xmlns:a16="http://schemas.microsoft.com/office/drawing/2014/main" id="{88F96A88-ED95-4F99-A18F-EA290A6CE432}"/>
               </a:ext>
             </a:extLst>
           </p:cNvPr>
@@ -22082,7 +22082,7 @@
           <p:cNvPr id="14" name="">
             <a:extLst xmlns:a="http://schemas.openxmlformats.org/drawingml/2006/main">
               <a:ext uri="{FF2B5EF4-FFF2-40B4-BE49-F238E27FC236}">
-                <a16:creationId xmlns:a16="http://schemas.microsoft.com/office/drawing/2014/main" id="{B8484801-CA4B-4726-BE37-B994272E48B7}"/>
+                <a16:creationId xmlns:a16="http://schemas.microsoft.com/office/drawing/2014/main" id="{F6F42B42-26C5-45FF-802E-9DBDCD995638}"/>
               </a:ext>
             </a:extLst>
           </p:cNvPr>
@@ -22140,7 +22140,7 @@
           <p:cNvPr id="15" name="">
             <a:extLst xmlns:a="http://schemas.openxmlformats.org/drawingml/2006/main">
               <a:ext uri="{FF2B5EF4-FFF2-40B4-BE49-F238E27FC236}">
-                <a16:creationId xmlns:a16="http://schemas.microsoft.com/office/drawing/2014/main" id="{3C015559-4202-4AB6-8491-D16985C05869}"/>
+                <a16:creationId xmlns:a16="http://schemas.microsoft.com/office/drawing/2014/main" id="{204A1E21-C1D5-44A9-9081-61B805AA2BA0}"/>
               </a:ext>
             </a:extLst>
           </p:cNvPr>
@@ -22173,7 +22173,7 @@
           <p:cNvPr id="16" name="">
             <a:extLst xmlns:a="http://schemas.openxmlformats.org/drawingml/2006/main">
               <a:ext uri="{FF2B5EF4-FFF2-40B4-BE49-F238E27FC236}">
-                <a16:creationId xmlns:a16="http://schemas.microsoft.com/office/drawing/2014/main" id="{29BC8147-752D-4CF9-99AF-E2D1E281A043}"/>
+                <a16:creationId xmlns:a16="http://schemas.microsoft.com/office/drawing/2014/main" id="{34323012-181B-4B40-BF78-4C48EA665C15}"/>
               </a:ext>
             </a:extLst>
           </p:cNvPr>
@@ -22208,7 +22208,7 @@
           <p:cNvPr id="17" name="">
             <a:extLst xmlns:a="http://schemas.openxmlformats.org/drawingml/2006/main">
               <a:ext uri="{FF2B5EF4-FFF2-40B4-BE49-F238E27FC236}">
-                <a16:creationId xmlns:a16="http://schemas.microsoft.com/office/drawing/2014/main" id="{FB0937D8-87E6-436A-BEC4-99E571B09A7C}"/>
+                <a16:creationId xmlns:a16="http://schemas.microsoft.com/office/drawing/2014/main" id="{F9E37B6A-4BF5-47A0-A565-A78512CEFF40}"/>
               </a:ext>
             </a:extLst>
           </p:cNvPr>
@@ -22266,7 +22266,7 @@
           <p:cNvPr id="18" name="">
             <a:extLst xmlns:a="http://schemas.openxmlformats.org/drawingml/2006/main">
               <a:ext uri="{FF2B5EF4-FFF2-40B4-BE49-F238E27FC236}">
-                <a16:creationId xmlns:a16="http://schemas.microsoft.com/office/drawing/2014/main" id="{C53C369F-9EE5-41C1-AACC-A84B6E5C031C}"/>
+                <a16:creationId xmlns:a16="http://schemas.microsoft.com/office/drawing/2014/main" id="{D0A527EE-8359-42BA-AA8B-C088237C36CE}"/>
               </a:ext>
             </a:extLst>
           </p:cNvPr>
@@ -22324,7 +22324,7 @@
           <p:cNvPr id="19" name="">
             <a:extLst xmlns:a="http://schemas.openxmlformats.org/drawingml/2006/main">
               <a:ext uri="{FF2B5EF4-FFF2-40B4-BE49-F238E27FC236}">
-                <a16:creationId xmlns:a16="http://schemas.microsoft.com/office/drawing/2014/main" id="{43250304-14EF-4479-8049-067938A5F230}"/>
+                <a16:creationId xmlns:a16="http://schemas.microsoft.com/office/drawing/2014/main" id="{48537FD5-C5F3-4A75-BDAD-B30020AB506D}"/>
               </a:ext>
             </a:extLst>
           </p:cNvPr>
@@ -22359,7 +22359,7 @@
           <p:cNvPr id="20" name="">
             <a:extLst xmlns:a="http://schemas.openxmlformats.org/drawingml/2006/main">
               <a:ext uri="{FF2B5EF4-FFF2-40B4-BE49-F238E27FC236}">
-                <a16:creationId xmlns:a16="http://schemas.microsoft.com/office/drawing/2014/main" id="{9967DC06-8C43-46EB-ABCC-E8CE599B3C99}"/>
+                <a16:creationId xmlns:a16="http://schemas.microsoft.com/office/drawing/2014/main" id="{4A22E990-45FA-47AC-89FD-DCB53CBA2629}"/>
               </a:ext>
             </a:extLst>
           </p:cNvPr>
@@ -22417,7 +22417,7 @@
           <p:cNvPr id="21" name="">
             <a:extLst xmlns:a="http://schemas.openxmlformats.org/drawingml/2006/main">
               <a:ext uri="{FF2B5EF4-FFF2-40B4-BE49-F238E27FC236}">
-                <a16:creationId xmlns:a16="http://schemas.microsoft.com/office/drawing/2014/main" id="{953C84A2-9699-4971-B3A2-D783C419D94F}"/>
+                <a16:creationId xmlns:a16="http://schemas.microsoft.com/office/drawing/2014/main" id="{EFAE1369-32C9-4B17-8DDB-BB958DD91220}"/>
               </a:ext>
             </a:extLst>
           </p:cNvPr>
@@ -22475,7 +22475,7 @@
           <p:cNvPr id="22" name="">
             <a:extLst xmlns:a="http://schemas.openxmlformats.org/drawingml/2006/main">
               <a:ext uri="{FF2B5EF4-FFF2-40B4-BE49-F238E27FC236}">
-                <a16:creationId xmlns:a16="http://schemas.microsoft.com/office/drawing/2014/main" id="{BE29AC7E-8AFE-4A6A-BD14-1F36CBD176D0}"/>
+                <a16:creationId xmlns:a16="http://schemas.microsoft.com/office/drawing/2014/main" id="{016BBAC6-389E-4CD2-9A5E-1798C810A4E8}"/>
               </a:ext>
             </a:extLst>
           </p:cNvPr>
@@ -22531,7 +22531,7 @@
     </p:spTree>
     <p:extLst>
       <p:ext uri="{BB962C8B-B14F-4D97-AF65-F5344CB8AC3E}">
-        <p14:creationId xmlns:p14="http://schemas.microsoft.com/office/powerpoint/2010/main" val="572866351"/>
+        <p14:creationId xmlns:p14="http://schemas.microsoft.com/office/powerpoint/2010/main" val="1364858927"/>
       </p:ext>
     </p:extLst>
   </p:cSld>
@@ -22555,7 +22555,7 @@
           <p:cNvPr id="23" name="">
             <a:extLst xmlns:a="http://schemas.openxmlformats.org/drawingml/2006/main">
               <a:ext uri="{FF2B5EF4-FFF2-40B4-BE49-F238E27FC236}">
-                <a16:creationId xmlns:a16="http://schemas.microsoft.com/office/drawing/2014/main" id="{2E0D6010-F4BF-4567-99A8-517EABFF425D}"/>
+                <a16:creationId xmlns:a16="http://schemas.microsoft.com/office/drawing/2014/main" id="{3F36C73A-584D-48DA-A80A-52A119C42C7A}"/>
               </a:ext>
             </a:extLst>
           </p:cNvPr>
@@ -22613,7 +22613,7 @@
           <p:cNvPr id="2" name="">
             <a:extLst xmlns:a="http://schemas.openxmlformats.org/drawingml/2006/main">
               <a:ext uri="{FF2B5EF4-FFF2-40B4-BE49-F238E27FC236}">
-                <a16:creationId xmlns:a16="http://schemas.microsoft.com/office/drawing/2014/main" id="{AC405A64-34EA-465C-9BB4-DB7A064939D7}"/>
+                <a16:creationId xmlns:a16="http://schemas.microsoft.com/office/drawing/2014/main" id="{DA9416C5-AB8A-46BD-9159-3659602BF0FA}"/>
               </a:ext>
             </a:extLst>
           </p:cNvPr>
@@ -22671,19 +22671,19 @@
           <p:cNvPr id="3" name="">
             <a:extLst xmlns:a="http://schemas.openxmlformats.org/drawingml/2006/main">
               <a:ext uri="{FF2B5EF4-FFF2-40B4-BE49-F238E27FC236}">
-                <a16:creationId xmlns:a16="http://schemas.microsoft.com/office/drawing/2014/main" id="{A739A66D-E6D1-439E-9D34-FEAC958837D1}"/>
-              </a:ext>
-            </a:extLst>
-          </p:cNvPr>
-          <p:cNvSpPr>
-            <a:spLocks xmlns:a="http://schemas.openxmlformats.org/drawingml/2006/main" noGrp="1"/>
-          </p:cNvSpPr>
-          <p:nvPr/>
-        </p:nvSpPr>
-        <p:spPr>
-          <a:xfrm xmlns:a="http://schemas.openxmlformats.org/drawingml/2006/main">
-            <a:off x="11239500" y="6334125"/>
-            <a:ext cx="552450" cy="190500"/>
+                <a16:creationId xmlns:a16="http://schemas.microsoft.com/office/drawing/2014/main" id="{E614D38A-565E-43D7-92F9-FD14CBA93F38}"/>
+              </a:ext>
+            </a:extLst>
+          </p:cNvPr>
+          <p:cNvSpPr>
+            <a:spLocks xmlns:a="http://schemas.openxmlformats.org/drawingml/2006/main" noGrp="1"/>
+          </p:cNvSpPr>
+          <p:nvPr/>
+        </p:nvSpPr>
+        <p:spPr>
+          <a:xfrm xmlns:a="http://schemas.openxmlformats.org/drawingml/2006/main">
+            <a:off x="10953750" y="6334125"/>
+            <a:ext cx="838200" cy="190500"/>
           </a:xfrm>
           <a:prstGeom xmlns:a="http://schemas.openxmlformats.org/drawingml/2006/main" prst="rect">
             <a:avLst/>
@@ -22729,7 +22729,7 @@
           <p:cNvPr id="4" name="">
             <a:extLst xmlns:a="http://schemas.openxmlformats.org/drawingml/2006/main">
               <a:ext uri="{FF2B5EF4-FFF2-40B4-BE49-F238E27FC236}">
-                <a16:creationId xmlns:a16="http://schemas.microsoft.com/office/drawing/2014/main" id="{5FC5F8D3-6F4A-4B13-BE43-AD4B8558AC2A}"/>
+                <a16:creationId xmlns:a16="http://schemas.microsoft.com/office/drawing/2014/main" id="{78D32D19-B745-465F-8C5D-30895C1591A1}"/>
               </a:ext>
             </a:extLst>
           </p:cNvPr>
@@ -22764,7 +22764,7 @@
           <p:cNvPr id="5" name="">
             <a:extLst xmlns:a="http://schemas.openxmlformats.org/drawingml/2006/main">
               <a:ext uri="{FF2B5EF4-FFF2-40B4-BE49-F238E27FC236}">
-                <a16:creationId xmlns:a16="http://schemas.microsoft.com/office/drawing/2014/main" id="{E76A4893-6525-4F2F-8BA3-B5DD6DFA3352}"/>
+                <a16:creationId xmlns:a16="http://schemas.microsoft.com/office/drawing/2014/main" id="{C6836B80-0D74-4353-A5AD-5F444C07E912}"/>
               </a:ext>
             </a:extLst>
           </p:cNvPr>
@@ -22822,7 +22822,7 @@
           <p:cNvPr id="6" name="">
             <a:extLst xmlns:a="http://schemas.openxmlformats.org/drawingml/2006/main">
               <a:ext uri="{FF2B5EF4-FFF2-40B4-BE49-F238E27FC236}">
-                <a16:creationId xmlns:a16="http://schemas.microsoft.com/office/drawing/2014/main" id="{56CAC451-4A7B-4CA8-9E3C-99ACBF281967}"/>
+                <a16:creationId xmlns:a16="http://schemas.microsoft.com/office/drawing/2014/main" id="{B1C83A46-4F21-4A0F-965E-B3AB0A75FFD4}"/>
               </a:ext>
             </a:extLst>
           </p:cNvPr>
@@ -22880,7 +22880,7 @@
           <p:cNvPr id="7" name="">
             <a:extLst xmlns:a="http://schemas.openxmlformats.org/drawingml/2006/main">
               <a:ext uri="{FF2B5EF4-FFF2-40B4-BE49-F238E27FC236}">
-                <a16:creationId xmlns:a16="http://schemas.microsoft.com/office/drawing/2014/main" id="{639C85F8-127B-4787-8F06-6E1D4317BE93}"/>
+                <a16:creationId xmlns:a16="http://schemas.microsoft.com/office/drawing/2014/main" id="{45FD9187-0F07-4919-9A2B-6C9445878C15}"/>
               </a:ext>
             </a:extLst>
           </p:cNvPr>
@@ -22913,7 +22913,7 @@
           <p:cNvPr id="8" name="">
             <a:extLst xmlns:a="http://schemas.openxmlformats.org/drawingml/2006/main">
               <a:ext uri="{FF2B5EF4-FFF2-40B4-BE49-F238E27FC236}">
-                <a16:creationId xmlns:a16="http://schemas.microsoft.com/office/drawing/2014/main" id="{CB94D5FD-ECCF-44E1-B538-E5F20714B154}"/>
+                <a16:creationId xmlns:a16="http://schemas.microsoft.com/office/drawing/2014/main" id="{67ADFB93-8701-4135-A7A7-08A1C5971356}"/>
               </a:ext>
             </a:extLst>
           </p:cNvPr>
@@ -22948,7 +22948,7 @@
           <p:cNvPr id="9" name="">
             <a:extLst xmlns:a="http://schemas.openxmlformats.org/drawingml/2006/main">
               <a:ext uri="{FF2B5EF4-FFF2-40B4-BE49-F238E27FC236}">
-                <a16:creationId xmlns:a16="http://schemas.microsoft.com/office/drawing/2014/main" id="{5E275072-5AC5-42D1-8F16-4C94D5A4F139}"/>
+                <a16:creationId xmlns:a16="http://schemas.microsoft.com/office/drawing/2014/main" id="{1E314AC2-CAE5-4147-A448-1FF5FF7A3703}"/>
               </a:ext>
             </a:extLst>
           </p:cNvPr>
@@ -23006,7 +23006,7 @@
           <p:cNvPr id="10" name="">
             <a:extLst xmlns:a="http://schemas.openxmlformats.org/drawingml/2006/main">
               <a:ext uri="{FF2B5EF4-FFF2-40B4-BE49-F238E27FC236}">
-                <a16:creationId xmlns:a16="http://schemas.microsoft.com/office/drawing/2014/main" id="{A0925089-87FD-4139-8F02-24E4F606D909}"/>
+                <a16:creationId xmlns:a16="http://schemas.microsoft.com/office/drawing/2014/main" id="{58BDC7E3-300C-44E7-B47B-5652AE781BA5}"/>
               </a:ext>
             </a:extLst>
           </p:cNvPr>
@@ -23064,7 +23064,7 @@
           <p:cNvPr id="11" name="">
             <a:extLst xmlns:a="http://schemas.openxmlformats.org/drawingml/2006/main">
               <a:ext uri="{FF2B5EF4-FFF2-40B4-BE49-F238E27FC236}">
-                <a16:creationId xmlns:a16="http://schemas.microsoft.com/office/drawing/2014/main" id="{0785DB43-96B2-4788-B124-8BF0BB5135BC}"/>
+                <a16:creationId xmlns:a16="http://schemas.microsoft.com/office/drawing/2014/main" id="{34AA507A-728E-42F7-BEDA-D22FAAFA65CB}"/>
               </a:ext>
             </a:extLst>
           </p:cNvPr>
@@ -23097,7 +23097,7 @@
           <p:cNvPr id="12" name="">
             <a:extLst xmlns:a="http://schemas.openxmlformats.org/drawingml/2006/main">
               <a:ext uri="{FF2B5EF4-FFF2-40B4-BE49-F238E27FC236}">
-                <a16:creationId xmlns:a16="http://schemas.microsoft.com/office/drawing/2014/main" id="{B40DB384-4545-40E2-AA0E-9CCBDAA34306}"/>
+                <a16:creationId xmlns:a16="http://schemas.microsoft.com/office/drawing/2014/main" id="{38FBABDE-3E31-49E5-BE5A-AA243DA7CC8B}"/>
               </a:ext>
             </a:extLst>
           </p:cNvPr>
@@ -23132,7 +23132,7 @@
           <p:cNvPr id="13" name="">
             <a:extLst xmlns:a="http://schemas.openxmlformats.org/drawingml/2006/main">
               <a:ext uri="{FF2B5EF4-FFF2-40B4-BE49-F238E27FC236}">
-                <a16:creationId xmlns:a16="http://schemas.microsoft.com/office/drawing/2014/main" id="{131F767C-5C0B-43D9-BECC-073A48327E19}"/>
+                <a16:creationId xmlns:a16="http://schemas.microsoft.com/office/drawing/2014/main" id="{191ADE7A-7DC6-43E9-BBC5-19C2CE317E62}"/>
               </a:ext>
             </a:extLst>
           </p:cNvPr>
@@ -23190,7 +23190,7 @@
           <p:cNvPr id="14" name="">
             <a:extLst xmlns:a="http://schemas.openxmlformats.org/drawingml/2006/main">
               <a:ext uri="{FF2B5EF4-FFF2-40B4-BE49-F238E27FC236}">
-                <a16:creationId xmlns:a16="http://schemas.microsoft.com/office/drawing/2014/main" id="{5937883F-DD4F-42A0-BEF7-D167E524543B}"/>
+                <a16:creationId xmlns:a16="http://schemas.microsoft.com/office/drawing/2014/main" id="{99EF8C8C-DA08-446C-BAEA-56C80202D67A}"/>
               </a:ext>
             </a:extLst>
           </p:cNvPr>
@@ -23248,7 +23248,7 @@
           <p:cNvPr id="15" name="">
             <a:extLst xmlns:a="http://schemas.openxmlformats.org/drawingml/2006/main">
               <a:ext uri="{FF2B5EF4-FFF2-40B4-BE49-F238E27FC236}">
-                <a16:creationId xmlns:a16="http://schemas.microsoft.com/office/drawing/2014/main" id="{CFF22903-4A1E-481A-83B4-D75352888B5B}"/>
+                <a16:creationId xmlns:a16="http://schemas.microsoft.com/office/drawing/2014/main" id="{2132C859-DA46-4D39-8923-BA2C9DD65DD7}"/>
               </a:ext>
             </a:extLst>
           </p:cNvPr>
@@ -23281,7 +23281,7 @@
           <p:cNvPr id="16" name="">
             <a:extLst xmlns:a="http://schemas.openxmlformats.org/drawingml/2006/main">
               <a:ext uri="{FF2B5EF4-FFF2-40B4-BE49-F238E27FC236}">
-                <a16:creationId xmlns:a16="http://schemas.microsoft.com/office/drawing/2014/main" id="{40D443A3-1A61-41E4-91FD-D0D1CE520737}"/>
+                <a16:creationId xmlns:a16="http://schemas.microsoft.com/office/drawing/2014/main" id="{B0331235-7493-429A-BA2B-DAFCCB3CFECD}"/>
               </a:ext>
             </a:extLst>
           </p:cNvPr>
@@ -23316,7 +23316,7 @@
           <p:cNvPr id="17" name="">
             <a:extLst xmlns:a="http://schemas.openxmlformats.org/drawingml/2006/main">
               <a:ext uri="{FF2B5EF4-FFF2-40B4-BE49-F238E27FC236}">
-                <a16:creationId xmlns:a16="http://schemas.microsoft.com/office/drawing/2014/main" id="{6FA2686B-D46E-4183-8CDB-19BA20A35EFE}"/>
+                <a16:creationId xmlns:a16="http://schemas.microsoft.com/office/drawing/2014/main" id="{3F80951E-7E8E-4B57-A546-7B0133DA96DE}"/>
               </a:ext>
             </a:extLst>
           </p:cNvPr>
@@ -23374,7 +23374,7 @@
           <p:cNvPr id="18" name="">
             <a:extLst xmlns:a="http://schemas.openxmlformats.org/drawingml/2006/main">
               <a:ext uri="{FF2B5EF4-FFF2-40B4-BE49-F238E27FC236}">
-                <a16:creationId xmlns:a16="http://schemas.microsoft.com/office/drawing/2014/main" id="{20AC83DD-27B9-4F01-8158-3CDA276D4373}"/>
+                <a16:creationId xmlns:a16="http://schemas.microsoft.com/office/drawing/2014/main" id="{83A49A1A-FF63-4A92-B8A7-70F8837FAFF2}"/>
               </a:ext>
             </a:extLst>
           </p:cNvPr>
@@ -23432,7 +23432,7 @@
           <p:cNvPr id="19" name="">
             <a:extLst xmlns:a="http://schemas.openxmlformats.org/drawingml/2006/main">
               <a:ext uri="{FF2B5EF4-FFF2-40B4-BE49-F238E27FC236}">
-                <a16:creationId xmlns:a16="http://schemas.microsoft.com/office/drawing/2014/main" id="{A34A3647-721C-4205-9F58-ADB6CCD223EB}"/>
+                <a16:creationId xmlns:a16="http://schemas.microsoft.com/office/drawing/2014/main" id="{1FD96F17-FD2D-4107-9643-6A2A43920160}"/>
               </a:ext>
             </a:extLst>
           </p:cNvPr>
@@ -23467,7 +23467,7 @@
           <p:cNvPr id="20" name="">
             <a:extLst xmlns:a="http://schemas.openxmlformats.org/drawingml/2006/main">
               <a:ext uri="{FF2B5EF4-FFF2-40B4-BE49-F238E27FC236}">
-                <a16:creationId xmlns:a16="http://schemas.microsoft.com/office/drawing/2014/main" id="{9BD4A798-BCD5-474F-981C-51FDFBFE4128}"/>
+                <a16:creationId xmlns:a16="http://schemas.microsoft.com/office/drawing/2014/main" id="{F95D60A5-B2BC-49B2-833A-5C10CBA5FFBE}"/>
               </a:ext>
             </a:extLst>
           </p:cNvPr>
@@ -23525,7 +23525,7 @@
           <p:cNvPr id="21" name="">
             <a:extLst xmlns:a="http://schemas.openxmlformats.org/drawingml/2006/main">
               <a:ext uri="{FF2B5EF4-FFF2-40B4-BE49-F238E27FC236}">
-                <a16:creationId xmlns:a16="http://schemas.microsoft.com/office/drawing/2014/main" id="{A2946C68-967A-4750-A7E7-6C1FBB57C376}"/>
+                <a16:creationId xmlns:a16="http://schemas.microsoft.com/office/drawing/2014/main" id="{9069FBBD-2520-4CDE-AD7D-BF31EF3F92C0}"/>
               </a:ext>
             </a:extLst>
           </p:cNvPr>
@@ -23583,7 +23583,7 @@
           <p:cNvPr id="22" name="">
             <a:extLst xmlns:a="http://schemas.openxmlformats.org/drawingml/2006/main">
               <a:ext uri="{FF2B5EF4-FFF2-40B4-BE49-F238E27FC236}">
-                <a16:creationId xmlns:a16="http://schemas.microsoft.com/office/drawing/2014/main" id="{011E1C50-C221-4F85-9862-9F631B02BB4D}"/>
+                <a16:creationId xmlns:a16="http://schemas.microsoft.com/office/drawing/2014/main" id="{C19394E1-F5AD-41F9-B5C4-62813737CA1C}"/>
               </a:ext>
             </a:extLst>
           </p:cNvPr>
@@ -23639,7 +23639,7 @@
     </p:spTree>
     <p:extLst>
       <p:ext uri="{BB962C8B-B14F-4D97-AF65-F5344CB8AC3E}">
-        <p14:creationId xmlns:p14="http://schemas.microsoft.com/office/powerpoint/2010/main" val="1045357794"/>
+        <p14:creationId xmlns:p14="http://schemas.microsoft.com/office/powerpoint/2010/main" val="1727498327"/>
       </p:ext>
     </p:extLst>
   </p:cSld>
@@ -23663,7 +23663,7 @@
           <p:cNvPr id="23" name="">
             <a:extLst xmlns:a="http://schemas.openxmlformats.org/drawingml/2006/main">
               <a:ext uri="{FF2B5EF4-FFF2-40B4-BE49-F238E27FC236}">
-                <a16:creationId xmlns:a16="http://schemas.microsoft.com/office/drawing/2014/main" id="{8B40D69A-FEFD-46E4-AC88-45564C5903BC}"/>
+                <a16:creationId xmlns:a16="http://schemas.microsoft.com/office/drawing/2014/main" id="{780FB7BD-08D6-47DE-B2C3-2771C8601CEA}"/>
               </a:ext>
             </a:extLst>
           </p:cNvPr>
@@ -23721,7 +23721,7 @@
           <p:cNvPr id="2" name="">
             <a:extLst xmlns:a="http://schemas.openxmlformats.org/drawingml/2006/main">
               <a:ext uri="{FF2B5EF4-FFF2-40B4-BE49-F238E27FC236}">
-                <a16:creationId xmlns:a16="http://schemas.microsoft.com/office/drawing/2014/main" id="{36494D00-6420-44E1-AE32-13E961894DDC}"/>
+                <a16:creationId xmlns:a16="http://schemas.microsoft.com/office/drawing/2014/main" id="{68FAAA1D-95D7-4079-932C-EC685C5D9AF8}"/>
               </a:ext>
             </a:extLst>
           </p:cNvPr>
@@ -23769,7 +23769,7 @@
                 <a:ea typeface="Microsoft YaHei"/>
                 <a:cs typeface="Microsoft YaHei"/>
               </a:rPr>
-              <a:t>安全 BO 同时看平均性能、噪声方差与安全裕量</a:t>
+              <a:t>安全 BO：同时约束风险与安全</a:t>
             </a:r>
           </a:p>
         </p:txBody>
@@ -23779,19 +23779,19 @@
           <p:cNvPr id="3" name="">
             <a:extLst xmlns:a="http://schemas.openxmlformats.org/drawingml/2006/main">
               <a:ext uri="{FF2B5EF4-FFF2-40B4-BE49-F238E27FC236}">
-                <a16:creationId xmlns:a16="http://schemas.microsoft.com/office/drawing/2014/main" id="{4D9BC8F5-E6C0-4328-A016-2F789A49EDB6}"/>
-              </a:ext>
-            </a:extLst>
-          </p:cNvPr>
-          <p:cNvSpPr>
-            <a:spLocks xmlns:a="http://schemas.openxmlformats.org/drawingml/2006/main" noGrp="1"/>
-          </p:cNvSpPr>
-          <p:nvPr/>
-        </p:nvSpPr>
-        <p:spPr>
-          <a:xfrm xmlns:a="http://schemas.openxmlformats.org/drawingml/2006/main">
-            <a:off x="11239500" y="6334125"/>
-            <a:ext cx="552450" cy="190500"/>
+                <a16:creationId xmlns:a16="http://schemas.microsoft.com/office/drawing/2014/main" id="{46958959-E2C9-4D3D-8DBE-17E7A9FF3DE2}"/>
+              </a:ext>
+            </a:extLst>
+          </p:cNvPr>
+          <p:cNvSpPr>
+            <a:spLocks xmlns:a="http://schemas.openxmlformats.org/drawingml/2006/main" noGrp="1"/>
+          </p:cNvSpPr>
+          <p:nvPr/>
+        </p:nvSpPr>
+        <p:spPr>
+          <a:xfrm xmlns:a="http://schemas.openxmlformats.org/drawingml/2006/main">
+            <a:off x="10953750" y="6334125"/>
+            <a:ext cx="838200" cy="190500"/>
           </a:xfrm>
           <a:prstGeom xmlns:a="http://schemas.openxmlformats.org/drawingml/2006/main" prst="rect">
             <a:avLst/>
@@ -23837,7 +23837,7 @@
           <p:cNvPr id="4" name="">
             <a:extLst xmlns:a="http://schemas.openxmlformats.org/drawingml/2006/main">
               <a:ext uri="{FF2B5EF4-FFF2-40B4-BE49-F238E27FC236}">
-                <a16:creationId xmlns:a16="http://schemas.microsoft.com/office/drawing/2014/main" id="{2DB2F94E-AE51-4975-800C-AE0CD83E9A78}"/>
+                <a16:creationId xmlns:a16="http://schemas.microsoft.com/office/drawing/2014/main" id="{8FEE921D-FE7E-498A-AA59-677FF7FD2AED}"/>
               </a:ext>
             </a:extLst>
           </p:cNvPr>
@@ -23872,7 +23872,7 @@
           <p:cNvPr id="5" name="">
             <a:extLst xmlns:a="http://schemas.openxmlformats.org/drawingml/2006/main">
               <a:ext uri="{FF2B5EF4-FFF2-40B4-BE49-F238E27FC236}">
-                <a16:creationId xmlns:a16="http://schemas.microsoft.com/office/drawing/2014/main" id="{7468D88E-D716-462E-9088-89F9224EF202}"/>
+                <a16:creationId xmlns:a16="http://schemas.microsoft.com/office/drawing/2014/main" id="{D372DDFB-E5A8-46E7-A1A2-D147D2BDB276}"/>
               </a:ext>
             </a:extLst>
           </p:cNvPr>
@@ -23930,7 +23930,7 @@
           <p:cNvPr id="6" name="">
             <a:extLst xmlns:a="http://schemas.openxmlformats.org/drawingml/2006/main">
               <a:ext uri="{FF2B5EF4-FFF2-40B4-BE49-F238E27FC236}">
-                <a16:creationId xmlns:a16="http://schemas.microsoft.com/office/drawing/2014/main" id="{942110C6-5880-42C7-9633-9B0243006E31}"/>
+                <a16:creationId xmlns:a16="http://schemas.microsoft.com/office/drawing/2014/main" id="{F7BCD703-C578-43DC-BD26-5930EBCFD588}"/>
               </a:ext>
             </a:extLst>
           </p:cNvPr>
@@ -23988,7 +23988,7 @@
           <p:cNvPr id="7" name="">
             <a:extLst xmlns:a="http://schemas.openxmlformats.org/drawingml/2006/main">
               <a:ext uri="{FF2B5EF4-FFF2-40B4-BE49-F238E27FC236}">
-                <a16:creationId xmlns:a16="http://schemas.microsoft.com/office/drawing/2014/main" id="{4E8CB797-FF56-478B-BBCF-A497C9398C24}"/>
+                <a16:creationId xmlns:a16="http://schemas.microsoft.com/office/drawing/2014/main" id="{E201D4D7-9F00-41BF-AB5C-E270CBA47893}"/>
               </a:ext>
             </a:extLst>
           </p:cNvPr>
@@ -24021,7 +24021,7 @@
           <p:cNvPr id="8" name="">
             <a:extLst xmlns:a="http://schemas.openxmlformats.org/drawingml/2006/main">
               <a:ext uri="{FF2B5EF4-FFF2-40B4-BE49-F238E27FC236}">
-                <a16:creationId xmlns:a16="http://schemas.microsoft.com/office/drawing/2014/main" id="{9FD4EF52-C883-4502-8BA9-2CEBEB13D24E}"/>
+                <a16:creationId xmlns:a16="http://schemas.microsoft.com/office/drawing/2014/main" id="{0B5B44FE-9DAA-47E0-B736-39F4C500B7BD}"/>
               </a:ext>
             </a:extLst>
           </p:cNvPr>
@@ -24056,7 +24056,7 @@
           <p:cNvPr id="9" name="">
             <a:extLst xmlns:a="http://schemas.openxmlformats.org/drawingml/2006/main">
               <a:ext uri="{FF2B5EF4-FFF2-40B4-BE49-F238E27FC236}">
-                <a16:creationId xmlns:a16="http://schemas.microsoft.com/office/drawing/2014/main" id="{DFABFCB9-ABA8-42A3-930B-102BD0C1E1D1}"/>
+                <a16:creationId xmlns:a16="http://schemas.microsoft.com/office/drawing/2014/main" id="{38171639-99FD-474C-AABB-5EA98B16037D}"/>
               </a:ext>
             </a:extLst>
           </p:cNvPr>
@@ -24114,7 +24114,7 @@
           <p:cNvPr id="10" name="">
             <a:extLst xmlns:a="http://schemas.openxmlformats.org/drawingml/2006/main">
               <a:ext uri="{FF2B5EF4-FFF2-40B4-BE49-F238E27FC236}">
-                <a16:creationId xmlns:a16="http://schemas.microsoft.com/office/drawing/2014/main" id="{71C9785B-E142-4830-8B0C-28EB8484A5D7}"/>
+                <a16:creationId xmlns:a16="http://schemas.microsoft.com/office/drawing/2014/main" id="{66254C11-70E4-4B65-818F-38B0505D924B}"/>
               </a:ext>
             </a:extLst>
           </p:cNvPr>
@@ -24172,7 +24172,7 @@
           <p:cNvPr id="11" name="">
             <a:extLst xmlns:a="http://schemas.openxmlformats.org/drawingml/2006/main">
               <a:ext uri="{FF2B5EF4-FFF2-40B4-BE49-F238E27FC236}">
-                <a16:creationId xmlns:a16="http://schemas.microsoft.com/office/drawing/2014/main" id="{A2D0009E-1AFC-40C5-95A7-B802E284B105}"/>
+                <a16:creationId xmlns:a16="http://schemas.microsoft.com/office/drawing/2014/main" id="{8F5F5129-03B7-47CD-9D00-95A90440B2D1}"/>
               </a:ext>
             </a:extLst>
           </p:cNvPr>
@@ -24205,7 +24205,7 @@
           <p:cNvPr id="12" name="">
             <a:extLst xmlns:a="http://schemas.openxmlformats.org/drawingml/2006/main">
               <a:ext uri="{FF2B5EF4-FFF2-40B4-BE49-F238E27FC236}">
-                <a16:creationId xmlns:a16="http://schemas.microsoft.com/office/drawing/2014/main" id="{AA7B3EA8-DA0D-445E-92B1-9E85D7A04FC9}"/>
+                <a16:creationId xmlns:a16="http://schemas.microsoft.com/office/drawing/2014/main" id="{7A4B3A35-A5FA-49EC-8DFA-5D4C0F9875D7}"/>
               </a:ext>
             </a:extLst>
           </p:cNvPr>
@@ -24240,7 +24240,7 @@
           <p:cNvPr id="13" name="">
             <a:extLst xmlns:a="http://schemas.openxmlformats.org/drawingml/2006/main">
               <a:ext uri="{FF2B5EF4-FFF2-40B4-BE49-F238E27FC236}">
-                <a16:creationId xmlns:a16="http://schemas.microsoft.com/office/drawing/2014/main" id="{744394E3-FB5C-4204-8E90-AFF60275EE15}"/>
+                <a16:creationId xmlns:a16="http://schemas.microsoft.com/office/drawing/2014/main" id="{569550FF-0857-4095-A820-83767E18A7C3}"/>
               </a:ext>
             </a:extLst>
           </p:cNvPr>
@@ -24298,7 +24298,7 @@
           <p:cNvPr id="14" name="">
             <a:extLst xmlns:a="http://schemas.openxmlformats.org/drawingml/2006/main">
               <a:ext uri="{FF2B5EF4-FFF2-40B4-BE49-F238E27FC236}">
-                <a16:creationId xmlns:a16="http://schemas.microsoft.com/office/drawing/2014/main" id="{DD5E6864-F098-4CCF-8A0E-C79B700B0BD8}"/>
+                <a16:creationId xmlns:a16="http://schemas.microsoft.com/office/drawing/2014/main" id="{77910916-9034-47EF-B12A-B37D408722B3}"/>
               </a:ext>
             </a:extLst>
           </p:cNvPr>
@@ -24356,7 +24356,7 @@
           <p:cNvPr id="15" name="">
             <a:extLst xmlns:a="http://schemas.openxmlformats.org/drawingml/2006/main">
               <a:ext uri="{FF2B5EF4-FFF2-40B4-BE49-F238E27FC236}">
-                <a16:creationId xmlns:a16="http://schemas.microsoft.com/office/drawing/2014/main" id="{9EBBEED3-6C3D-4FEE-9250-3011F791B72E}"/>
+                <a16:creationId xmlns:a16="http://schemas.microsoft.com/office/drawing/2014/main" id="{BDC09349-3872-4510-B887-73CA0EC2A125}"/>
               </a:ext>
             </a:extLst>
           </p:cNvPr>
@@ -24389,7 +24389,7 @@
           <p:cNvPr id="16" name="">
             <a:extLst xmlns:a="http://schemas.openxmlformats.org/drawingml/2006/main">
               <a:ext uri="{FF2B5EF4-FFF2-40B4-BE49-F238E27FC236}">
-                <a16:creationId xmlns:a16="http://schemas.microsoft.com/office/drawing/2014/main" id="{B0B6C1B0-6E41-48A9-BD50-5B31E39A43EC}"/>
+                <a16:creationId xmlns:a16="http://schemas.microsoft.com/office/drawing/2014/main" id="{C58DF34B-151D-474B-8F52-1F0FFF228DD4}"/>
               </a:ext>
             </a:extLst>
           </p:cNvPr>
@@ -24424,7 +24424,7 @@
           <p:cNvPr id="17" name="">
             <a:extLst xmlns:a="http://schemas.openxmlformats.org/drawingml/2006/main">
               <a:ext uri="{FF2B5EF4-FFF2-40B4-BE49-F238E27FC236}">
-                <a16:creationId xmlns:a16="http://schemas.microsoft.com/office/drawing/2014/main" id="{3394A026-E97C-4DD8-8B62-FBC6F128FC24}"/>
+                <a16:creationId xmlns:a16="http://schemas.microsoft.com/office/drawing/2014/main" id="{A6FA1D21-EC6F-48A1-BFF4-CABE09FFA88A}"/>
               </a:ext>
             </a:extLst>
           </p:cNvPr>
@@ -24482,7 +24482,7 @@
           <p:cNvPr id="18" name="">
             <a:extLst xmlns:a="http://schemas.openxmlformats.org/drawingml/2006/main">
               <a:ext uri="{FF2B5EF4-FFF2-40B4-BE49-F238E27FC236}">
-                <a16:creationId xmlns:a16="http://schemas.microsoft.com/office/drawing/2014/main" id="{57A578EF-7099-42EA-97F0-944123D00481}"/>
+                <a16:creationId xmlns:a16="http://schemas.microsoft.com/office/drawing/2014/main" id="{7B41C0E0-943D-4431-9758-7F825B54FE7D}"/>
               </a:ext>
             </a:extLst>
           </p:cNvPr>
@@ -24540,7 +24540,7 @@
           <p:cNvPr id="19" name="">
             <a:extLst xmlns:a="http://schemas.openxmlformats.org/drawingml/2006/main">
               <a:ext uri="{FF2B5EF4-FFF2-40B4-BE49-F238E27FC236}">
-                <a16:creationId xmlns:a16="http://schemas.microsoft.com/office/drawing/2014/main" id="{B458E53E-D1D6-4AB0-B0F8-6EEB956C3D0D}"/>
+                <a16:creationId xmlns:a16="http://schemas.microsoft.com/office/drawing/2014/main" id="{DE55B025-E533-453C-A559-E84928C6B419}"/>
               </a:ext>
             </a:extLst>
           </p:cNvPr>
@@ -24575,7 +24575,7 @@
           <p:cNvPr id="20" name="">
             <a:extLst xmlns:a="http://schemas.openxmlformats.org/drawingml/2006/main">
               <a:ext uri="{FF2B5EF4-FFF2-40B4-BE49-F238E27FC236}">
-                <a16:creationId xmlns:a16="http://schemas.microsoft.com/office/drawing/2014/main" id="{8CB070D1-16B1-4453-861B-202845635AA2}"/>
+                <a16:creationId xmlns:a16="http://schemas.microsoft.com/office/drawing/2014/main" id="{F71D655D-6F71-46CB-AF14-DA89B2B0314A}"/>
               </a:ext>
             </a:extLst>
           </p:cNvPr>
@@ -24633,7 +24633,7 @@
           <p:cNvPr id="21" name="">
             <a:extLst xmlns:a="http://schemas.openxmlformats.org/drawingml/2006/main">
               <a:ext uri="{FF2B5EF4-FFF2-40B4-BE49-F238E27FC236}">
-                <a16:creationId xmlns:a16="http://schemas.microsoft.com/office/drawing/2014/main" id="{13290F9E-5CB1-4FD5-A00B-23167A706B42}"/>
+                <a16:creationId xmlns:a16="http://schemas.microsoft.com/office/drawing/2014/main" id="{09432D9D-5351-49C0-8E90-30CBCB976A3C}"/>
               </a:ext>
             </a:extLst>
           </p:cNvPr>
@@ -24691,7 +24691,7 @@
           <p:cNvPr id="22" name="">
             <a:extLst xmlns:a="http://schemas.openxmlformats.org/drawingml/2006/main">
               <a:ext uri="{FF2B5EF4-FFF2-40B4-BE49-F238E27FC236}">
-                <a16:creationId xmlns:a16="http://schemas.microsoft.com/office/drawing/2014/main" id="{B569639D-47D3-4DFF-A153-8ADF7061108E}"/>
+                <a16:creationId xmlns:a16="http://schemas.microsoft.com/office/drawing/2014/main" id="{D734D670-34BE-4A71-AEDD-74648D347F6E}"/>
               </a:ext>
             </a:extLst>
           </p:cNvPr>
@@ -24747,7 +24747,7 @@
     </p:spTree>
     <p:extLst>
       <p:ext uri="{BB962C8B-B14F-4D97-AF65-F5344CB8AC3E}">
-        <p14:creationId xmlns:p14="http://schemas.microsoft.com/office/powerpoint/2010/main" val="1437435282"/>
+        <p14:creationId xmlns:p14="http://schemas.microsoft.com/office/powerpoint/2010/main" val="152267645"/>
       </p:ext>
     </p:extLst>
   </p:cSld>

</xml_diff>